<commit_message>
exploration of annual effects
</commit_message>
<xml_diff>
--- a/stock-specific/hake/output_plots_20260730.pptx
+++ b/stock-specific/hake/output_plots_20260730.pptx
@@ -5,50 +5,60 @@
     <p:sldMasterId id="2147483648" r:id="rId1"/>
   </p:sldMasterIdLst>
   <p:notesMasterIdLst>
-    <p:notesMasterId r:id="rId43"/>
+    <p:notesMasterId r:id="rId53"/>
   </p:notesMasterIdLst>
   <p:sldIdLst>
     <p:sldId id="256" r:id="rId2"/>
     <p:sldId id="263" r:id="rId3"/>
-    <p:sldId id="257" r:id="rId4"/>
-    <p:sldId id="308" r:id="rId5"/>
-    <p:sldId id="309" r:id="rId6"/>
-    <p:sldId id="310" r:id="rId7"/>
-    <p:sldId id="301" r:id="rId8"/>
-    <p:sldId id="304" r:id="rId9"/>
-    <p:sldId id="302" r:id="rId10"/>
-    <p:sldId id="313" r:id="rId11"/>
-    <p:sldId id="316" r:id="rId12"/>
-    <p:sldId id="306" r:id="rId13"/>
-    <p:sldId id="259" r:id="rId14"/>
-    <p:sldId id="322" r:id="rId15"/>
-    <p:sldId id="268" r:id="rId16"/>
-    <p:sldId id="325" r:id="rId17"/>
-    <p:sldId id="284" r:id="rId18"/>
-    <p:sldId id="293" r:id="rId19"/>
-    <p:sldId id="271" r:id="rId20"/>
-    <p:sldId id="267" r:id="rId21"/>
-    <p:sldId id="326" r:id="rId22"/>
-    <p:sldId id="323" r:id="rId23"/>
-    <p:sldId id="298" r:id="rId24"/>
-    <p:sldId id="269" r:id="rId25"/>
-    <p:sldId id="320" r:id="rId26"/>
-    <p:sldId id="321" r:id="rId27"/>
-    <p:sldId id="317" r:id="rId28"/>
-    <p:sldId id="318" r:id="rId29"/>
-    <p:sldId id="319" r:id="rId30"/>
-    <p:sldId id="270" r:id="rId31"/>
-    <p:sldId id="266" r:id="rId32"/>
-    <p:sldId id="287" r:id="rId33"/>
-    <p:sldId id="280" r:id="rId34"/>
-    <p:sldId id="281" r:id="rId35"/>
-    <p:sldId id="288" r:id="rId36"/>
-    <p:sldId id="289" r:id="rId37"/>
-    <p:sldId id="292" r:id="rId38"/>
-    <p:sldId id="294" r:id="rId39"/>
-    <p:sldId id="295" r:id="rId40"/>
-    <p:sldId id="296" r:id="rId41"/>
-    <p:sldId id="297" r:id="rId42"/>
+    <p:sldId id="308" r:id="rId4"/>
+    <p:sldId id="309" r:id="rId5"/>
+    <p:sldId id="310" r:id="rId6"/>
+    <p:sldId id="301" r:id="rId7"/>
+    <p:sldId id="304" r:id="rId8"/>
+    <p:sldId id="302" r:id="rId9"/>
+    <p:sldId id="313" r:id="rId10"/>
+    <p:sldId id="316" r:id="rId11"/>
+    <p:sldId id="306" r:id="rId12"/>
+    <p:sldId id="259" r:id="rId13"/>
+    <p:sldId id="328" r:id="rId14"/>
+    <p:sldId id="327" r:id="rId15"/>
+    <p:sldId id="322" r:id="rId16"/>
+    <p:sldId id="268" r:id="rId17"/>
+    <p:sldId id="325" r:id="rId18"/>
+    <p:sldId id="284" r:id="rId19"/>
+    <p:sldId id="293" r:id="rId20"/>
+    <p:sldId id="271" r:id="rId21"/>
+    <p:sldId id="329" r:id="rId22"/>
+    <p:sldId id="330" r:id="rId23"/>
+    <p:sldId id="331" r:id="rId24"/>
+    <p:sldId id="332" r:id="rId25"/>
+    <p:sldId id="333" r:id="rId26"/>
+    <p:sldId id="334" r:id="rId27"/>
+    <p:sldId id="335" r:id="rId28"/>
+    <p:sldId id="267" r:id="rId29"/>
+    <p:sldId id="326" r:id="rId30"/>
+    <p:sldId id="323" r:id="rId31"/>
+    <p:sldId id="298" r:id="rId32"/>
+    <p:sldId id="269" r:id="rId33"/>
+    <p:sldId id="320" r:id="rId34"/>
+    <p:sldId id="336" r:id="rId35"/>
+    <p:sldId id="321" r:id="rId36"/>
+    <p:sldId id="317" r:id="rId37"/>
+    <p:sldId id="318" r:id="rId38"/>
+    <p:sldId id="319" r:id="rId39"/>
+    <p:sldId id="270" r:id="rId40"/>
+    <p:sldId id="266" r:id="rId41"/>
+    <p:sldId id="257" r:id="rId42"/>
+    <p:sldId id="287" r:id="rId43"/>
+    <p:sldId id="280" r:id="rId44"/>
+    <p:sldId id="281" r:id="rId45"/>
+    <p:sldId id="288" r:id="rId46"/>
+    <p:sldId id="289" r:id="rId47"/>
+    <p:sldId id="292" r:id="rId48"/>
+    <p:sldId id="294" r:id="rId49"/>
+    <p:sldId id="295" r:id="rId50"/>
+    <p:sldId id="296" r:id="rId51"/>
+    <p:sldId id="297" r:id="rId52"/>
   </p:sldIdLst>
   <p:sldSz cx="12192000" cy="6858000"/>
   <p:notesSz cx="6858000" cy="9144000"/>
@@ -237,7 +247,7 @@
           <a:p>
             <a:fld id="{B1A585C4-8FDE-44AD-AB8B-4802EADEEE94}" type="datetimeFigureOut">
               <a:rPr lang="en-US" smtClean="0"/>
-              <a:t>9/28/2026</a:t>
+              <a:t>10/21/2026</a:t>
             </a:fld>
             <a:endParaRPr lang="en-US"/>
           </a:p>
@@ -593,7 +603,7 @@
           <a:p>
             <a:fld id="{BC9AF6F9-19A8-4B2B-96C4-42992BE88AC3}" type="slidenum">
               <a:rPr lang="en-US" smtClean="0"/>
-              <a:t>6</a:t>
+              <a:t>5</a:t>
             </a:fld>
             <a:endParaRPr lang="en-US"/>
           </a:p>
@@ -701,7 +711,7 @@
           <a:p>
             <a:fld id="{BC9AF6F9-19A8-4B2B-96C4-42992BE88AC3}" type="slidenum">
               <a:rPr lang="en-US" smtClean="0"/>
-              <a:t>10</a:t>
+              <a:t>9</a:t>
             </a:fld>
             <a:endParaRPr lang="en-US"/>
           </a:p>
@@ -809,7 +819,7 @@
           <a:p>
             <a:fld id="{BC9AF6F9-19A8-4B2B-96C4-42992BE88AC3}" type="slidenum">
               <a:rPr lang="en-US" smtClean="0"/>
-              <a:t>11</a:t>
+              <a:t>10</a:t>
             </a:fld>
             <a:endParaRPr lang="en-US"/>
           </a:p>
@@ -917,7 +927,7 @@
           <a:p>
             <a:fld id="{BC9AF6F9-19A8-4B2B-96C4-42992BE88AC3}" type="slidenum">
               <a:rPr lang="en-US" smtClean="0"/>
-              <a:t>14</a:t>
+              <a:t>15</a:t>
             </a:fld>
             <a:endParaRPr lang="en-US"/>
           </a:p>
@@ -1001,7 +1011,7 @@
           <a:p>
             <a:fld id="{BC9AF6F9-19A8-4B2B-96C4-42992BE88AC3}" type="slidenum">
               <a:rPr lang="en-US" smtClean="0"/>
-              <a:t>15</a:t>
+              <a:t>16</a:t>
             </a:fld>
             <a:endParaRPr lang="en-US"/>
           </a:p>
@@ -1100,7 +1110,7 @@
           <a:p>
             <a:fld id="{BC9AF6F9-19A8-4B2B-96C4-42992BE88AC3}" type="slidenum">
               <a:rPr lang="en-US" smtClean="0"/>
-              <a:t>20</a:t>
+              <a:t>28</a:t>
             </a:fld>
             <a:endParaRPr lang="en-US"/>
           </a:p>
@@ -1266,7 +1276,7 @@
           <a:p>
             <a:fld id="{0679C2E1-833F-46B1-9B12-C4DA11FEBF42}" type="datetimeFigureOut">
               <a:rPr lang="en-US" smtClean="0"/>
-              <a:t>9/28/2026</a:t>
+              <a:t>10/21/2026</a:t>
             </a:fld>
             <a:endParaRPr lang="en-US"/>
           </a:p>
@@ -1464,7 +1474,7 @@
           <a:p>
             <a:fld id="{0679C2E1-833F-46B1-9B12-C4DA11FEBF42}" type="datetimeFigureOut">
               <a:rPr lang="en-US" smtClean="0"/>
-              <a:t>9/28/2026</a:t>
+              <a:t>10/21/2026</a:t>
             </a:fld>
             <a:endParaRPr lang="en-US"/>
           </a:p>
@@ -1672,7 +1682,7 @@
           <a:p>
             <a:fld id="{0679C2E1-833F-46B1-9B12-C4DA11FEBF42}" type="datetimeFigureOut">
               <a:rPr lang="en-US" smtClean="0"/>
-              <a:t>9/28/2026</a:t>
+              <a:t>10/21/2026</a:t>
             </a:fld>
             <a:endParaRPr lang="en-US"/>
           </a:p>
@@ -1870,7 +1880,7 @@
           <a:p>
             <a:fld id="{0679C2E1-833F-46B1-9B12-C4DA11FEBF42}" type="datetimeFigureOut">
               <a:rPr lang="en-US" smtClean="0"/>
-              <a:t>9/28/2026</a:t>
+              <a:t>10/21/2026</a:t>
             </a:fld>
             <a:endParaRPr lang="en-US"/>
           </a:p>
@@ -2145,7 +2155,7 @@
           <a:p>
             <a:fld id="{0679C2E1-833F-46B1-9B12-C4DA11FEBF42}" type="datetimeFigureOut">
               <a:rPr lang="en-US" smtClean="0"/>
-              <a:t>9/28/2026</a:t>
+              <a:t>10/21/2026</a:t>
             </a:fld>
             <a:endParaRPr lang="en-US"/>
           </a:p>
@@ -2410,7 +2420,7 @@
           <a:p>
             <a:fld id="{0679C2E1-833F-46B1-9B12-C4DA11FEBF42}" type="datetimeFigureOut">
               <a:rPr lang="en-US" smtClean="0"/>
-              <a:t>9/28/2026</a:t>
+              <a:t>10/21/2026</a:t>
             </a:fld>
             <a:endParaRPr lang="en-US"/>
           </a:p>
@@ -2822,7 +2832,7 @@
           <a:p>
             <a:fld id="{0679C2E1-833F-46B1-9B12-C4DA11FEBF42}" type="datetimeFigureOut">
               <a:rPr lang="en-US" smtClean="0"/>
-              <a:t>9/28/2026</a:t>
+              <a:t>10/21/2026</a:t>
             </a:fld>
             <a:endParaRPr lang="en-US"/>
           </a:p>
@@ -2963,7 +2973,7 @@
           <a:p>
             <a:fld id="{0679C2E1-833F-46B1-9B12-C4DA11FEBF42}" type="datetimeFigureOut">
               <a:rPr lang="en-US" smtClean="0"/>
-              <a:t>9/28/2026</a:t>
+              <a:t>10/21/2026</a:t>
             </a:fld>
             <a:endParaRPr lang="en-US"/>
           </a:p>
@@ -3076,7 +3086,7 @@
           <a:p>
             <a:fld id="{0679C2E1-833F-46B1-9B12-C4DA11FEBF42}" type="datetimeFigureOut">
               <a:rPr lang="en-US" smtClean="0"/>
-              <a:t>9/28/2026</a:t>
+              <a:t>10/21/2026</a:t>
             </a:fld>
             <a:endParaRPr lang="en-US"/>
           </a:p>
@@ -3387,7 +3397,7 @@
           <a:p>
             <a:fld id="{0679C2E1-833F-46B1-9B12-C4DA11FEBF42}" type="datetimeFigureOut">
               <a:rPr lang="en-US" smtClean="0"/>
-              <a:t>9/28/2026</a:t>
+              <a:t>10/21/2026</a:t>
             </a:fld>
             <a:endParaRPr lang="en-US"/>
           </a:p>
@@ -3675,7 +3685,7 @@
           <a:p>
             <a:fld id="{0679C2E1-833F-46B1-9B12-C4DA11FEBF42}" type="datetimeFigureOut">
               <a:rPr lang="en-US" smtClean="0"/>
-              <a:t>9/28/2026</a:t>
+              <a:t>10/21/2026</a:t>
             </a:fld>
             <a:endParaRPr lang="en-US"/>
           </a:p>
@@ -3916,7 +3926,7 @@
           <a:p>
             <a:fld id="{0679C2E1-833F-46B1-9B12-C4DA11FEBF42}" type="datetimeFigureOut">
               <a:rPr lang="en-US" smtClean="0"/>
-              <a:t>9/28/2026</a:t>
+              <a:t>10/21/2026</a:t>
             </a:fld>
             <a:endParaRPr lang="en-US"/>
           </a:p>
@@ -4404,7 +4414,7 @@
           <a:p>
             <a:r>
               <a:rPr lang="en-US" dirty="0"/>
-              <a:t>Hake, age and environmental factors</a:t>
+              <a:t>Hake, body condition. age and environmental factors</a:t>
             </a:r>
           </a:p>
         </p:txBody>
@@ -4448,100 +4458,6 @@
 </file>
 
 <file path=ppt/slides/slide10.xml><?xml version="1.0" encoding="utf-8"?>
-<p:sld xmlns:a="http://schemas.openxmlformats.org/drawingml/2006/main" xmlns:r="http://schemas.openxmlformats.org/officeDocument/2006/relationships" xmlns:p="http://schemas.openxmlformats.org/presentationml/2006/main">
-  <p:cSld>
-    <p:spTree>
-      <p:nvGrpSpPr>
-        <p:cNvPr id="1" name="">
-          <a:extLst>
-            <a:ext uri="{FF2B5EF4-FFF2-40B4-BE49-F238E27FC236}">
-              <a16:creationId xmlns:a16="http://schemas.microsoft.com/office/drawing/2014/main" id="{99EB299D-3070-B03A-6039-34685C748421}"/>
-            </a:ext>
-          </a:extLst>
-        </p:cNvPr>
-        <p:cNvGrpSpPr/>
-        <p:nvPr/>
-      </p:nvGrpSpPr>
-      <p:grpSpPr>
-        <a:xfrm>
-          <a:off x="0" y="0"/>
-          <a:ext cx="0" cy="0"/>
-          <a:chOff x="0" y="0"/>
-          <a:chExt cx="0" cy="0"/>
-        </a:xfrm>
-      </p:grpSpPr>
-      <p:sp>
-        <p:nvSpPr>
-          <p:cNvPr id="2" name="Title 1">
-            <a:extLst>
-              <a:ext uri="{FF2B5EF4-FFF2-40B4-BE49-F238E27FC236}">
-                <a16:creationId xmlns:a16="http://schemas.microsoft.com/office/drawing/2014/main" id="{7287E5C3-6A63-10AA-1280-022AC875066C}"/>
-              </a:ext>
-            </a:extLst>
-          </p:cNvPr>
-          <p:cNvSpPr>
-            <a:spLocks noGrp="1"/>
-          </p:cNvSpPr>
-          <p:nvPr>
-            <p:ph type="title"/>
-          </p:nvPr>
-        </p:nvSpPr>
-        <p:spPr/>
-        <p:txBody>
-          <a:bodyPr/>
-          <a:lstStyle/>
-          <a:p>
-            <a:r>
-              <a:rPr lang="en-US" dirty="0"/>
-              <a:t>Env data plots – US Data</a:t>
-            </a:r>
-          </a:p>
-        </p:txBody>
-      </p:sp>
-      <p:pic>
-        <p:nvPicPr>
-          <p:cNvPr id="4" name="Picture 3">
-            <a:extLst>
-              <a:ext uri="{FF2B5EF4-FFF2-40B4-BE49-F238E27FC236}">
-                <a16:creationId xmlns:a16="http://schemas.microsoft.com/office/drawing/2014/main" id="{759E3529-BD8B-027B-CDD6-9F00584D5600}"/>
-              </a:ext>
-            </a:extLst>
-          </p:cNvPr>
-          <p:cNvPicPr>
-            <a:picLocks noChangeAspect="1"/>
-          </p:cNvPicPr>
-          <p:nvPr/>
-        </p:nvPicPr>
-        <p:blipFill>
-          <a:blip r:embed="rId3"/>
-          <a:stretch>
-            <a:fillRect/>
-          </a:stretch>
-        </p:blipFill>
-        <p:spPr>
-          <a:xfrm>
-            <a:off x="2203578" y="1475632"/>
-            <a:ext cx="7784844" cy="5017243"/>
-          </a:xfrm>
-          <a:prstGeom prst="rect">
-            <a:avLst/>
-          </a:prstGeom>
-        </p:spPr>
-      </p:pic>
-    </p:spTree>
-    <p:extLst>
-      <p:ext uri="{BB962C8B-B14F-4D97-AF65-F5344CB8AC3E}">
-        <p14:creationId xmlns:p14="http://schemas.microsoft.com/office/powerpoint/2010/main" val="3763793456"/>
-      </p:ext>
-    </p:extLst>
-  </p:cSld>
-  <p:clrMapOvr>
-    <a:masterClrMapping/>
-  </p:clrMapOvr>
-</p:sld>
-</file>
-
-<file path=ppt/slides/slide11.xml><?xml version="1.0" encoding="utf-8"?>
 <p:sld xmlns:a="http://schemas.openxmlformats.org/drawingml/2006/main" xmlns:r="http://schemas.openxmlformats.org/officeDocument/2006/relationships" xmlns:p="http://schemas.openxmlformats.org/presentationml/2006/main">
   <p:cSld>
     <p:spTree>
@@ -4635,6 +4551,89 @@
 </p:sld>
 </file>
 
+<file path=ppt/slides/slide11.xml><?xml version="1.0" encoding="utf-8"?>
+<p:sld xmlns:a="http://schemas.openxmlformats.org/drawingml/2006/main" xmlns:r="http://schemas.openxmlformats.org/officeDocument/2006/relationships" xmlns:p="http://schemas.openxmlformats.org/presentationml/2006/main">
+  <p:cSld>
+    <p:spTree>
+      <p:nvGrpSpPr>
+        <p:cNvPr id="1" name=""/>
+        <p:cNvGrpSpPr/>
+        <p:nvPr/>
+      </p:nvGrpSpPr>
+      <p:grpSpPr>
+        <a:xfrm>
+          <a:off x="0" y="0"/>
+          <a:ext cx="0" cy="0"/>
+          <a:chOff x="0" y="0"/>
+          <a:chExt cx="0" cy="0"/>
+        </a:xfrm>
+      </p:grpSpPr>
+      <p:sp>
+        <p:nvSpPr>
+          <p:cNvPr id="2" name="Title 1">
+            <a:extLst>
+              <a:ext uri="{FF2B5EF4-FFF2-40B4-BE49-F238E27FC236}">
+                <a16:creationId xmlns:a16="http://schemas.microsoft.com/office/drawing/2014/main" id="{01E53C5E-E8C5-1617-78E1-FC5D8747D8D7}"/>
+              </a:ext>
+            </a:extLst>
+          </p:cNvPr>
+          <p:cNvSpPr>
+            <a:spLocks noGrp="1"/>
+          </p:cNvSpPr>
+          <p:nvPr>
+            <p:ph type="title"/>
+          </p:nvPr>
+        </p:nvSpPr>
+        <p:spPr/>
+        <p:txBody>
+          <a:bodyPr/>
+          <a:lstStyle/>
+          <a:p>
+            <a:r>
+              <a:rPr lang="en-US" dirty="0"/>
+              <a:t>Bayesian model output</a:t>
+            </a:r>
+          </a:p>
+        </p:txBody>
+      </p:sp>
+      <p:sp>
+        <p:nvSpPr>
+          <p:cNvPr id="3" name="Content Placeholder 2">
+            <a:extLst>
+              <a:ext uri="{FF2B5EF4-FFF2-40B4-BE49-F238E27FC236}">
+                <a16:creationId xmlns:a16="http://schemas.microsoft.com/office/drawing/2014/main" id="{D5C43D05-A3EB-146E-88BB-0F7D4C7754D0}"/>
+              </a:ext>
+            </a:extLst>
+          </p:cNvPr>
+          <p:cNvSpPr>
+            <a:spLocks noGrp="1"/>
+          </p:cNvSpPr>
+          <p:nvPr>
+            <p:ph idx="1"/>
+          </p:nvPr>
+        </p:nvSpPr>
+        <p:spPr/>
+        <p:txBody>
+          <a:bodyPr/>
+          <a:lstStyle/>
+          <a:p>
+            <a:endParaRPr lang="en-US"/>
+          </a:p>
+        </p:txBody>
+      </p:sp>
+    </p:spTree>
+    <p:extLst>
+      <p:ext uri="{BB962C8B-B14F-4D97-AF65-F5344CB8AC3E}">
+        <p14:creationId xmlns:p14="http://schemas.microsoft.com/office/powerpoint/2010/main" val="1566926840"/>
+      </p:ext>
+    </p:extLst>
+  </p:cSld>
+  <p:clrMapOvr>
+    <a:masterClrMapping/>
+  </p:clrMapOvr>
+</p:sld>
+</file>
+
 <file path=ppt/slides/slide12.xml><?xml version="1.0" encoding="utf-8"?>
 <p:sld xmlns:a="http://schemas.openxmlformats.org/drawingml/2006/main" xmlns:r="http://schemas.openxmlformats.org/officeDocument/2006/relationships" xmlns:p="http://schemas.openxmlformats.org/presentationml/2006/main">
   <p:cSld>
@@ -4657,7 +4656,7 @@
           <p:cNvPr id="2" name="Title 1">
             <a:extLst>
               <a:ext uri="{FF2B5EF4-FFF2-40B4-BE49-F238E27FC236}">
-                <a16:creationId xmlns:a16="http://schemas.microsoft.com/office/drawing/2014/main" id="{01E53C5E-E8C5-1617-78E1-FC5D8747D8D7}"/>
+                <a16:creationId xmlns:a16="http://schemas.microsoft.com/office/drawing/2014/main" id="{030618CE-196B-4610-700F-D477A87C3BDC}"/>
               </a:ext>
             </a:extLst>
           </p:cNvPr>
@@ -4674,9 +4673,10 @@
           <a:lstStyle/>
           <a:p>
             <a:r>
-              <a:rPr lang="en-US" dirty="0"/>
-              <a:t>Bayesian model output</a:t>
-            </a:r>
+              <a:rPr lang="en-US"/>
+              <a:t>All data – posterior distribution of environmental covariates</a:t>
+            </a:r>
+            <a:endParaRPr lang="en-US" dirty="0"/>
           </a:p>
         </p:txBody>
       </p:sp>
@@ -4685,7 +4685,7 @@
           <p:cNvPr id="3" name="Content Placeholder 2">
             <a:extLst>
               <a:ext uri="{FF2B5EF4-FFF2-40B4-BE49-F238E27FC236}">
-                <a16:creationId xmlns:a16="http://schemas.microsoft.com/office/drawing/2014/main" id="{D5C43D05-A3EB-146E-88BB-0F7D4C7754D0}"/>
+                <a16:creationId xmlns:a16="http://schemas.microsoft.com/office/drawing/2014/main" id="{EC9D7370-E9A1-8842-4C68-AE1912AD72DE}"/>
               </a:ext>
             </a:extLst>
           </p:cNvPr>
@@ -4701,14 +4701,44 @@
           <a:bodyPr/>
           <a:lstStyle/>
           <a:p>
-            <a:endParaRPr lang="en-US"/>
-          </a:p>
-        </p:txBody>
-      </p:sp>
+            <a:endParaRPr lang="en-US" dirty="0"/>
+          </a:p>
+        </p:txBody>
+      </p:sp>
+      <p:pic>
+        <p:nvPicPr>
+          <p:cNvPr id="5" name="Picture 4">
+            <a:extLst>
+              <a:ext uri="{FF2B5EF4-FFF2-40B4-BE49-F238E27FC236}">
+                <a16:creationId xmlns:a16="http://schemas.microsoft.com/office/drawing/2014/main" id="{209DEE5B-4399-5A97-5265-ED6F2CDFCB9B}"/>
+              </a:ext>
+            </a:extLst>
+          </p:cNvPr>
+          <p:cNvPicPr>
+            <a:picLocks noChangeAspect="1"/>
+          </p:cNvPicPr>
+          <p:nvPr/>
+        </p:nvPicPr>
+        <p:blipFill>
+          <a:blip r:embed="rId2"/>
+          <a:stretch>
+            <a:fillRect/>
+          </a:stretch>
+        </p:blipFill>
+        <p:spPr>
+          <a:xfrm>
+            <a:off x="4305012" y="2043906"/>
+            <a:ext cx="5743863" cy="3914775"/>
+          </a:xfrm>
+          <a:prstGeom prst="rect">
+            <a:avLst/>
+          </a:prstGeom>
+        </p:spPr>
+      </p:pic>
     </p:spTree>
     <p:extLst>
       <p:ext uri="{BB962C8B-B14F-4D97-AF65-F5344CB8AC3E}">
-        <p14:creationId xmlns:p14="http://schemas.microsoft.com/office/powerpoint/2010/main" val="1566926840"/>
+        <p14:creationId xmlns:p14="http://schemas.microsoft.com/office/powerpoint/2010/main" val="3555751872"/>
       </p:ext>
     </p:extLst>
   </p:cSld>
@@ -4740,7 +4770,7 @@
           <p:cNvPr id="2" name="Title 1">
             <a:extLst>
               <a:ext uri="{FF2B5EF4-FFF2-40B4-BE49-F238E27FC236}">
-                <a16:creationId xmlns:a16="http://schemas.microsoft.com/office/drawing/2014/main" id="{030618CE-196B-4610-700F-D477A87C3BDC}"/>
+                <a16:creationId xmlns:a16="http://schemas.microsoft.com/office/drawing/2014/main" id="{A76E1893-F885-30C7-28A7-99621162EF96}"/>
               </a:ext>
             </a:extLst>
           </p:cNvPr>
@@ -4756,10 +4786,7 @@
           <a:bodyPr/>
           <a:lstStyle/>
           <a:p>
-            <a:r>
-              <a:rPr lang="en-US" dirty="0"/>
-              <a:t>All data – posterior distribution of environmental covariates</a:t>
-            </a:r>
+            <a:endParaRPr lang="en-US"/>
           </a:p>
         </p:txBody>
       </p:sp>
@@ -4768,7 +4795,7 @@
           <p:cNvPr id="3" name="Content Placeholder 2">
             <a:extLst>
               <a:ext uri="{FF2B5EF4-FFF2-40B4-BE49-F238E27FC236}">
-                <a16:creationId xmlns:a16="http://schemas.microsoft.com/office/drawing/2014/main" id="{EC9D7370-E9A1-8842-4C68-AE1912AD72DE}"/>
+                <a16:creationId xmlns:a16="http://schemas.microsoft.com/office/drawing/2014/main" id="{0742EA1B-F4DE-1DEE-4F7E-88BBA386538A}"/>
               </a:ext>
             </a:extLst>
           </p:cNvPr>
@@ -4784,16 +4811,16 @@
           <a:bodyPr/>
           <a:lstStyle/>
           <a:p>
-            <a:endParaRPr lang="en-US" dirty="0"/>
+            <a:endParaRPr lang="en-US"/>
           </a:p>
         </p:txBody>
       </p:sp>
       <p:pic>
         <p:nvPicPr>
-          <p:cNvPr id="10" name="Picture 9">
-            <a:extLst>
-              <a:ext uri="{FF2B5EF4-FFF2-40B4-BE49-F238E27FC236}">
-                <a16:creationId xmlns:a16="http://schemas.microsoft.com/office/drawing/2014/main" id="{4CB5E670-C7EF-4E71-1F74-D1DE16BC25E4}"/>
+          <p:cNvPr id="5" name="Picture 4">
+            <a:extLst>
+              <a:ext uri="{FF2B5EF4-FFF2-40B4-BE49-F238E27FC236}">
+                <a16:creationId xmlns:a16="http://schemas.microsoft.com/office/drawing/2014/main" id="{C41CE28B-3551-87AC-4616-77DCCD6E5AB1}"/>
               </a:ext>
             </a:extLst>
           </p:cNvPr>
@@ -4810,8 +4837,8 @@
         </p:blipFill>
         <p:spPr>
           <a:xfrm>
-            <a:off x="1596064" y="1690688"/>
-            <a:ext cx="8274620" cy="4869079"/>
+            <a:off x="2811018" y="0"/>
+            <a:ext cx="6569964" cy="6858000"/>
           </a:xfrm>
           <a:prstGeom prst="rect">
             <a:avLst/>
@@ -4821,7 +4848,7 @@
     </p:spTree>
     <p:extLst>
       <p:ext uri="{BB962C8B-B14F-4D97-AF65-F5344CB8AC3E}">
-        <p14:creationId xmlns:p14="http://schemas.microsoft.com/office/powerpoint/2010/main" val="3555751872"/>
+        <p14:creationId xmlns:p14="http://schemas.microsoft.com/office/powerpoint/2010/main" val="434478555"/>
       </p:ext>
     </p:extLst>
   </p:cSld>
@@ -4832,6 +4859,116 @@
 </file>
 
 <file path=ppt/slides/slide14.xml><?xml version="1.0" encoding="utf-8"?>
+<p:sld xmlns:a="http://schemas.openxmlformats.org/drawingml/2006/main" xmlns:r="http://schemas.openxmlformats.org/officeDocument/2006/relationships" xmlns:p="http://schemas.openxmlformats.org/presentationml/2006/main">
+  <p:cSld>
+    <p:spTree>
+      <p:nvGrpSpPr>
+        <p:cNvPr id="1" name=""/>
+        <p:cNvGrpSpPr/>
+        <p:nvPr/>
+      </p:nvGrpSpPr>
+      <p:grpSpPr>
+        <a:xfrm>
+          <a:off x="0" y="0"/>
+          <a:ext cx="0" cy="0"/>
+          <a:chOff x="0" y="0"/>
+          <a:chExt cx="0" cy="0"/>
+        </a:xfrm>
+      </p:grpSpPr>
+      <p:sp>
+        <p:nvSpPr>
+          <p:cNvPr id="2" name="Title 1">
+            <a:extLst>
+              <a:ext uri="{FF2B5EF4-FFF2-40B4-BE49-F238E27FC236}">
+                <a16:creationId xmlns:a16="http://schemas.microsoft.com/office/drawing/2014/main" id="{45C05EB4-186C-174C-11C8-150A20CAD864}"/>
+              </a:ext>
+            </a:extLst>
+          </p:cNvPr>
+          <p:cNvSpPr>
+            <a:spLocks noGrp="1"/>
+          </p:cNvSpPr>
+          <p:nvPr>
+            <p:ph type="title"/>
+          </p:nvPr>
+        </p:nvSpPr>
+        <p:spPr/>
+        <p:txBody>
+          <a:bodyPr/>
+          <a:lstStyle/>
+          <a:p>
+            <a:endParaRPr lang="en-US"/>
+          </a:p>
+        </p:txBody>
+      </p:sp>
+      <p:sp>
+        <p:nvSpPr>
+          <p:cNvPr id="3" name="Content Placeholder 2">
+            <a:extLst>
+              <a:ext uri="{FF2B5EF4-FFF2-40B4-BE49-F238E27FC236}">
+                <a16:creationId xmlns:a16="http://schemas.microsoft.com/office/drawing/2014/main" id="{7B80C4F9-F655-F3C7-470E-FB6B9864B798}"/>
+              </a:ext>
+            </a:extLst>
+          </p:cNvPr>
+          <p:cNvSpPr>
+            <a:spLocks noGrp="1"/>
+          </p:cNvSpPr>
+          <p:nvPr>
+            <p:ph idx="1"/>
+          </p:nvPr>
+        </p:nvSpPr>
+        <p:spPr/>
+        <p:txBody>
+          <a:bodyPr/>
+          <a:lstStyle/>
+          <a:p>
+            <a:endParaRPr lang="en-US"/>
+          </a:p>
+        </p:txBody>
+      </p:sp>
+      <p:pic>
+        <p:nvPicPr>
+          <p:cNvPr id="5" name="Picture 4">
+            <a:extLst>
+              <a:ext uri="{FF2B5EF4-FFF2-40B4-BE49-F238E27FC236}">
+                <a16:creationId xmlns:a16="http://schemas.microsoft.com/office/drawing/2014/main" id="{EC8A23BC-ADCC-7459-24D4-3259525F9F98}"/>
+              </a:ext>
+            </a:extLst>
+          </p:cNvPr>
+          <p:cNvPicPr>
+            <a:picLocks noChangeAspect="1"/>
+          </p:cNvPicPr>
+          <p:nvPr/>
+        </p:nvPicPr>
+        <p:blipFill>
+          <a:blip r:embed="rId2"/>
+          <a:stretch>
+            <a:fillRect/>
+          </a:stretch>
+        </p:blipFill>
+        <p:spPr>
+          <a:xfrm>
+            <a:off x="2671763" y="595312"/>
+            <a:ext cx="7581899" cy="5667375"/>
+          </a:xfrm>
+          <a:prstGeom prst="rect">
+            <a:avLst/>
+          </a:prstGeom>
+        </p:spPr>
+      </p:pic>
+    </p:spTree>
+    <p:extLst>
+      <p:ext uri="{BB962C8B-B14F-4D97-AF65-F5344CB8AC3E}">
+        <p14:creationId xmlns:p14="http://schemas.microsoft.com/office/powerpoint/2010/main" val="1527682479"/>
+      </p:ext>
+    </p:extLst>
+  </p:cSld>
+  <p:clrMapOvr>
+    <a:masterClrMapping/>
+  </p:clrMapOvr>
+</p:sld>
+</file>
+
+<file path=ppt/slides/slide15.xml><?xml version="1.0" encoding="utf-8"?>
 <p:sld xmlns:a="http://schemas.openxmlformats.org/drawingml/2006/main" xmlns:r="http://schemas.openxmlformats.org/officeDocument/2006/relationships" xmlns:p="http://schemas.openxmlformats.org/presentationml/2006/main">
   <p:cSld>
     <p:spTree>
@@ -4950,7 +5087,7 @@
 </p:sld>
 </file>
 
-<file path=ppt/slides/slide15.xml><?xml version="1.0" encoding="utf-8"?>
+<file path=ppt/slides/slide16.xml><?xml version="1.0" encoding="utf-8"?>
 <p:sld xmlns:a="http://schemas.openxmlformats.org/drawingml/2006/main" xmlns:r="http://schemas.openxmlformats.org/officeDocument/2006/relationships" xmlns:p="http://schemas.openxmlformats.org/presentationml/2006/main">
   <p:cSld>
     <p:spTree>
@@ -5063,7 +5200,7 @@
 </p:sld>
 </file>
 
-<file path=ppt/slides/slide16.xml><?xml version="1.0" encoding="utf-8"?>
+<file path=ppt/slides/slide17.xml><?xml version="1.0" encoding="utf-8"?>
 <p:sld xmlns:a="http://schemas.openxmlformats.org/drawingml/2006/main" xmlns:r="http://schemas.openxmlformats.org/officeDocument/2006/relationships" xmlns:p="http://schemas.openxmlformats.org/presentationml/2006/main">
   <p:cSld>
     <p:spTree>
@@ -5155,7 +5292,7 @@
 </p:sld>
 </file>
 
-<file path=ppt/slides/slide17.xml><?xml version="1.0" encoding="utf-8"?>
+<file path=ppt/slides/slide18.xml><?xml version="1.0" encoding="utf-8"?>
 <p:sld xmlns:a="http://schemas.openxmlformats.org/drawingml/2006/main" xmlns:r="http://schemas.openxmlformats.org/officeDocument/2006/relationships" xmlns:p="http://schemas.openxmlformats.org/presentationml/2006/main">
   <p:cSld>
     <p:spTree>
@@ -5268,7 +5405,7 @@
 </p:sld>
 </file>
 
-<file path=ppt/slides/slide18.xml><?xml version="1.0" encoding="utf-8"?>
+<file path=ppt/slides/slide19.xml><?xml version="1.0" encoding="utf-8"?>
 <p:sld xmlns:a="http://schemas.openxmlformats.org/drawingml/2006/main" xmlns:r="http://schemas.openxmlformats.org/officeDocument/2006/relationships" xmlns:p="http://schemas.openxmlformats.org/presentationml/2006/main">
   <p:cSld>
     <p:spTree>
@@ -5387,224 +5524,6 @@
 </p:sld>
 </file>
 
-<file path=ppt/slides/slide19.xml><?xml version="1.0" encoding="utf-8"?>
-<p:sld xmlns:a="http://schemas.openxmlformats.org/drawingml/2006/main" xmlns:r="http://schemas.openxmlformats.org/officeDocument/2006/relationships" xmlns:p="http://schemas.openxmlformats.org/presentationml/2006/main">
-  <p:cSld>
-    <p:spTree>
-      <p:nvGrpSpPr>
-        <p:cNvPr id="1" name=""/>
-        <p:cNvGrpSpPr/>
-        <p:nvPr/>
-      </p:nvGrpSpPr>
-      <p:grpSpPr>
-        <a:xfrm>
-          <a:off x="0" y="0"/>
-          <a:ext cx="0" cy="0"/>
-          <a:chOff x="0" y="0"/>
-          <a:chExt cx="0" cy="0"/>
-        </a:xfrm>
-      </p:grpSpPr>
-      <p:sp>
-        <p:nvSpPr>
-          <p:cNvPr id="2" name="Title 1">
-            <a:extLst>
-              <a:ext uri="{FF2B5EF4-FFF2-40B4-BE49-F238E27FC236}">
-                <a16:creationId xmlns:a16="http://schemas.microsoft.com/office/drawing/2014/main" id="{63974EF5-9152-C1CB-5024-DF20EC0C92A0}"/>
-              </a:ext>
-            </a:extLst>
-          </p:cNvPr>
-          <p:cNvSpPr>
-            <a:spLocks noGrp="1"/>
-          </p:cNvSpPr>
-          <p:nvPr>
-            <p:ph type="title"/>
-          </p:nvPr>
-        </p:nvSpPr>
-        <p:spPr>
-          <a:xfrm>
-            <a:off x="254913" y="84740"/>
-            <a:ext cx="10515600" cy="1325563"/>
-          </a:xfrm>
-        </p:spPr>
-        <p:txBody>
-          <a:bodyPr/>
-          <a:lstStyle/>
-          <a:p>
-            <a:r>
-              <a:rPr lang="en-US" dirty="0"/>
-              <a:t>Annual mean age with env covariates</a:t>
-            </a:r>
-          </a:p>
-        </p:txBody>
-      </p:sp>
-      <p:sp>
-        <p:nvSpPr>
-          <p:cNvPr id="3" name="Content Placeholder 2">
-            <a:extLst>
-              <a:ext uri="{FF2B5EF4-FFF2-40B4-BE49-F238E27FC236}">
-                <a16:creationId xmlns:a16="http://schemas.microsoft.com/office/drawing/2014/main" id="{F0069C7D-117B-E5CF-E117-185BC93578DC}"/>
-              </a:ext>
-            </a:extLst>
-          </p:cNvPr>
-          <p:cNvSpPr>
-            <a:spLocks noGrp="1"/>
-          </p:cNvSpPr>
-          <p:nvPr>
-            <p:ph idx="1"/>
-          </p:nvPr>
-        </p:nvSpPr>
-        <p:spPr/>
-        <p:txBody>
-          <a:bodyPr/>
-          <a:lstStyle/>
-          <a:p>
-            <a:endParaRPr lang="en-US"/>
-          </a:p>
-        </p:txBody>
-      </p:sp>
-      <p:pic>
-        <p:nvPicPr>
-          <p:cNvPr id="8" name="Picture 7">
-            <a:extLst>
-              <a:ext uri="{FF2B5EF4-FFF2-40B4-BE49-F238E27FC236}">
-                <a16:creationId xmlns:a16="http://schemas.microsoft.com/office/drawing/2014/main" id="{3B35CE2F-5329-6B02-B0B3-8EEE4CD6EE84}"/>
-              </a:ext>
-            </a:extLst>
-          </p:cNvPr>
-          <p:cNvPicPr>
-            <a:picLocks noChangeAspect="1"/>
-          </p:cNvPicPr>
-          <p:nvPr/>
-        </p:nvPicPr>
-        <p:blipFill>
-          <a:blip r:embed="rId2"/>
-          <a:stretch>
-            <a:fillRect/>
-          </a:stretch>
-        </p:blipFill>
-        <p:spPr>
-          <a:xfrm>
-            <a:off x="254913" y="1571370"/>
-            <a:ext cx="5956238" cy="4921505"/>
-          </a:xfrm>
-          <a:prstGeom prst="rect">
-            <a:avLst/>
-          </a:prstGeom>
-        </p:spPr>
-      </p:pic>
-      <p:pic>
-        <p:nvPicPr>
-          <p:cNvPr id="12" name="Picture 11">
-            <a:extLst>
-              <a:ext uri="{FF2B5EF4-FFF2-40B4-BE49-F238E27FC236}">
-                <a16:creationId xmlns:a16="http://schemas.microsoft.com/office/drawing/2014/main" id="{0A39B213-D867-8C9B-4E79-4E845AAC3F93}"/>
-              </a:ext>
-            </a:extLst>
-          </p:cNvPr>
-          <p:cNvPicPr>
-            <a:picLocks noChangeAspect="1"/>
-          </p:cNvPicPr>
-          <p:nvPr/>
-        </p:nvPicPr>
-        <p:blipFill>
-          <a:blip r:embed="rId3"/>
-          <a:stretch>
-            <a:fillRect/>
-          </a:stretch>
-        </p:blipFill>
-        <p:spPr>
-          <a:xfrm>
-            <a:off x="6400639" y="1503491"/>
-            <a:ext cx="5779071" cy="4989384"/>
-          </a:xfrm>
-          <a:prstGeom prst="rect">
-            <a:avLst/>
-          </a:prstGeom>
-        </p:spPr>
-      </p:pic>
-      <p:sp>
-        <p:nvSpPr>
-          <p:cNvPr id="14" name="TextBox 13">
-            <a:extLst>
-              <a:ext uri="{FF2B5EF4-FFF2-40B4-BE49-F238E27FC236}">
-                <a16:creationId xmlns:a16="http://schemas.microsoft.com/office/drawing/2014/main" id="{84C87C66-D5D4-E059-9326-536F7A75785E}"/>
-              </a:ext>
-            </a:extLst>
-          </p:cNvPr>
-          <p:cNvSpPr txBox="1"/>
-          <p:nvPr/>
-        </p:nvSpPr>
-        <p:spPr>
-          <a:xfrm>
-            <a:off x="671121" y="1177358"/>
-            <a:ext cx="1500732" cy="369332"/>
-          </a:xfrm>
-          <a:prstGeom prst="rect">
-            <a:avLst/>
-          </a:prstGeom>
-          <a:noFill/>
-        </p:spPr>
-        <p:txBody>
-          <a:bodyPr wrap="none" rtlCol="0">
-            <a:spAutoFit/>
-          </a:bodyPr>
-          <a:lstStyle/>
-          <a:p>
-            <a:r>
-              <a:rPr lang="en-US" dirty="0"/>
-              <a:t>Annual mean</a:t>
-            </a:r>
-          </a:p>
-        </p:txBody>
-      </p:sp>
-      <p:sp>
-        <p:nvSpPr>
-          <p:cNvPr id="16" name="TextBox 15">
-            <a:extLst>
-              <a:ext uri="{FF2B5EF4-FFF2-40B4-BE49-F238E27FC236}">
-                <a16:creationId xmlns:a16="http://schemas.microsoft.com/office/drawing/2014/main" id="{55029EBF-8225-99EE-0EBF-0EC9C0F0050D}"/>
-              </a:ext>
-            </a:extLst>
-          </p:cNvPr>
-          <p:cNvSpPr txBox="1"/>
-          <p:nvPr/>
-        </p:nvSpPr>
-        <p:spPr>
-          <a:xfrm>
-            <a:off x="6892414" y="1121505"/>
-            <a:ext cx="2720617" cy="369332"/>
-          </a:xfrm>
-          <a:prstGeom prst="rect">
-            <a:avLst/>
-          </a:prstGeom>
-          <a:noFill/>
-        </p:spPr>
-        <p:txBody>
-          <a:bodyPr wrap="none" rtlCol="0">
-            <a:spAutoFit/>
-          </a:bodyPr>
-          <a:lstStyle/>
-          <a:p>
-            <a:r>
-              <a:rPr lang="en-US" dirty="0"/>
-              <a:t>Spring mean (April – June)</a:t>
-            </a:r>
-          </a:p>
-        </p:txBody>
-      </p:sp>
-    </p:spTree>
-    <p:extLst>
-      <p:ext uri="{BB962C8B-B14F-4D97-AF65-F5344CB8AC3E}">
-        <p14:creationId xmlns:p14="http://schemas.microsoft.com/office/powerpoint/2010/main" val="4222444916"/>
-      </p:ext>
-    </p:extLst>
-  </p:cSld>
-  <p:clrMapOvr>
-    <a:masterClrMapping/>
-  </p:clrMapOvr>
-</p:sld>
-</file>
-
 <file path=ppt/slides/slide2.xml><?xml version="1.0" encoding="utf-8"?>
 <p:sld xmlns:a="http://schemas.openxmlformats.org/drawingml/2006/main" xmlns:r="http://schemas.openxmlformats.org/officeDocument/2006/relationships" xmlns:p="http://schemas.openxmlformats.org/presentationml/2006/main">
   <p:cSld>
@@ -5785,6 +5704,994 @@
           <p:cNvPr id="2" name="Title 1">
             <a:extLst>
               <a:ext uri="{FF2B5EF4-FFF2-40B4-BE49-F238E27FC236}">
+                <a16:creationId xmlns:a16="http://schemas.microsoft.com/office/drawing/2014/main" id="{63974EF5-9152-C1CB-5024-DF20EC0C92A0}"/>
+              </a:ext>
+            </a:extLst>
+          </p:cNvPr>
+          <p:cNvSpPr>
+            <a:spLocks noGrp="1"/>
+          </p:cNvSpPr>
+          <p:nvPr>
+            <p:ph type="title"/>
+          </p:nvPr>
+        </p:nvSpPr>
+        <p:spPr>
+          <a:xfrm>
+            <a:off x="254913" y="84740"/>
+            <a:ext cx="10515600" cy="1325563"/>
+          </a:xfrm>
+        </p:spPr>
+        <p:txBody>
+          <a:bodyPr/>
+          <a:lstStyle/>
+          <a:p>
+            <a:r>
+              <a:rPr lang="en-US" dirty="0"/>
+              <a:t>Annual mean age with env covariates</a:t>
+            </a:r>
+          </a:p>
+        </p:txBody>
+      </p:sp>
+      <p:sp>
+        <p:nvSpPr>
+          <p:cNvPr id="3" name="Content Placeholder 2">
+            <a:extLst>
+              <a:ext uri="{FF2B5EF4-FFF2-40B4-BE49-F238E27FC236}">
+                <a16:creationId xmlns:a16="http://schemas.microsoft.com/office/drawing/2014/main" id="{F0069C7D-117B-E5CF-E117-185BC93578DC}"/>
+              </a:ext>
+            </a:extLst>
+          </p:cNvPr>
+          <p:cNvSpPr>
+            <a:spLocks noGrp="1"/>
+          </p:cNvSpPr>
+          <p:nvPr>
+            <p:ph idx="1"/>
+          </p:nvPr>
+        </p:nvSpPr>
+        <p:spPr/>
+        <p:txBody>
+          <a:bodyPr/>
+          <a:lstStyle/>
+          <a:p>
+            <a:endParaRPr lang="en-US" dirty="0"/>
+          </a:p>
+        </p:txBody>
+      </p:sp>
+      <p:pic>
+        <p:nvPicPr>
+          <p:cNvPr id="8" name="Picture 7">
+            <a:extLst>
+              <a:ext uri="{FF2B5EF4-FFF2-40B4-BE49-F238E27FC236}">
+                <a16:creationId xmlns:a16="http://schemas.microsoft.com/office/drawing/2014/main" id="{3B35CE2F-5329-6B02-B0B3-8EEE4CD6EE84}"/>
+              </a:ext>
+            </a:extLst>
+          </p:cNvPr>
+          <p:cNvPicPr>
+            <a:picLocks noChangeAspect="1"/>
+          </p:cNvPicPr>
+          <p:nvPr/>
+        </p:nvPicPr>
+        <p:blipFill>
+          <a:blip r:embed="rId2"/>
+          <a:stretch>
+            <a:fillRect/>
+          </a:stretch>
+        </p:blipFill>
+        <p:spPr>
+          <a:xfrm>
+            <a:off x="254913" y="1571370"/>
+            <a:ext cx="5956238" cy="4921505"/>
+          </a:xfrm>
+          <a:prstGeom prst="rect">
+            <a:avLst/>
+          </a:prstGeom>
+        </p:spPr>
+      </p:pic>
+      <p:pic>
+        <p:nvPicPr>
+          <p:cNvPr id="12" name="Picture 11">
+            <a:extLst>
+              <a:ext uri="{FF2B5EF4-FFF2-40B4-BE49-F238E27FC236}">
+                <a16:creationId xmlns:a16="http://schemas.microsoft.com/office/drawing/2014/main" id="{0A39B213-D867-8C9B-4E79-4E845AAC3F93}"/>
+              </a:ext>
+            </a:extLst>
+          </p:cNvPr>
+          <p:cNvPicPr>
+            <a:picLocks noChangeAspect="1"/>
+          </p:cNvPicPr>
+          <p:nvPr/>
+        </p:nvPicPr>
+        <p:blipFill>
+          <a:blip r:embed="rId3"/>
+          <a:stretch>
+            <a:fillRect/>
+          </a:stretch>
+        </p:blipFill>
+        <p:spPr>
+          <a:xfrm>
+            <a:off x="6400639" y="1503491"/>
+            <a:ext cx="5779071" cy="4989384"/>
+          </a:xfrm>
+          <a:prstGeom prst="rect">
+            <a:avLst/>
+          </a:prstGeom>
+        </p:spPr>
+      </p:pic>
+      <p:sp>
+        <p:nvSpPr>
+          <p:cNvPr id="14" name="TextBox 13">
+            <a:extLst>
+              <a:ext uri="{FF2B5EF4-FFF2-40B4-BE49-F238E27FC236}">
+                <a16:creationId xmlns:a16="http://schemas.microsoft.com/office/drawing/2014/main" id="{84C87C66-D5D4-E059-9326-536F7A75785E}"/>
+              </a:ext>
+            </a:extLst>
+          </p:cNvPr>
+          <p:cNvSpPr txBox="1"/>
+          <p:nvPr/>
+        </p:nvSpPr>
+        <p:spPr>
+          <a:xfrm>
+            <a:off x="671121" y="1177358"/>
+            <a:ext cx="1500732" cy="369332"/>
+          </a:xfrm>
+          <a:prstGeom prst="rect">
+            <a:avLst/>
+          </a:prstGeom>
+          <a:noFill/>
+        </p:spPr>
+        <p:txBody>
+          <a:bodyPr wrap="none" rtlCol="0">
+            <a:spAutoFit/>
+          </a:bodyPr>
+          <a:lstStyle/>
+          <a:p>
+            <a:r>
+              <a:rPr lang="en-US" dirty="0"/>
+              <a:t>Annual mean</a:t>
+            </a:r>
+          </a:p>
+        </p:txBody>
+      </p:sp>
+      <p:sp>
+        <p:nvSpPr>
+          <p:cNvPr id="16" name="TextBox 15">
+            <a:extLst>
+              <a:ext uri="{FF2B5EF4-FFF2-40B4-BE49-F238E27FC236}">
+                <a16:creationId xmlns:a16="http://schemas.microsoft.com/office/drawing/2014/main" id="{55029EBF-8225-99EE-0EBF-0EC9C0F0050D}"/>
+              </a:ext>
+            </a:extLst>
+          </p:cNvPr>
+          <p:cNvSpPr txBox="1"/>
+          <p:nvPr/>
+        </p:nvSpPr>
+        <p:spPr>
+          <a:xfrm>
+            <a:off x="6892414" y="1121505"/>
+            <a:ext cx="2720617" cy="369332"/>
+          </a:xfrm>
+          <a:prstGeom prst="rect">
+            <a:avLst/>
+          </a:prstGeom>
+          <a:noFill/>
+        </p:spPr>
+        <p:txBody>
+          <a:bodyPr wrap="none" rtlCol="0">
+            <a:spAutoFit/>
+          </a:bodyPr>
+          <a:lstStyle/>
+          <a:p>
+            <a:r>
+              <a:rPr lang="en-US" dirty="0"/>
+              <a:t>Spring mean (April – June)</a:t>
+            </a:r>
+          </a:p>
+        </p:txBody>
+      </p:sp>
+    </p:spTree>
+    <p:extLst>
+      <p:ext uri="{BB962C8B-B14F-4D97-AF65-F5344CB8AC3E}">
+        <p14:creationId xmlns:p14="http://schemas.microsoft.com/office/powerpoint/2010/main" val="4222444916"/>
+      </p:ext>
+    </p:extLst>
+  </p:cSld>
+  <p:clrMapOvr>
+    <a:masterClrMapping/>
+  </p:clrMapOvr>
+</p:sld>
+</file>
+
+<file path=ppt/slides/slide21.xml><?xml version="1.0" encoding="utf-8"?>
+<p:sld xmlns:a="http://schemas.openxmlformats.org/drawingml/2006/main" xmlns:r="http://schemas.openxmlformats.org/officeDocument/2006/relationships" xmlns:p="http://schemas.openxmlformats.org/presentationml/2006/main">
+  <p:cSld>
+    <p:spTree>
+      <p:nvGrpSpPr>
+        <p:cNvPr id="1" name=""/>
+        <p:cNvGrpSpPr/>
+        <p:nvPr/>
+      </p:nvGrpSpPr>
+      <p:grpSpPr>
+        <a:xfrm>
+          <a:off x="0" y="0"/>
+          <a:ext cx="0" cy="0"/>
+          <a:chOff x="0" y="0"/>
+          <a:chExt cx="0" cy="0"/>
+        </a:xfrm>
+      </p:grpSpPr>
+      <p:sp>
+        <p:nvSpPr>
+          <p:cNvPr id="2" name="Title 1">
+            <a:extLst>
+              <a:ext uri="{FF2B5EF4-FFF2-40B4-BE49-F238E27FC236}">
+                <a16:creationId xmlns:a16="http://schemas.microsoft.com/office/drawing/2014/main" id="{C19929FA-4060-5FBB-DA5F-01782E94ADB5}"/>
+              </a:ext>
+            </a:extLst>
+          </p:cNvPr>
+          <p:cNvSpPr>
+            <a:spLocks noGrp="1"/>
+          </p:cNvSpPr>
+          <p:nvPr>
+            <p:ph type="title"/>
+          </p:nvPr>
+        </p:nvSpPr>
+        <p:spPr/>
+        <p:txBody>
+          <a:bodyPr/>
+          <a:lstStyle/>
+          <a:p>
+            <a:endParaRPr lang="en-US"/>
+          </a:p>
+        </p:txBody>
+      </p:sp>
+      <p:sp>
+        <p:nvSpPr>
+          <p:cNvPr id="3" name="Content Placeholder 2">
+            <a:extLst>
+              <a:ext uri="{FF2B5EF4-FFF2-40B4-BE49-F238E27FC236}">
+                <a16:creationId xmlns:a16="http://schemas.microsoft.com/office/drawing/2014/main" id="{61A0BB3D-2541-7FBC-B800-08FE76EE340B}"/>
+              </a:ext>
+            </a:extLst>
+          </p:cNvPr>
+          <p:cNvSpPr>
+            <a:spLocks noGrp="1"/>
+          </p:cNvSpPr>
+          <p:nvPr>
+            <p:ph idx="1"/>
+          </p:nvPr>
+        </p:nvSpPr>
+        <p:spPr/>
+        <p:txBody>
+          <a:bodyPr/>
+          <a:lstStyle/>
+          <a:p>
+            <a:endParaRPr lang="en-US"/>
+          </a:p>
+        </p:txBody>
+      </p:sp>
+      <p:pic>
+        <p:nvPicPr>
+          <p:cNvPr id="5" name="Picture 4">
+            <a:extLst>
+              <a:ext uri="{FF2B5EF4-FFF2-40B4-BE49-F238E27FC236}">
+                <a16:creationId xmlns:a16="http://schemas.microsoft.com/office/drawing/2014/main" id="{F4DFA375-F069-D058-6D3C-25D0613FFA83}"/>
+              </a:ext>
+            </a:extLst>
+          </p:cNvPr>
+          <p:cNvPicPr>
+            <a:picLocks noChangeAspect="1"/>
+          </p:cNvPicPr>
+          <p:nvPr/>
+        </p:nvPicPr>
+        <p:blipFill>
+          <a:blip r:embed="rId2"/>
+          <a:stretch>
+            <a:fillRect/>
+          </a:stretch>
+        </p:blipFill>
+        <p:spPr>
+          <a:xfrm>
+            <a:off x="1890712" y="614362"/>
+            <a:ext cx="8410575" cy="5629275"/>
+          </a:xfrm>
+          <a:prstGeom prst="rect">
+            <a:avLst/>
+          </a:prstGeom>
+        </p:spPr>
+      </p:pic>
+    </p:spTree>
+    <p:extLst>
+      <p:ext uri="{BB962C8B-B14F-4D97-AF65-F5344CB8AC3E}">
+        <p14:creationId xmlns:p14="http://schemas.microsoft.com/office/powerpoint/2010/main" val="1186108255"/>
+      </p:ext>
+    </p:extLst>
+  </p:cSld>
+  <p:clrMapOvr>
+    <a:masterClrMapping/>
+  </p:clrMapOvr>
+</p:sld>
+</file>
+
+<file path=ppt/slides/slide22.xml><?xml version="1.0" encoding="utf-8"?>
+<p:sld xmlns:a="http://schemas.openxmlformats.org/drawingml/2006/main" xmlns:r="http://schemas.openxmlformats.org/officeDocument/2006/relationships" xmlns:p="http://schemas.openxmlformats.org/presentationml/2006/main">
+  <p:cSld>
+    <p:spTree>
+      <p:nvGrpSpPr>
+        <p:cNvPr id="1" name=""/>
+        <p:cNvGrpSpPr/>
+        <p:nvPr/>
+      </p:nvGrpSpPr>
+      <p:grpSpPr>
+        <a:xfrm>
+          <a:off x="0" y="0"/>
+          <a:ext cx="0" cy="0"/>
+          <a:chOff x="0" y="0"/>
+          <a:chExt cx="0" cy="0"/>
+        </a:xfrm>
+      </p:grpSpPr>
+      <p:sp>
+        <p:nvSpPr>
+          <p:cNvPr id="2" name="Title 1">
+            <a:extLst>
+              <a:ext uri="{FF2B5EF4-FFF2-40B4-BE49-F238E27FC236}">
+                <a16:creationId xmlns:a16="http://schemas.microsoft.com/office/drawing/2014/main" id="{75BAC652-5B40-B274-F246-6F66640DD4EF}"/>
+              </a:ext>
+            </a:extLst>
+          </p:cNvPr>
+          <p:cNvSpPr>
+            <a:spLocks noGrp="1"/>
+          </p:cNvSpPr>
+          <p:nvPr>
+            <p:ph type="title"/>
+          </p:nvPr>
+        </p:nvSpPr>
+        <p:spPr/>
+        <p:txBody>
+          <a:bodyPr/>
+          <a:lstStyle/>
+          <a:p>
+            <a:endParaRPr lang="en-US"/>
+          </a:p>
+        </p:txBody>
+      </p:sp>
+      <p:sp>
+        <p:nvSpPr>
+          <p:cNvPr id="3" name="Content Placeholder 2">
+            <a:extLst>
+              <a:ext uri="{FF2B5EF4-FFF2-40B4-BE49-F238E27FC236}">
+                <a16:creationId xmlns:a16="http://schemas.microsoft.com/office/drawing/2014/main" id="{14736978-8D7B-63B2-D3DE-AD4510C6D130}"/>
+              </a:ext>
+            </a:extLst>
+          </p:cNvPr>
+          <p:cNvSpPr>
+            <a:spLocks noGrp="1"/>
+          </p:cNvSpPr>
+          <p:nvPr>
+            <p:ph idx="1"/>
+          </p:nvPr>
+        </p:nvSpPr>
+        <p:spPr/>
+        <p:txBody>
+          <a:bodyPr/>
+          <a:lstStyle/>
+          <a:p>
+            <a:endParaRPr lang="en-US"/>
+          </a:p>
+        </p:txBody>
+      </p:sp>
+      <p:pic>
+        <p:nvPicPr>
+          <p:cNvPr id="5" name="Picture 4">
+            <a:extLst>
+              <a:ext uri="{FF2B5EF4-FFF2-40B4-BE49-F238E27FC236}">
+                <a16:creationId xmlns:a16="http://schemas.microsoft.com/office/drawing/2014/main" id="{C5B8155E-016F-B0AC-D13C-D51E11E44D53}"/>
+              </a:ext>
+            </a:extLst>
+          </p:cNvPr>
+          <p:cNvPicPr>
+            <a:picLocks noChangeAspect="1"/>
+          </p:cNvPicPr>
+          <p:nvPr/>
+        </p:nvPicPr>
+        <p:blipFill>
+          <a:blip r:embed="rId2"/>
+          <a:stretch>
+            <a:fillRect/>
+          </a:stretch>
+        </p:blipFill>
+        <p:spPr>
+          <a:xfrm>
+            <a:off x="1890712" y="614362"/>
+            <a:ext cx="8410575" cy="5629275"/>
+          </a:xfrm>
+          <a:prstGeom prst="rect">
+            <a:avLst/>
+          </a:prstGeom>
+        </p:spPr>
+      </p:pic>
+    </p:spTree>
+    <p:extLst>
+      <p:ext uri="{BB962C8B-B14F-4D97-AF65-F5344CB8AC3E}">
+        <p14:creationId xmlns:p14="http://schemas.microsoft.com/office/powerpoint/2010/main" val="2047275557"/>
+      </p:ext>
+    </p:extLst>
+  </p:cSld>
+  <p:clrMapOvr>
+    <a:masterClrMapping/>
+  </p:clrMapOvr>
+</p:sld>
+</file>
+
+<file path=ppt/slides/slide23.xml><?xml version="1.0" encoding="utf-8"?>
+<p:sld xmlns:a="http://schemas.openxmlformats.org/drawingml/2006/main" xmlns:r="http://schemas.openxmlformats.org/officeDocument/2006/relationships" xmlns:p="http://schemas.openxmlformats.org/presentationml/2006/main">
+  <p:cSld>
+    <p:spTree>
+      <p:nvGrpSpPr>
+        <p:cNvPr id="1" name=""/>
+        <p:cNvGrpSpPr/>
+        <p:nvPr/>
+      </p:nvGrpSpPr>
+      <p:grpSpPr>
+        <a:xfrm>
+          <a:off x="0" y="0"/>
+          <a:ext cx="0" cy="0"/>
+          <a:chOff x="0" y="0"/>
+          <a:chExt cx="0" cy="0"/>
+        </a:xfrm>
+      </p:grpSpPr>
+      <p:sp>
+        <p:nvSpPr>
+          <p:cNvPr id="2" name="Title 1">
+            <a:extLst>
+              <a:ext uri="{FF2B5EF4-FFF2-40B4-BE49-F238E27FC236}">
+                <a16:creationId xmlns:a16="http://schemas.microsoft.com/office/drawing/2014/main" id="{1B011B56-9DE8-7761-E909-4A0205E50B27}"/>
+              </a:ext>
+            </a:extLst>
+          </p:cNvPr>
+          <p:cNvSpPr>
+            <a:spLocks noGrp="1"/>
+          </p:cNvSpPr>
+          <p:nvPr>
+            <p:ph type="title"/>
+          </p:nvPr>
+        </p:nvSpPr>
+        <p:spPr/>
+        <p:txBody>
+          <a:bodyPr/>
+          <a:lstStyle/>
+          <a:p>
+            <a:endParaRPr lang="en-US"/>
+          </a:p>
+        </p:txBody>
+      </p:sp>
+      <p:sp>
+        <p:nvSpPr>
+          <p:cNvPr id="3" name="Content Placeholder 2">
+            <a:extLst>
+              <a:ext uri="{FF2B5EF4-FFF2-40B4-BE49-F238E27FC236}">
+                <a16:creationId xmlns:a16="http://schemas.microsoft.com/office/drawing/2014/main" id="{2F183027-F366-3E69-F0A6-5EF247317126}"/>
+              </a:ext>
+            </a:extLst>
+          </p:cNvPr>
+          <p:cNvSpPr>
+            <a:spLocks noGrp="1"/>
+          </p:cNvSpPr>
+          <p:nvPr>
+            <p:ph idx="1"/>
+          </p:nvPr>
+        </p:nvSpPr>
+        <p:spPr/>
+        <p:txBody>
+          <a:bodyPr/>
+          <a:lstStyle/>
+          <a:p>
+            <a:endParaRPr lang="en-US"/>
+          </a:p>
+        </p:txBody>
+      </p:sp>
+      <p:pic>
+        <p:nvPicPr>
+          <p:cNvPr id="5" name="Picture 4">
+            <a:extLst>
+              <a:ext uri="{FF2B5EF4-FFF2-40B4-BE49-F238E27FC236}">
+                <a16:creationId xmlns:a16="http://schemas.microsoft.com/office/drawing/2014/main" id="{FFB82144-DEEE-27A5-4591-A56B936896E5}"/>
+              </a:ext>
+            </a:extLst>
+          </p:cNvPr>
+          <p:cNvPicPr>
+            <a:picLocks noChangeAspect="1"/>
+          </p:cNvPicPr>
+          <p:nvPr/>
+        </p:nvPicPr>
+        <p:blipFill>
+          <a:blip r:embed="rId2"/>
+          <a:stretch>
+            <a:fillRect/>
+          </a:stretch>
+        </p:blipFill>
+        <p:spPr>
+          <a:xfrm>
+            <a:off x="2811018" y="0"/>
+            <a:ext cx="6569964" cy="6858000"/>
+          </a:xfrm>
+          <a:prstGeom prst="rect">
+            <a:avLst/>
+          </a:prstGeom>
+        </p:spPr>
+      </p:pic>
+    </p:spTree>
+    <p:extLst>
+      <p:ext uri="{BB962C8B-B14F-4D97-AF65-F5344CB8AC3E}">
+        <p14:creationId xmlns:p14="http://schemas.microsoft.com/office/powerpoint/2010/main" val="1105672825"/>
+      </p:ext>
+    </p:extLst>
+  </p:cSld>
+  <p:clrMapOvr>
+    <a:masterClrMapping/>
+  </p:clrMapOvr>
+</p:sld>
+</file>
+
+<file path=ppt/slides/slide24.xml><?xml version="1.0" encoding="utf-8"?>
+<p:sld xmlns:a="http://schemas.openxmlformats.org/drawingml/2006/main" xmlns:r="http://schemas.openxmlformats.org/officeDocument/2006/relationships" xmlns:p="http://schemas.openxmlformats.org/presentationml/2006/main">
+  <p:cSld>
+    <p:spTree>
+      <p:nvGrpSpPr>
+        <p:cNvPr id="1" name=""/>
+        <p:cNvGrpSpPr/>
+        <p:nvPr/>
+      </p:nvGrpSpPr>
+      <p:grpSpPr>
+        <a:xfrm>
+          <a:off x="0" y="0"/>
+          <a:ext cx="0" cy="0"/>
+          <a:chOff x="0" y="0"/>
+          <a:chExt cx="0" cy="0"/>
+        </a:xfrm>
+      </p:grpSpPr>
+      <p:sp>
+        <p:nvSpPr>
+          <p:cNvPr id="2" name="Title 1">
+            <a:extLst>
+              <a:ext uri="{FF2B5EF4-FFF2-40B4-BE49-F238E27FC236}">
+                <a16:creationId xmlns:a16="http://schemas.microsoft.com/office/drawing/2014/main" id="{A3322957-BA25-870A-DB7F-919CCCEA37F6}"/>
+              </a:ext>
+            </a:extLst>
+          </p:cNvPr>
+          <p:cNvSpPr>
+            <a:spLocks noGrp="1"/>
+          </p:cNvSpPr>
+          <p:nvPr>
+            <p:ph type="title"/>
+          </p:nvPr>
+        </p:nvSpPr>
+        <p:spPr/>
+        <p:txBody>
+          <a:bodyPr/>
+          <a:lstStyle/>
+          <a:p>
+            <a:endParaRPr lang="en-US"/>
+          </a:p>
+        </p:txBody>
+      </p:sp>
+      <p:sp>
+        <p:nvSpPr>
+          <p:cNvPr id="3" name="Content Placeholder 2">
+            <a:extLst>
+              <a:ext uri="{FF2B5EF4-FFF2-40B4-BE49-F238E27FC236}">
+                <a16:creationId xmlns:a16="http://schemas.microsoft.com/office/drawing/2014/main" id="{A716BB37-DFF5-98F3-8B1B-0760798A2DB9}"/>
+              </a:ext>
+            </a:extLst>
+          </p:cNvPr>
+          <p:cNvSpPr>
+            <a:spLocks noGrp="1"/>
+          </p:cNvSpPr>
+          <p:nvPr>
+            <p:ph idx="1"/>
+          </p:nvPr>
+        </p:nvSpPr>
+        <p:spPr/>
+        <p:txBody>
+          <a:bodyPr/>
+          <a:lstStyle/>
+          <a:p>
+            <a:endParaRPr lang="en-US"/>
+          </a:p>
+        </p:txBody>
+      </p:sp>
+      <p:pic>
+        <p:nvPicPr>
+          <p:cNvPr id="5" name="Picture 4">
+            <a:extLst>
+              <a:ext uri="{FF2B5EF4-FFF2-40B4-BE49-F238E27FC236}">
+                <a16:creationId xmlns:a16="http://schemas.microsoft.com/office/drawing/2014/main" id="{939DD9A7-7E5A-2651-A738-028542BA62AE}"/>
+              </a:ext>
+            </a:extLst>
+          </p:cNvPr>
+          <p:cNvPicPr>
+            <a:picLocks noChangeAspect="1"/>
+          </p:cNvPicPr>
+          <p:nvPr/>
+        </p:nvPicPr>
+        <p:blipFill>
+          <a:blip r:embed="rId2"/>
+          <a:stretch>
+            <a:fillRect/>
+          </a:stretch>
+        </p:blipFill>
+        <p:spPr>
+          <a:xfrm>
+            <a:off x="2811018" y="0"/>
+            <a:ext cx="6569964" cy="6858000"/>
+          </a:xfrm>
+          <a:prstGeom prst="rect">
+            <a:avLst/>
+          </a:prstGeom>
+        </p:spPr>
+      </p:pic>
+    </p:spTree>
+    <p:extLst>
+      <p:ext uri="{BB962C8B-B14F-4D97-AF65-F5344CB8AC3E}">
+        <p14:creationId xmlns:p14="http://schemas.microsoft.com/office/powerpoint/2010/main" val="4165770529"/>
+      </p:ext>
+    </p:extLst>
+  </p:cSld>
+  <p:clrMapOvr>
+    <a:masterClrMapping/>
+  </p:clrMapOvr>
+</p:sld>
+</file>
+
+<file path=ppt/slides/slide25.xml><?xml version="1.0" encoding="utf-8"?>
+<p:sld xmlns:a="http://schemas.openxmlformats.org/drawingml/2006/main" xmlns:r="http://schemas.openxmlformats.org/officeDocument/2006/relationships" xmlns:p="http://schemas.openxmlformats.org/presentationml/2006/main">
+  <p:cSld>
+    <p:spTree>
+      <p:nvGrpSpPr>
+        <p:cNvPr id="1" name=""/>
+        <p:cNvGrpSpPr/>
+        <p:nvPr/>
+      </p:nvGrpSpPr>
+      <p:grpSpPr>
+        <a:xfrm>
+          <a:off x="0" y="0"/>
+          <a:ext cx="0" cy="0"/>
+          <a:chOff x="0" y="0"/>
+          <a:chExt cx="0" cy="0"/>
+        </a:xfrm>
+      </p:grpSpPr>
+      <p:sp>
+        <p:nvSpPr>
+          <p:cNvPr id="2" name="Title 1">
+            <a:extLst>
+              <a:ext uri="{FF2B5EF4-FFF2-40B4-BE49-F238E27FC236}">
+                <a16:creationId xmlns:a16="http://schemas.microsoft.com/office/drawing/2014/main" id="{870EAD8F-A5E0-E791-BE7A-12ED249B55B8}"/>
+              </a:ext>
+            </a:extLst>
+          </p:cNvPr>
+          <p:cNvSpPr>
+            <a:spLocks noGrp="1"/>
+          </p:cNvSpPr>
+          <p:nvPr>
+            <p:ph type="title"/>
+          </p:nvPr>
+        </p:nvSpPr>
+        <p:spPr/>
+        <p:txBody>
+          <a:bodyPr/>
+          <a:lstStyle/>
+          <a:p>
+            <a:endParaRPr lang="en-US"/>
+          </a:p>
+        </p:txBody>
+      </p:sp>
+      <p:sp>
+        <p:nvSpPr>
+          <p:cNvPr id="3" name="Content Placeholder 2">
+            <a:extLst>
+              <a:ext uri="{FF2B5EF4-FFF2-40B4-BE49-F238E27FC236}">
+                <a16:creationId xmlns:a16="http://schemas.microsoft.com/office/drawing/2014/main" id="{217786A2-9177-4ED7-4197-F0D1CAD7DC17}"/>
+              </a:ext>
+            </a:extLst>
+          </p:cNvPr>
+          <p:cNvSpPr>
+            <a:spLocks noGrp="1"/>
+          </p:cNvSpPr>
+          <p:nvPr>
+            <p:ph idx="1"/>
+          </p:nvPr>
+        </p:nvSpPr>
+        <p:spPr/>
+        <p:txBody>
+          <a:bodyPr/>
+          <a:lstStyle/>
+          <a:p>
+            <a:endParaRPr lang="en-US"/>
+          </a:p>
+        </p:txBody>
+      </p:sp>
+      <p:pic>
+        <p:nvPicPr>
+          <p:cNvPr id="7" name="Picture 6">
+            <a:extLst>
+              <a:ext uri="{FF2B5EF4-FFF2-40B4-BE49-F238E27FC236}">
+                <a16:creationId xmlns:a16="http://schemas.microsoft.com/office/drawing/2014/main" id="{C72F0394-3D32-DD07-6C00-8DAC7D2922B0}"/>
+              </a:ext>
+            </a:extLst>
+          </p:cNvPr>
+          <p:cNvPicPr>
+            <a:picLocks noChangeAspect="1"/>
+          </p:cNvPicPr>
+          <p:nvPr/>
+        </p:nvPicPr>
+        <p:blipFill>
+          <a:blip r:embed="rId2"/>
+          <a:stretch>
+            <a:fillRect/>
+          </a:stretch>
+        </p:blipFill>
+        <p:spPr>
+          <a:xfrm>
+            <a:off x="2811018" y="0"/>
+            <a:ext cx="6569964" cy="6858000"/>
+          </a:xfrm>
+          <a:prstGeom prst="rect">
+            <a:avLst/>
+          </a:prstGeom>
+        </p:spPr>
+      </p:pic>
+    </p:spTree>
+    <p:extLst>
+      <p:ext uri="{BB962C8B-B14F-4D97-AF65-F5344CB8AC3E}">
+        <p14:creationId xmlns:p14="http://schemas.microsoft.com/office/powerpoint/2010/main" val="3384598973"/>
+      </p:ext>
+    </p:extLst>
+  </p:cSld>
+  <p:clrMapOvr>
+    <a:masterClrMapping/>
+  </p:clrMapOvr>
+</p:sld>
+</file>
+
+<file path=ppt/slides/slide26.xml><?xml version="1.0" encoding="utf-8"?>
+<p:sld xmlns:a="http://schemas.openxmlformats.org/drawingml/2006/main" xmlns:r="http://schemas.openxmlformats.org/officeDocument/2006/relationships" xmlns:p="http://schemas.openxmlformats.org/presentationml/2006/main">
+  <p:cSld>
+    <p:spTree>
+      <p:nvGrpSpPr>
+        <p:cNvPr id="1" name=""/>
+        <p:cNvGrpSpPr/>
+        <p:nvPr/>
+      </p:nvGrpSpPr>
+      <p:grpSpPr>
+        <a:xfrm>
+          <a:off x="0" y="0"/>
+          <a:ext cx="0" cy="0"/>
+          <a:chOff x="0" y="0"/>
+          <a:chExt cx="0" cy="0"/>
+        </a:xfrm>
+      </p:grpSpPr>
+      <p:sp>
+        <p:nvSpPr>
+          <p:cNvPr id="2" name="Title 1">
+            <a:extLst>
+              <a:ext uri="{FF2B5EF4-FFF2-40B4-BE49-F238E27FC236}">
+                <a16:creationId xmlns:a16="http://schemas.microsoft.com/office/drawing/2014/main" id="{201060CC-6580-8544-6521-15B86C26299D}"/>
+              </a:ext>
+            </a:extLst>
+          </p:cNvPr>
+          <p:cNvSpPr>
+            <a:spLocks noGrp="1"/>
+          </p:cNvSpPr>
+          <p:nvPr>
+            <p:ph type="title"/>
+          </p:nvPr>
+        </p:nvSpPr>
+        <p:spPr/>
+        <p:txBody>
+          <a:bodyPr/>
+          <a:lstStyle/>
+          <a:p>
+            <a:endParaRPr lang="en-US"/>
+          </a:p>
+        </p:txBody>
+      </p:sp>
+      <p:sp>
+        <p:nvSpPr>
+          <p:cNvPr id="3" name="Content Placeholder 2">
+            <a:extLst>
+              <a:ext uri="{FF2B5EF4-FFF2-40B4-BE49-F238E27FC236}">
+                <a16:creationId xmlns:a16="http://schemas.microsoft.com/office/drawing/2014/main" id="{B9D18044-7AC2-5377-15C7-E07F93CA918F}"/>
+              </a:ext>
+            </a:extLst>
+          </p:cNvPr>
+          <p:cNvSpPr>
+            <a:spLocks noGrp="1"/>
+          </p:cNvSpPr>
+          <p:nvPr>
+            <p:ph idx="1"/>
+          </p:nvPr>
+        </p:nvSpPr>
+        <p:spPr/>
+        <p:txBody>
+          <a:bodyPr/>
+          <a:lstStyle/>
+          <a:p>
+            <a:endParaRPr lang="en-US"/>
+          </a:p>
+        </p:txBody>
+      </p:sp>
+      <p:pic>
+        <p:nvPicPr>
+          <p:cNvPr id="5" name="Picture 4">
+            <a:extLst>
+              <a:ext uri="{FF2B5EF4-FFF2-40B4-BE49-F238E27FC236}">
+                <a16:creationId xmlns:a16="http://schemas.microsoft.com/office/drawing/2014/main" id="{D2C016DF-482A-8BD1-BE49-ADA3BA8D4280}"/>
+              </a:ext>
+            </a:extLst>
+          </p:cNvPr>
+          <p:cNvPicPr>
+            <a:picLocks noChangeAspect="1"/>
+          </p:cNvPicPr>
+          <p:nvPr/>
+        </p:nvPicPr>
+        <p:blipFill>
+          <a:blip r:embed="rId2"/>
+          <a:stretch>
+            <a:fillRect/>
+          </a:stretch>
+        </p:blipFill>
+        <p:spPr>
+          <a:xfrm>
+            <a:off x="2811018" y="0"/>
+            <a:ext cx="6569964" cy="6858000"/>
+          </a:xfrm>
+          <a:prstGeom prst="rect">
+            <a:avLst/>
+          </a:prstGeom>
+        </p:spPr>
+      </p:pic>
+    </p:spTree>
+    <p:extLst>
+      <p:ext uri="{BB962C8B-B14F-4D97-AF65-F5344CB8AC3E}">
+        <p14:creationId xmlns:p14="http://schemas.microsoft.com/office/powerpoint/2010/main" val="3443751830"/>
+      </p:ext>
+    </p:extLst>
+  </p:cSld>
+  <p:clrMapOvr>
+    <a:masterClrMapping/>
+  </p:clrMapOvr>
+</p:sld>
+</file>
+
+<file path=ppt/slides/slide27.xml><?xml version="1.0" encoding="utf-8"?>
+<p:sld xmlns:a="http://schemas.openxmlformats.org/drawingml/2006/main" xmlns:r="http://schemas.openxmlformats.org/officeDocument/2006/relationships" xmlns:p="http://schemas.openxmlformats.org/presentationml/2006/main">
+  <p:cSld>
+    <p:spTree>
+      <p:nvGrpSpPr>
+        <p:cNvPr id="1" name=""/>
+        <p:cNvGrpSpPr/>
+        <p:nvPr/>
+      </p:nvGrpSpPr>
+      <p:grpSpPr>
+        <a:xfrm>
+          <a:off x="0" y="0"/>
+          <a:ext cx="0" cy="0"/>
+          <a:chOff x="0" y="0"/>
+          <a:chExt cx="0" cy="0"/>
+        </a:xfrm>
+      </p:grpSpPr>
+      <p:sp>
+        <p:nvSpPr>
+          <p:cNvPr id="2" name="Title 1">
+            <a:extLst>
+              <a:ext uri="{FF2B5EF4-FFF2-40B4-BE49-F238E27FC236}">
+                <a16:creationId xmlns:a16="http://schemas.microsoft.com/office/drawing/2014/main" id="{EF566A12-6064-FAE6-BF3A-EA0EE52F4F23}"/>
+              </a:ext>
+            </a:extLst>
+          </p:cNvPr>
+          <p:cNvSpPr>
+            <a:spLocks noGrp="1"/>
+          </p:cNvSpPr>
+          <p:nvPr>
+            <p:ph type="title"/>
+          </p:nvPr>
+        </p:nvSpPr>
+        <p:spPr/>
+        <p:txBody>
+          <a:bodyPr/>
+          <a:lstStyle/>
+          <a:p>
+            <a:endParaRPr lang="en-US"/>
+          </a:p>
+        </p:txBody>
+      </p:sp>
+      <p:sp>
+        <p:nvSpPr>
+          <p:cNvPr id="3" name="Content Placeholder 2">
+            <a:extLst>
+              <a:ext uri="{FF2B5EF4-FFF2-40B4-BE49-F238E27FC236}">
+                <a16:creationId xmlns:a16="http://schemas.microsoft.com/office/drawing/2014/main" id="{D797BA6C-B1CF-383A-AFEC-93800E7776D0}"/>
+              </a:ext>
+            </a:extLst>
+          </p:cNvPr>
+          <p:cNvSpPr>
+            <a:spLocks noGrp="1"/>
+          </p:cNvSpPr>
+          <p:nvPr>
+            <p:ph idx="1"/>
+          </p:nvPr>
+        </p:nvSpPr>
+        <p:spPr/>
+        <p:txBody>
+          <a:bodyPr/>
+          <a:lstStyle/>
+          <a:p>
+            <a:endParaRPr lang="en-US"/>
+          </a:p>
+        </p:txBody>
+      </p:sp>
+      <p:pic>
+        <p:nvPicPr>
+          <p:cNvPr id="5" name="Picture 4">
+            <a:extLst>
+              <a:ext uri="{FF2B5EF4-FFF2-40B4-BE49-F238E27FC236}">
+                <a16:creationId xmlns:a16="http://schemas.microsoft.com/office/drawing/2014/main" id="{E983FB14-C514-3AB3-4107-D355A46005F2}"/>
+              </a:ext>
+            </a:extLst>
+          </p:cNvPr>
+          <p:cNvPicPr>
+            <a:picLocks noChangeAspect="1"/>
+          </p:cNvPicPr>
+          <p:nvPr/>
+        </p:nvPicPr>
+        <p:blipFill>
+          <a:blip r:embed="rId2"/>
+          <a:stretch>
+            <a:fillRect/>
+          </a:stretch>
+        </p:blipFill>
+        <p:spPr>
+          <a:xfrm>
+            <a:off x="0" y="225425"/>
+            <a:ext cx="12192000" cy="6407150"/>
+          </a:xfrm>
+          <a:prstGeom prst="rect">
+            <a:avLst/>
+          </a:prstGeom>
+        </p:spPr>
+      </p:pic>
+    </p:spTree>
+    <p:extLst>
+      <p:ext uri="{BB962C8B-B14F-4D97-AF65-F5344CB8AC3E}">
+        <p14:creationId xmlns:p14="http://schemas.microsoft.com/office/powerpoint/2010/main" val="2716879471"/>
+      </p:ext>
+    </p:extLst>
+  </p:cSld>
+  <p:clrMapOvr>
+    <a:masterClrMapping/>
+  </p:clrMapOvr>
+</p:sld>
+</file>
+
+<file path=ppt/slides/slide28.xml><?xml version="1.0" encoding="utf-8"?>
+<p:sld xmlns:a="http://schemas.openxmlformats.org/drawingml/2006/main" xmlns:r="http://schemas.openxmlformats.org/officeDocument/2006/relationships" xmlns:p="http://schemas.openxmlformats.org/presentationml/2006/main">
+  <p:cSld>
+    <p:spTree>
+      <p:nvGrpSpPr>
+        <p:cNvPr id="1" name=""/>
+        <p:cNvGrpSpPr/>
+        <p:nvPr/>
+      </p:nvGrpSpPr>
+      <p:grpSpPr>
+        <a:xfrm>
+          <a:off x="0" y="0"/>
+          <a:ext cx="0" cy="0"/>
+          <a:chOff x="0" y="0"/>
+          <a:chExt cx="0" cy="0"/>
+        </a:xfrm>
+      </p:grpSpPr>
+      <p:sp>
+        <p:nvSpPr>
+          <p:cNvPr id="2" name="Title 1">
+            <a:extLst>
+              <a:ext uri="{FF2B5EF4-FFF2-40B4-BE49-F238E27FC236}">
                 <a16:creationId xmlns:a16="http://schemas.microsoft.com/office/drawing/2014/main" id="{5B5204AC-FB7D-0970-F42A-67583A6AFFB6}"/>
               </a:ext>
             </a:extLst>
@@ -5952,7 +6859,7 @@
 </p:sld>
 </file>
 
-<file path=ppt/slides/slide21.xml><?xml version="1.0" encoding="utf-8"?>
+<file path=ppt/slides/slide29.xml><?xml version="1.0" encoding="utf-8"?>
 <p:sld xmlns:a="http://schemas.openxmlformats.org/drawingml/2006/main" xmlns:r="http://schemas.openxmlformats.org/officeDocument/2006/relationships" xmlns:p="http://schemas.openxmlformats.org/presentationml/2006/main">
   <p:cSld>
     <p:spTree>
@@ -6062,7 +6969,159 @@
 </p:sld>
 </file>
 
-<file path=ppt/slides/slide22.xml><?xml version="1.0" encoding="utf-8"?>
+<file path=ppt/slides/slide3.xml><?xml version="1.0" encoding="utf-8"?>
+<p:sld xmlns:a="http://schemas.openxmlformats.org/drawingml/2006/main" xmlns:r="http://schemas.openxmlformats.org/officeDocument/2006/relationships" xmlns:p="http://schemas.openxmlformats.org/presentationml/2006/main">
+  <p:cSld>
+    <p:spTree>
+      <p:nvGrpSpPr>
+        <p:cNvPr id="1" name="">
+          <a:extLst>
+            <a:ext uri="{FF2B5EF4-FFF2-40B4-BE49-F238E27FC236}">
+              <a16:creationId xmlns:a16="http://schemas.microsoft.com/office/drawing/2014/main" id="{57D9EE95-29B0-444E-862E-C8EBBB46B271}"/>
+            </a:ext>
+          </a:extLst>
+        </p:cNvPr>
+        <p:cNvGrpSpPr/>
+        <p:nvPr/>
+      </p:nvGrpSpPr>
+      <p:grpSpPr>
+        <a:xfrm>
+          <a:off x="0" y="0"/>
+          <a:ext cx="0" cy="0"/>
+          <a:chOff x="0" y="0"/>
+          <a:chExt cx="0" cy="0"/>
+        </a:xfrm>
+      </p:grpSpPr>
+      <p:sp>
+        <p:nvSpPr>
+          <p:cNvPr id="2" name="Title 1">
+            <a:extLst>
+              <a:ext uri="{FF2B5EF4-FFF2-40B4-BE49-F238E27FC236}">
+                <a16:creationId xmlns:a16="http://schemas.microsoft.com/office/drawing/2014/main" id="{5A38A37B-F21C-0AC6-B0A5-6E00BCBF6BD7}"/>
+              </a:ext>
+            </a:extLst>
+          </p:cNvPr>
+          <p:cNvSpPr>
+            <a:spLocks noGrp="1"/>
+          </p:cNvSpPr>
+          <p:nvPr>
+            <p:ph type="title"/>
+          </p:nvPr>
+        </p:nvSpPr>
+        <p:spPr/>
+        <p:txBody>
+          <a:bodyPr/>
+          <a:lstStyle/>
+          <a:p>
+            <a:r>
+              <a:rPr lang="en-US" dirty="0"/>
+              <a:t>Env data plots</a:t>
+            </a:r>
+          </a:p>
+        </p:txBody>
+      </p:sp>
+      <p:sp>
+        <p:nvSpPr>
+          <p:cNvPr id="3" name="Content Placeholder 2">
+            <a:extLst>
+              <a:ext uri="{FF2B5EF4-FFF2-40B4-BE49-F238E27FC236}">
+                <a16:creationId xmlns:a16="http://schemas.microsoft.com/office/drawing/2014/main" id="{C590EC79-74F3-B72A-D66F-4C024AA7B044}"/>
+              </a:ext>
+            </a:extLst>
+          </p:cNvPr>
+          <p:cNvSpPr>
+            <a:spLocks noGrp="1"/>
+          </p:cNvSpPr>
+          <p:nvPr>
+            <p:ph idx="1"/>
+          </p:nvPr>
+        </p:nvSpPr>
+        <p:spPr/>
+        <p:txBody>
+          <a:bodyPr/>
+          <a:lstStyle/>
+          <a:p>
+            <a:r>
+              <a:rPr lang="en-US" dirty="0"/>
+              <a:t>PDO and NPGO</a:t>
+            </a:r>
+          </a:p>
+        </p:txBody>
+      </p:sp>
+      <p:pic>
+        <p:nvPicPr>
+          <p:cNvPr id="6" name="Picture 5">
+            <a:extLst>
+              <a:ext uri="{FF2B5EF4-FFF2-40B4-BE49-F238E27FC236}">
+                <a16:creationId xmlns:a16="http://schemas.microsoft.com/office/drawing/2014/main" id="{A7C554CA-1D2A-2FEB-F754-E7533274B0F3}"/>
+              </a:ext>
+            </a:extLst>
+          </p:cNvPr>
+          <p:cNvPicPr>
+            <a:picLocks noChangeAspect="1"/>
+          </p:cNvPicPr>
+          <p:nvPr/>
+        </p:nvPicPr>
+        <p:blipFill>
+          <a:blip r:embed="rId2"/>
+          <a:stretch>
+            <a:fillRect/>
+          </a:stretch>
+        </p:blipFill>
+        <p:spPr>
+          <a:xfrm>
+            <a:off x="266020" y="2844799"/>
+            <a:ext cx="5720956" cy="3648076"/>
+          </a:xfrm>
+          <a:prstGeom prst="rect">
+            <a:avLst/>
+          </a:prstGeom>
+        </p:spPr>
+      </p:pic>
+      <p:pic>
+        <p:nvPicPr>
+          <p:cNvPr id="9" name="Picture 8">
+            <a:extLst>
+              <a:ext uri="{FF2B5EF4-FFF2-40B4-BE49-F238E27FC236}">
+                <a16:creationId xmlns:a16="http://schemas.microsoft.com/office/drawing/2014/main" id="{71B2C31F-292E-17AE-72DF-3499C1211FDD}"/>
+              </a:ext>
+            </a:extLst>
+          </p:cNvPr>
+          <p:cNvPicPr>
+            <a:picLocks noChangeAspect="1"/>
+          </p:cNvPicPr>
+          <p:nvPr/>
+        </p:nvPicPr>
+        <p:blipFill>
+          <a:blip r:embed="rId3"/>
+          <a:stretch>
+            <a:fillRect/>
+          </a:stretch>
+        </p:blipFill>
+        <p:spPr>
+          <a:xfrm>
+            <a:off x="6205026" y="2844799"/>
+            <a:ext cx="5720956" cy="3648076"/>
+          </a:xfrm>
+          <a:prstGeom prst="rect">
+            <a:avLst/>
+          </a:prstGeom>
+        </p:spPr>
+      </p:pic>
+    </p:spTree>
+    <p:extLst>
+      <p:ext uri="{BB962C8B-B14F-4D97-AF65-F5344CB8AC3E}">
+        <p14:creationId xmlns:p14="http://schemas.microsoft.com/office/powerpoint/2010/main" val="1379679899"/>
+      </p:ext>
+    </p:extLst>
+  </p:cSld>
+  <p:clrMapOvr>
+    <a:masterClrMapping/>
+  </p:clrMapOvr>
+</p:sld>
+</file>
+
+<file path=ppt/slides/slide30.xml><?xml version="1.0" encoding="utf-8"?>
 <p:sld xmlns:a="http://schemas.openxmlformats.org/drawingml/2006/main" xmlns:r="http://schemas.openxmlformats.org/officeDocument/2006/relationships" xmlns:p="http://schemas.openxmlformats.org/presentationml/2006/main">
   <p:cSld>
     <p:spTree>
@@ -6228,7 +7287,7 @@
 </p:sld>
 </file>
 
-<file path=ppt/slides/slide23.xml><?xml version="1.0" encoding="utf-8"?>
+<file path=ppt/slides/slide31.xml><?xml version="1.0" encoding="utf-8"?>
 <p:sld xmlns:a="http://schemas.openxmlformats.org/drawingml/2006/main" xmlns:r="http://schemas.openxmlformats.org/officeDocument/2006/relationships" xmlns:p="http://schemas.openxmlformats.org/presentationml/2006/main">
   <p:cSld>
     <p:spTree>
@@ -6388,7 +7447,7 @@
 </p:sld>
 </file>
 
-<file path=ppt/slides/slide24.xml><?xml version="1.0" encoding="utf-8"?>
+<file path=ppt/slides/slide32.xml><?xml version="1.0" encoding="utf-8"?>
 <p:sld xmlns:a="http://schemas.openxmlformats.org/drawingml/2006/main" xmlns:r="http://schemas.openxmlformats.org/officeDocument/2006/relationships" xmlns:p="http://schemas.openxmlformats.org/presentationml/2006/main">
   <p:cSld>
     <p:spTree>
@@ -6426,7 +7485,10 @@
           <a:bodyPr/>
           <a:lstStyle/>
           <a:p>
-            <a:endParaRPr lang="en-US"/>
+            <a:r>
+              <a:rPr lang="en-US" dirty="0"/>
+              <a:t>Next steps</a:t>
+            </a:r>
           </a:p>
         </p:txBody>
       </p:sp>
@@ -6451,7 +7513,34 @@
           <a:bodyPr/>
           <a:lstStyle/>
           <a:p>
-            <a:endParaRPr lang="en-US"/>
+            <a:r>
+              <a:rPr lang="en-US" dirty="0"/>
+              <a:t>Okay to include all sources</a:t>
+            </a:r>
+          </a:p>
+          <a:p>
+            <a:r>
+              <a:rPr lang="en-US" dirty="0"/>
+              <a:t>Separate by sex</a:t>
+            </a:r>
+          </a:p>
+          <a:p>
+            <a:r>
+              <a:rPr lang="en-US" dirty="0"/>
+              <a:t>Timing of fishery – perhaps just use data in core survey/catch months</a:t>
+            </a:r>
+          </a:p>
+          <a:p>
+            <a:r>
+              <a:rPr lang="en-US" dirty="0"/>
+              <a:t>Think of how to combine weight at age and LW relationship and env variables</a:t>
+            </a:r>
+          </a:p>
+          <a:p>
+            <a:endParaRPr lang="en-US" dirty="0"/>
+          </a:p>
+          <a:p>
+            <a:endParaRPr lang="en-US" dirty="0"/>
           </a:p>
         </p:txBody>
       </p:sp>
@@ -6468,7 +7557,7 @@
 </p:sld>
 </file>
 
-<file path=ppt/slides/slide25.xml><?xml version="1.0" encoding="utf-8"?>
+<file path=ppt/slides/slide33.xml><?xml version="1.0" encoding="utf-8"?>
 <p:sld xmlns:a="http://schemas.openxmlformats.org/drawingml/2006/main" xmlns:r="http://schemas.openxmlformats.org/officeDocument/2006/relationships" xmlns:p="http://schemas.openxmlformats.org/presentationml/2006/main">
   <p:cSld>
     <p:spTree>
@@ -6506,7 +7595,10 @@
           <a:bodyPr/>
           <a:lstStyle/>
           <a:p>
-            <a:endParaRPr lang="en-US"/>
+            <a:r>
+              <a:rPr lang="en-US" dirty="0"/>
+              <a:t>Apr-Jun condition with same year seasonal indicators</a:t>
+            </a:r>
           </a:p>
         </p:txBody>
       </p:sp>
@@ -6531,7 +7623,7 @@
           <a:bodyPr/>
           <a:lstStyle/>
           <a:p>
-            <a:endParaRPr lang="en-US"/>
+            <a:endParaRPr lang="en-US" dirty="0"/>
           </a:p>
         </p:txBody>
       </p:sp>
@@ -6548,7 +7640,7 @@
 </p:sld>
 </file>
 
-<file path=ppt/slides/slide26.xml><?xml version="1.0" encoding="utf-8"?>
+<file path=ppt/slides/slide34.xml><?xml version="1.0" encoding="utf-8"?>
 <p:sld xmlns:a="http://schemas.openxmlformats.org/drawingml/2006/main" xmlns:r="http://schemas.openxmlformats.org/officeDocument/2006/relationships" xmlns:p="http://schemas.openxmlformats.org/presentationml/2006/main">
   <p:cSld>
     <p:spTree>
@@ -6570,7 +7662,7 @@
           <p:cNvPr id="2" name="Title 1">
             <a:extLst>
               <a:ext uri="{FF2B5EF4-FFF2-40B4-BE49-F238E27FC236}">
-                <a16:creationId xmlns:a16="http://schemas.microsoft.com/office/drawing/2014/main" id="{C0B608F8-BBCA-D4E4-04B8-D6FAF5965948}"/>
+                <a16:creationId xmlns:a16="http://schemas.microsoft.com/office/drawing/2014/main" id="{2D9E9978-5464-76B5-6999-2F5334A9AB86}"/>
               </a:ext>
             </a:extLst>
           </p:cNvPr>
@@ -6595,7 +7687,7 @@
           <p:cNvPr id="3" name="Content Placeholder 2">
             <a:extLst>
               <a:ext uri="{FF2B5EF4-FFF2-40B4-BE49-F238E27FC236}">
-                <a16:creationId xmlns:a16="http://schemas.microsoft.com/office/drawing/2014/main" id="{69CBC5E0-A2A5-68A6-C41E-630D4281CB74}"/>
+                <a16:creationId xmlns:a16="http://schemas.microsoft.com/office/drawing/2014/main" id="{5B7842F1-FC74-F530-263F-D5985D038A6E}"/>
               </a:ext>
             </a:extLst>
           </p:cNvPr>
@@ -6615,10 +7707,40 @@
           </a:p>
         </p:txBody>
       </p:sp>
+      <p:pic>
+        <p:nvPicPr>
+          <p:cNvPr id="5" name="Picture 4">
+            <a:extLst>
+              <a:ext uri="{FF2B5EF4-FFF2-40B4-BE49-F238E27FC236}">
+                <a16:creationId xmlns:a16="http://schemas.microsoft.com/office/drawing/2014/main" id="{26382773-FD56-7C67-861C-85EE559C2D7B}"/>
+              </a:ext>
+            </a:extLst>
+          </p:cNvPr>
+          <p:cNvPicPr>
+            <a:picLocks noChangeAspect="1"/>
+          </p:cNvPicPr>
+          <p:nvPr/>
+        </p:nvPicPr>
+        <p:blipFill>
+          <a:blip r:embed="rId2"/>
+          <a:stretch>
+            <a:fillRect/>
+          </a:stretch>
+        </p:blipFill>
+        <p:spPr>
+          <a:xfrm>
+            <a:off x="2262187" y="1281112"/>
+            <a:ext cx="7667625" cy="4295775"/>
+          </a:xfrm>
+          <a:prstGeom prst="rect">
+            <a:avLst/>
+          </a:prstGeom>
+        </p:spPr>
+      </p:pic>
     </p:spTree>
     <p:extLst>
       <p:ext uri="{BB962C8B-B14F-4D97-AF65-F5344CB8AC3E}">
-        <p14:creationId xmlns:p14="http://schemas.microsoft.com/office/powerpoint/2010/main" val="330511795"/>
+        <p14:creationId xmlns:p14="http://schemas.microsoft.com/office/powerpoint/2010/main" val="1680572366"/>
       </p:ext>
     </p:extLst>
   </p:cSld>
@@ -6628,7 +7750,7 @@
 </p:sld>
 </file>
 
-<file path=ppt/slides/slide27.xml><?xml version="1.0" encoding="utf-8"?>
+<file path=ppt/slides/slide35.xml><?xml version="1.0" encoding="utf-8"?>
 <p:sld xmlns:a="http://schemas.openxmlformats.org/drawingml/2006/main" xmlns:r="http://schemas.openxmlformats.org/officeDocument/2006/relationships" xmlns:p="http://schemas.openxmlformats.org/presentationml/2006/main">
   <p:cSld>
     <p:spTree>
@@ -6650,7 +7772,7 @@
           <p:cNvPr id="2" name="Title 1">
             <a:extLst>
               <a:ext uri="{FF2B5EF4-FFF2-40B4-BE49-F238E27FC236}">
-                <a16:creationId xmlns:a16="http://schemas.microsoft.com/office/drawing/2014/main" id="{346CF44C-CD1F-7FFD-1178-6E1FEF57E7A6}"/>
+                <a16:creationId xmlns:a16="http://schemas.microsoft.com/office/drawing/2014/main" id="{C0B608F8-BBCA-D4E4-04B8-D6FAF5965948}"/>
               </a:ext>
             </a:extLst>
           </p:cNvPr>
@@ -6675,7 +7797,7 @@
           <p:cNvPr id="3" name="Content Placeholder 2">
             <a:extLst>
               <a:ext uri="{FF2B5EF4-FFF2-40B4-BE49-F238E27FC236}">
-                <a16:creationId xmlns:a16="http://schemas.microsoft.com/office/drawing/2014/main" id="{0E5F1611-A3B8-8B48-4802-F7C9F91FCC3B}"/>
+                <a16:creationId xmlns:a16="http://schemas.microsoft.com/office/drawing/2014/main" id="{69CBC5E0-A2A5-68A6-C41E-630D4281CB74}"/>
               </a:ext>
             </a:extLst>
           </p:cNvPr>
@@ -6695,10 +7817,40 @@
           </a:p>
         </p:txBody>
       </p:sp>
+      <p:pic>
+        <p:nvPicPr>
+          <p:cNvPr id="5" name="Picture 4">
+            <a:extLst>
+              <a:ext uri="{FF2B5EF4-FFF2-40B4-BE49-F238E27FC236}">
+                <a16:creationId xmlns:a16="http://schemas.microsoft.com/office/drawing/2014/main" id="{47A90585-2C24-1325-0DEE-F204909D65F9}"/>
+              </a:ext>
+            </a:extLst>
+          </p:cNvPr>
+          <p:cNvPicPr>
+            <a:picLocks noChangeAspect="1"/>
+          </p:cNvPicPr>
+          <p:nvPr/>
+        </p:nvPicPr>
+        <p:blipFill>
+          <a:blip r:embed="rId2"/>
+          <a:stretch>
+            <a:fillRect/>
+          </a:stretch>
+        </p:blipFill>
+        <p:spPr>
+          <a:xfrm>
+            <a:off x="2262187" y="1281112"/>
+            <a:ext cx="7667625" cy="4295775"/>
+          </a:xfrm>
+          <a:prstGeom prst="rect">
+            <a:avLst/>
+          </a:prstGeom>
+        </p:spPr>
+      </p:pic>
     </p:spTree>
     <p:extLst>
       <p:ext uri="{BB962C8B-B14F-4D97-AF65-F5344CB8AC3E}">
-        <p14:creationId xmlns:p14="http://schemas.microsoft.com/office/powerpoint/2010/main" val="3630585970"/>
+        <p14:creationId xmlns:p14="http://schemas.microsoft.com/office/powerpoint/2010/main" val="330511795"/>
       </p:ext>
     </p:extLst>
   </p:cSld>
@@ -6708,7 +7860,7 @@
 </p:sld>
 </file>
 
-<file path=ppt/slides/slide28.xml><?xml version="1.0" encoding="utf-8"?>
+<file path=ppt/slides/slide36.xml><?xml version="1.0" encoding="utf-8"?>
 <p:sld xmlns:a="http://schemas.openxmlformats.org/drawingml/2006/main" xmlns:r="http://schemas.openxmlformats.org/officeDocument/2006/relationships" xmlns:p="http://schemas.openxmlformats.org/presentationml/2006/main">
   <p:cSld>
     <p:spTree>
@@ -6730,7 +7882,7 @@
           <p:cNvPr id="2" name="Title 1">
             <a:extLst>
               <a:ext uri="{FF2B5EF4-FFF2-40B4-BE49-F238E27FC236}">
-                <a16:creationId xmlns:a16="http://schemas.microsoft.com/office/drawing/2014/main" id="{BCBCD289-7E48-5C9A-EFA7-3D935118A830}"/>
+                <a16:creationId xmlns:a16="http://schemas.microsoft.com/office/drawing/2014/main" id="{346CF44C-CD1F-7FFD-1178-6E1FEF57E7A6}"/>
               </a:ext>
             </a:extLst>
           </p:cNvPr>
@@ -6755,7 +7907,7 @@
           <p:cNvPr id="3" name="Content Placeholder 2">
             <a:extLst>
               <a:ext uri="{FF2B5EF4-FFF2-40B4-BE49-F238E27FC236}">
-                <a16:creationId xmlns:a16="http://schemas.microsoft.com/office/drawing/2014/main" id="{308B9F9F-32C3-BF94-4533-D143344C9A6C}"/>
+                <a16:creationId xmlns:a16="http://schemas.microsoft.com/office/drawing/2014/main" id="{0E5F1611-A3B8-8B48-4802-F7C9F91FCC3B}"/>
               </a:ext>
             </a:extLst>
           </p:cNvPr>
@@ -6775,10 +7927,40 @@
           </a:p>
         </p:txBody>
       </p:sp>
+      <p:pic>
+        <p:nvPicPr>
+          <p:cNvPr id="5" name="Picture 4">
+            <a:extLst>
+              <a:ext uri="{FF2B5EF4-FFF2-40B4-BE49-F238E27FC236}">
+                <a16:creationId xmlns:a16="http://schemas.microsoft.com/office/drawing/2014/main" id="{A542F9F7-C939-5E3E-2F78-E5B4C15D453A}"/>
+              </a:ext>
+            </a:extLst>
+          </p:cNvPr>
+          <p:cNvPicPr>
+            <a:picLocks noChangeAspect="1"/>
+          </p:cNvPicPr>
+          <p:nvPr/>
+        </p:nvPicPr>
+        <p:blipFill>
+          <a:blip r:embed="rId2"/>
+          <a:stretch>
+            <a:fillRect/>
+          </a:stretch>
+        </p:blipFill>
+        <p:spPr>
+          <a:xfrm>
+            <a:off x="2474603" y="1825625"/>
+            <a:ext cx="7667625" cy="4295775"/>
+          </a:xfrm>
+          <a:prstGeom prst="rect">
+            <a:avLst/>
+          </a:prstGeom>
+        </p:spPr>
+      </p:pic>
     </p:spTree>
     <p:extLst>
       <p:ext uri="{BB962C8B-B14F-4D97-AF65-F5344CB8AC3E}">
-        <p14:creationId xmlns:p14="http://schemas.microsoft.com/office/powerpoint/2010/main" val="4291675638"/>
+        <p14:creationId xmlns:p14="http://schemas.microsoft.com/office/powerpoint/2010/main" val="3630585970"/>
       </p:ext>
     </p:extLst>
   </p:cSld>
@@ -6788,7 +7970,7 @@
 </p:sld>
 </file>
 
-<file path=ppt/slides/slide29.xml><?xml version="1.0" encoding="utf-8"?>
+<file path=ppt/slides/slide37.xml><?xml version="1.0" encoding="utf-8"?>
 <p:sld xmlns:a="http://schemas.openxmlformats.org/drawingml/2006/main" xmlns:r="http://schemas.openxmlformats.org/officeDocument/2006/relationships" xmlns:p="http://schemas.openxmlformats.org/presentationml/2006/main">
   <p:cSld>
     <p:spTree>
@@ -6810,7 +7992,7 @@
           <p:cNvPr id="2" name="Title 1">
             <a:extLst>
               <a:ext uri="{FF2B5EF4-FFF2-40B4-BE49-F238E27FC236}">
-                <a16:creationId xmlns:a16="http://schemas.microsoft.com/office/drawing/2014/main" id="{CFCD8A87-80DC-C180-D3F1-FFE60E84471A}"/>
+                <a16:creationId xmlns:a16="http://schemas.microsoft.com/office/drawing/2014/main" id="{BCBCD289-7E48-5C9A-EFA7-3D935118A830}"/>
               </a:ext>
             </a:extLst>
           </p:cNvPr>
@@ -6835,7 +8017,7 @@
           <p:cNvPr id="3" name="Content Placeholder 2">
             <a:extLst>
               <a:ext uri="{FF2B5EF4-FFF2-40B4-BE49-F238E27FC236}">
-                <a16:creationId xmlns:a16="http://schemas.microsoft.com/office/drawing/2014/main" id="{B2064F4C-0661-F4C6-1DB0-87302985C104}"/>
+                <a16:creationId xmlns:a16="http://schemas.microsoft.com/office/drawing/2014/main" id="{308B9F9F-32C3-BF94-4533-D143344C9A6C}"/>
               </a:ext>
             </a:extLst>
           </p:cNvPr>
@@ -6858,7 +8040,7 @@
     </p:spTree>
     <p:extLst>
       <p:ext uri="{BB962C8B-B14F-4D97-AF65-F5344CB8AC3E}">
-        <p14:creationId xmlns:p14="http://schemas.microsoft.com/office/powerpoint/2010/main" val="1264616559"/>
+        <p14:creationId xmlns:p14="http://schemas.microsoft.com/office/powerpoint/2010/main" val="4291675638"/>
       </p:ext>
     </p:extLst>
   </p:cSld>
@@ -6868,7 +8050,7 @@
 </p:sld>
 </file>
 
-<file path=ppt/slides/slide3.xml><?xml version="1.0" encoding="utf-8"?>
+<file path=ppt/slides/slide38.xml><?xml version="1.0" encoding="utf-8"?>
 <p:sld xmlns:a="http://schemas.openxmlformats.org/drawingml/2006/main" xmlns:r="http://schemas.openxmlformats.org/officeDocument/2006/relationships" xmlns:p="http://schemas.openxmlformats.org/presentationml/2006/main">
   <p:cSld>
     <p:spTree>
@@ -6885,12 +8067,234 @@
           <a:chExt cx="0" cy="0"/>
         </a:xfrm>
       </p:grpSpPr>
+      <p:sp>
+        <p:nvSpPr>
+          <p:cNvPr id="2" name="Title 1">
+            <a:extLst>
+              <a:ext uri="{FF2B5EF4-FFF2-40B4-BE49-F238E27FC236}">
+                <a16:creationId xmlns:a16="http://schemas.microsoft.com/office/drawing/2014/main" id="{CFCD8A87-80DC-C180-D3F1-FFE60E84471A}"/>
+              </a:ext>
+            </a:extLst>
+          </p:cNvPr>
+          <p:cNvSpPr>
+            <a:spLocks noGrp="1"/>
+          </p:cNvSpPr>
+          <p:nvPr>
+            <p:ph type="title"/>
+          </p:nvPr>
+        </p:nvSpPr>
+        <p:spPr/>
+        <p:txBody>
+          <a:bodyPr/>
+          <a:lstStyle/>
+          <a:p>
+            <a:endParaRPr lang="en-US"/>
+          </a:p>
+        </p:txBody>
+      </p:sp>
+      <p:sp>
+        <p:nvSpPr>
+          <p:cNvPr id="3" name="Content Placeholder 2">
+            <a:extLst>
+              <a:ext uri="{FF2B5EF4-FFF2-40B4-BE49-F238E27FC236}">
+                <a16:creationId xmlns:a16="http://schemas.microsoft.com/office/drawing/2014/main" id="{B2064F4C-0661-F4C6-1DB0-87302985C104}"/>
+              </a:ext>
+            </a:extLst>
+          </p:cNvPr>
+          <p:cNvSpPr>
+            <a:spLocks noGrp="1"/>
+          </p:cNvSpPr>
+          <p:nvPr>
+            <p:ph idx="1"/>
+          </p:nvPr>
+        </p:nvSpPr>
+        <p:spPr/>
+        <p:txBody>
+          <a:bodyPr/>
+          <a:lstStyle/>
+          <a:p>
+            <a:endParaRPr lang="en-US"/>
+          </a:p>
+        </p:txBody>
+      </p:sp>
+    </p:spTree>
+    <p:extLst>
+      <p:ext uri="{BB962C8B-B14F-4D97-AF65-F5344CB8AC3E}">
+        <p14:creationId xmlns:p14="http://schemas.microsoft.com/office/powerpoint/2010/main" val="1264616559"/>
+      </p:ext>
+    </p:extLst>
+  </p:cSld>
+  <p:clrMapOvr>
+    <a:masterClrMapping/>
+  </p:clrMapOvr>
+</p:sld>
+</file>
+
+<file path=ppt/slides/slide39.xml><?xml version="1.0" encoding="utf-8"?>
+<p:sld xmlns:a="http://schemas.openxmlformats.org/drawingml/2006/main" xmlns:r="http://schemas.openxmlformats.org/officeDocument/2006/relationships" xmlns:p="http://schemas.openxmlformats.org/presentationml/2006/main">
+  <p:cSld>
+    <p:spTree>
+      <p:nvGrpSpPr>
+        <p:cNvPr id="1" name=""/>
+        <p:cNvGrpSpPr/>
+        <p:nvPr/>
+      </p:nvGrpSpPr>
+      <p:grpSpPr>
+        <a:xfrm>
+          <a:off x="0" y="0"/>
+          <a:ext cx="0" cy="0"/>
+          <a:chOff x="0" y="0"/>
+          <a:chExt cx="0" cy="0"/>
+        </a:xfrm>
+      </p:grpSpPr>
+      <p:sp>
+        <p:nvSpPr>
+          <p:cNvPr id="2" name="Title 1">
+            <a:extLst>
+              <a:ext uri="{FF2B5EF4-FFF2-40B4-BE49-F238E27FC236}">
+                <a16:creationId xmlns:a16="http://schemas.microsoft.com/office/drawing/2014/main" id="{2473313D-9410-7606-DB19-CE63EE0B4B09}"/>
+              </a:ext>
+            </a:extLst>
+          </p:cNvPr>
+          <p:cNvSpPr>
+            <a:spLocks noGrp="1"/>
+          </p:cNvSpPr>
+          <p:nvPr>
+            <p:ph type="title"/>
+          </p:nvPr>
+        </p:nvSpPr>
+        <p:spPr/>
+        <p:txBody>
+          <a:bodyPr/>
+          <a:lstStyle/>
+          <a:p>
+            <a:endParaRPr lang="en-US"/>
+          </a:p>
+        </p:txBody>
+      </p:sp>
+      <p:sp>
+        <p:nvSpPr>
+          <p:cNvPr id="3" name="Content Placeholder 2">
+            <a:extLst>
+              <a:ext uri="{FF2B5EF4-FFF2-40B4-BE49-F238E27FC236}">
+                <a16:creationId xmlns:a16="http://schemas.microsoft.com/office/drawing/2014/main" id="{2F30C77D-E59B-5D9E-C679-3B98F968634F}"/>
+              </a:ext>
+            </a:extLst>
+          </p:cNvPr>
+          <p:cNvSpPr>
+            <a:spLocks noGrp="1"/>
+          </p:cNvSpPr>
+          <p:nvPr>
+            <p:ph idx="1"/>
+          </p:nvPr>
+        </p:nvSpPr>
+        <p:spPr/>
+        <p:txBody>
+          <a:bodyPr/>
+          <a:lstStyle/>
+          <a:p>
+            <a:endParaRPr lang="en-US"/>
+          </a:p>
+        </p:txBody>
+      </p:sp>
+    </p:spTree>
+    <p:extLst>
+      <p:ext uri="{BB962C8B-B14F-4D97-AF65-F5344CB8AC3E}">
+        <p14:creationId xmlns:p14="http://schemas.microsoft.com/office/powerpoint/2010/main" val="787473245"/>
+      </p:ext>
+    </p:extLst>
+  </p:cSld>
+  <p:clrMapOvr>
+    <a:masterClrMapping/>
+  </p:clrMapOvr>
+</p:sld>
+</file>
+
+<file path=ppt/slides/slide4.xml><?xml version="1.0" encoding="utf-8"?>
+<p:sld xmlns:a="http://schemas.openxmlformats.org/drawingml/2006/main" xmlns:r="http://schemas.openxmlformats.org/officeDocument/2006/relationships" xmlns:p="http://schemas.openxmlformats.org/presentationml/2006/main">
+  <p:cSld>
+    <p:spTree>
+      <p:nvGrpSpPr>
+        <p:cNvPr id="1" name="">
+          <a:extLst>
+            <a:ext uri="{FF2B5EF4-FFF2-40B4-BE49-F238E27FC236}">
+              <a16:creationId xmlns:a16="http://schemas.microsoft.com/office/drawing/2014/main" id="{EEB1E60C-20CB-5321-9E5D-94DB47F4B15A}"/>
+            </a:ext>
+          </a:extLst>
+        </p:cNvPr>
+        <p:cNvGrpSpPr/>
+        <p:nvPr/>
+      </p:nvGrpSpPr>
+      <p:grpSpPr>
+        <a:xfrm>
+          <a:off x="0" y="0"/>
+          <a:ext cx="0" cy="0"/>
+          <a:chOff x="0" y="0"/>
+          <a:chExt cx="0" cy="0"/>
+        </a:xfrm>
+      </p:grpSpPr>
+      <p:sp>
+        <p:nvSpPr>
+          <p:cNvPr id="2" name="Title 1">
+            <a:extLst>
+              <a:ext uri="{FF2B5EF4-FFF2-40B4-BE49-F238E27FC236}">
+                <a16:creationId xmlns:a16="http://schemas.microsoft.com/office/drawing/2014/main" id="{5DA238A7-6716-640F-7161-17FECB540E5B}"/>
+              </a:ext>
+            </a:extLst>
+          </p:cNvPr>
+          <p:cNvSpPr>
+            <a:spLocks noGrp="1"/>
+          </p:cNvSpPr>
+          <p:nvPr>
+            <p:ph type="title"/>
+          </p:nvPr>
+        </p:nvSpPr>
+        <p:spPr/>
+        <p:txBody>
+          <a:bodyPr/>
+          <a:lstStyle/>
+          <a:p>
+            <a:r>
+              <a:rPr lang="en-US" dirty="0"/>
+              <a:t>Env data plots</a:t>
+            </a:r>
+          </a:p>
+        </p:txBody>
+      </p:sp>
+      <p:sp>
+        <p:nvSpPr>
+          <p:cNvPr id="3" name="Content Placeholder 2">
+            <a:extLst>
+              <a:ext uri="{FF2B5EF4-FFF2-40B4-BE49-F238E27FC236}">
+                <a16:creationId xmlns:a16="http://schemas.microsoft.com/office/drawing/2014/main" id="{67A12D8A-C703-C271-5D8B-3E9500284D34}"/>
+              </a:ext>
+            </a:extLst>
+          </p:cNvPr>
+          <p:cNvSpPr>
+            <a:spLocks noGrp="1"/>
+          </p:cNvSpPr>
+          <p:nvPr>
+            <p:ph idx="1"/>
+          </p:nvPr>
+        </p:nvSpPr>
+        <p:spPr/>
+        <p:txBody>
+          <a:bodyPr/>
+          <a:lstStyle/>
+          <a:p>
+            <a:r>
+              <a:rPr lang="en-US" dirty="0"/>
+              <a:t>ONI and NPI</a:t>
+            </a:r>
+          </a:p>
+        </p:txBody>
+      </p:sp>
       <p:pic>
         <p:nvPicPr>
-          <p:cNvPr id="9" name="Picture 8">
-            <a:extLst>
-              <a:ext uri="{FF2B5EF4-FFF2-40B4-BE49-F238E27FC236}">
-                <a16:creationId xmlns:a16="http://schemas.microsoft.com/office/drawing/2014/main" id="{B4461000-CD6C-C489-4AF9-496580DE2C94}"/>
+          <p:cNvPr id="5" name="Picture 4">
+            <a:extLst>
+              <a:ext uri="{FF2B5EF4-FFF2-40B4-BE49-F238E27FC236}">
+                <a16:creationId xmlns:a16="http://schemas.microsoft.com/office/drawing/2014/main" id="{FFF0C0A6-3A03-C95A-6F50-3F21A82E042A}"/>
               </a:ext>
             </a:extLst>
           </p:cNvPr>
@@ -6907,81 +8311,20 @@
         </p:blipFill>
         <p:spPr>
           <a:xfrm>
-            <a:off x="6272199" y="858981"/>
-            <a:ext cx="5324747" cy="5731164"/>
+            <a:off x="148331" y="2993641"/>
+            <a:ext cx="5766286" cy="3676982"/>
           </a:xfrm>
           <a:prstGeom prst="rect">
             <a:avLst/>
           </a:prstGeom>
         </p:spPr>
       </p:pic>
-      <p:sp>
-        <p:nvSpPr>
-          <p:cNvPr id="2" name="Title 1">
-            <a:extLst>
-              <a:ext uri="{FF2B5EF4-FFF2-40B4-BE49-F238E27FC236}">
-                <a16:creationId xmlns:a16="http://schemas.microsoft.com/office/drawing/2014/main" id="{7C99787E-C5E9-7C55-BF99-5D920886E980}"/>
-              </a:ext>
-            </a:extLst>
-          </p:cNvPr>
-          <p:cNvSpPr>
-            <a:spLocks noGrp="1"/>
-          </p:cNvSpPr>
-          <p:nvPr>
-            <p:ph type="title"/>
-          </p:nvPr>
-        </p:nvSpPr>
-        <p:spPr/>
-        <p:txBody>
-          <a:bodyPr/>
-          <a:lstStyle/>
-          <a:p>
-            <a:r>
-              <a:rPr lang="en-US" dirty="0"/>
-              <a:t>Le </a:t>
-            </a:r>
-            <a:r>
-              <a:rPr lang="en-US" dirty="0" err="1"/>
-              <a:t>Cren’s</a:t>
-            </a:r>
-            <a:r>
-              <a:rPr lang="en-US" dirty="0"/>
-              <a:t> body condition</a:t>
-            </a:r>
-          </a:p>
-        </p:txBody>
-      </p:sp>
-      <p:sp>
-        <p:nvSpPr>
-          <p:cNvPr id="3" name="Content Placeholder 2">
-            <a:extLst>
-              <a:ext uri="{FF2B5EF4-FFF2-40B4-BE49-F238E27FC236}">
-                <a16:creationId xmlns:a16="http://schemas.microsoft.com/office/drawing/2014/main" id="{90C36CF5-35F6-7683-E969-73033189FB70}"/>
-              </a:ext>
-            </a:extLst>
-          </p:cNvPr>
-          <p:cNvSpPr>
-            <a:spLocks noGrp="1"/>
-          </p:cNvSpPr>
-          <p:nvPr>
-            <p:ph idx="1"/>
-          </p:nvPr>
-        </p:nvSpPr>
-        <p:spPr/>
-        <p:txBody>
-          <a:bodyPr/>
-          <a:lstStyle/>
-          <a:p>
-            <a:endParaRPr lang="en-US" dirty="0"/>
-          </a:p>
-        </p:txBody>
-      </p:sp>
       <p:pic>
         <p:nvPicPr>
-          <p:cNvPr id="11" name="Picture 10">
-            <a:extLst>
-              <a:ext uri="{FF2B5EF4-FFF2-40B4-BE49-F238E27FC236}">
-                <a16:creationId xmlns:a16="http://schemas.microsoft.com/office/drawing/2014/main" id="{F96F4006-B815-AF60-A4C3-097F022B6D0D}"/>
+          <p:cNvPr id="8" name="Picture 7">
+            <a:extLst>
+              <a:ext uri="{FF2B5EF4-FFF2-40B4-BE49-F238E27FC236}">
+                <a16:creationId xmlns:a16="http://schemas.microsoft.com/office/drawing/2014/main" id="{156E5472-1329-A51D-495D-A204CDAE34F7}"/>
               </a:ext>
             </a:extLst>
           </p:cNvPr>
@@ -6998,8 +8341,210 @@
         </p:blipFill>
         <p:spPr>
           <a:xfrm>
-            <a:off x="235594" y="2576945"/>
-            <a:ext cx="5945824" cy="3338946"/>
+            <a:off x="6096000" y="2993641"/>
+            <a:ext cx="5766287" cy="3676982"/>
+          </a:xfrm>
+          <a:prstGeom prst="rect">
+            <a:avLst/>
+          </a:prstGeom>
+        </p:spPr>
+      </p:pic>
+    </p:spTree>
+    <p:extLst>
+      <p:ext uri="{BB962C8B-B14F-4D97-AF65-F5344CB8AC3E}">
+        <p14:creationId xmlns:p14="http://schemas.microsoft.com/office/powerpoint/2010/main" val="1212096548"/>
+      </p:ext>
+    </p:extLst>
+  </p:cSld>
+  <p:clrMapOvr>
+    <a:masterClrMapping/>
+  </p:clrMapOvr>
+</p:sld>
+</file>
+
+<file path=ppt/slides/slide40.xml><?xml version="1.0" encoding="utf-8"?>
+<p:sld xmlns:a="http://schemas.openxmlformats.org/drawingml/2006/main" xmlns:r="http://schemas.openxmlformats.org/officeDocument/2006/relationships" xmlns:p="http://schemas.openxmlformats.org/presentationml/2006/main">
+  <p:cSld>
+    <p:spTree>
+      <p:nvGrpSpPr>
+        <p:cNvPr id="1" name=""/>
+        <p:cNvGrpSpPr/>
+        <p:nvPr/>
+      </p:nvGrpSpPr>
+      <p:grpSpPr>
+        <a:xfrm>
+          <a:off x="0" y="0"/>
+          <a:ext cx="0" cy="0"/>
+          <a:chOff x="0" y="0"/>
+          <a:chExt cx="0" cy="0"/>
+        </a:xfrm>
+      </p:grpSpPr>
+      <p:sp>
+        <p:nvSpPr>
+          <p:cNvPr id="2" name="Title 1">
+            <a:extLst>
+              <a:ext uri="{FF2B5EF4-FFF2-40B4-BE49-F238E27FC236}">
+                <a16:creationId xmlns:a16="http://schemas.microsoft.com/office/drawing/2014/main" id="{17F016EE-8CCC-98C7-EBF4-3DD8648C6038}"/>
+              </a:ext>
+            </a:extLst>
+          </p:cNvPr>
+          <p:cNvSpPr>
+            <a:spLocks noGrp="1"/>
+          </p:cNvSpPr>
+          <p:nvPr>
+            <p:ph type="title"/>
+          </p:nvPr>
+        </p:nvSpPr>
+        <p:spPr/>
+        <p:txBody>
+          <a:bodyPr/>
+          <a:lstStyle/>
+          <a:p>
+            <a:endParaRPr lang="en-US"/>
+          </a:p>
+        </p:txBody>
+      </p:sp>
+      <p:sp>
+        <p:nvSpPr>
+          <p:cNvPr id="3" name="Content Placeholder 2">
+            <a:extLst>
+              <a:ext uri="{FF2B5EF4-FFF2-40B4-BE49-F238E27FC236}">
+                <a16:creationId xmlns:a16="http://schemas.microsoft.com/office/drawing/2014/main" id="{FCEEF53E-840B-45A6-AEE4-B33A69894A7B}"/>
+              </a:ext>
+            </a:extLst>
+          </p:cNvPr>
+          <p:cNvSpPr>
+            <a:spLocks noGrp="1"/>
+          </p:cNvSpPr>
+          <p:nvPr>
+            <p:ph idx="1"/>
+          </p:nvPr>
+        </p:nvSpPr>
+        <p:spPr/>
+        <p:txBody>
+          <a:bodyPr/>
+          <a:lstStyle/>
+          <a:p>
+            <a:endParaRPr lang="en-US"/>
+          </a:p>
+        </p:txBody>
+      </p:sp>
+    </p:spTree>
+    <p:extLst>
+      <p:ext uri="{BB962C8B-B14F-4D97-AF65-F5344CB8AC3E}">
+        <p14:creationId xmlns:p14="http://schemas.microsoft.com/office/powerpoint/2010/main" val="612133903"/>
+      </p:ext>
+    </p:extLst>
+  </p:cSld>
+  <p:clrMapOvr>
+    <a:masterClrMapping/>
+  </p:clrMapOvr>
+</p:sld>
+</file>
+
+<file path=ppt/slides/slide41.xml><?xml version="1.0" encoding="utf-8"?>
+<p:sld xmlns:a="http://schemas.openxmlformats.org/drawingml/2006/main" xmlns:r="http://schemas.openxmlformats.org/officeDocument/2006/relationships" xmlns:p="http://schemas.openxmlformats.org/presentationml/2006/main">
+  <p:cSld>
+    <p:spTree>
+      <p:nvGrpSpPr>
+        <p:cNvPr id="1" name=""/>
+        <p:cNvGrpSpPr/>
+        <p:nvPr/>
+      </p:nvGrpSpPr>
+      <p:grpSpPr>
+        <a:xfrm>
+          <a:off x="0" y="0"/>
+          <a:ext cx="0" cy="0"/>
+          <a:chOff x="0" y="0"/>
+          <a:chExt cx="0" cy="0"/>
+        </a:xfrm>
+      </p:grpSpPr>
+      <p:sp>
+        <p:nvSpPr>
+          <p:cNvPr id="2" name="Title 1">
+            <a:extLst>
+              <a:ext uri="{FF2B5EF4-FFF2-40B4-BE49-F238E27FC236}">
+                <a16:creationId xmlns:a16="http://schemas.microsoft.com/office/drawing/2014/main" id="{7C99787E-C5E9-7C55-BF99-5D920886E980}"/>
+              </a:ext>
+            </a:extLst>
+          </p:cNvPr>
+          <p:cNvSpPr>
+            <a:spLocks noGrp="1"/>
+          </p:cNvSpPr>
+          <p:nvPr>
+            <p:ph type="title"/>
+          </p:nvPr>
+        </p:nvSpPr>
+        <p:spPr/>
+        <p:txBody>
+          <a:bodyPr/>
+          <a:lstStyle/>
+          <a:p>
+            <a:r>
+              <a:rPr lang="en-US" dirty="0"/>
+              <a:t>Le </a:t>
+            </a:r>
+            <a:r>
+              <a:rPr lang="en-US" dirty="0" err="1"/>
+              <a:t>Cren’s</a:t>
+            </a:r>
+            <a:r>
+              <a:rPr lang="en-US" dirty="0"/>
+              <a:t> body condition</a:t>
+            </a:r>
+          </a:p>
+        </p:txBody>
+      </p:sp>
+      <p:sp>
+        <p:nvSpPr>
+          <p:cNvPr id="3" name="Content Placeholder 2">
+            <a:extLst>
+              <a:ext uri="{FF2B5EF4-FFF2-40B4-BE49-F238E27FC236}">
+                <a16:creationId xmlns:a16="http://schemas.microsoft.com/office/drawing/2014/main" id="{90C36CF5-35F6-7683-E969-73033189FB70}"/>
+              </a:ext>
+            </a:extLst>
+          </p:cNvPr>
+          <p:cNvSpPr>
+            <a:spLocks noGrp="1"/>
+          </p:cNvSpPr>
+          <p:nvPr>
+            <p:ph idx="1"/>
+          </p:nvPr>
+        </p:nvSpPr>
+        <p:spPr/>
+        <p:txBody>
+          <a:bodyPr/>
+          <a:lstStyle/>
+          <a:p>
+            <a:endParaRPr lang="en-US" b="1" dirty="0"/>
+          </a:p>
+        </p:txBody>
+      </p:sp>
+      <p:pic>
+        <p:nvPicPr>
+          <p:cNvPr id="9" name="Picture 8">
+            <a:extLst>
+              <a:ext uri="{FF2B5EF4-FFF2-40B4-BE49-F238E27FC236}">
+                <a16:creationId xmlns:a16="http://schemas.microsoft.com/office/drawing/2014/main" id="{B4461000-CD6C-C489-4AF9-496580DE2C94}"/>
+              </a:ext>
+            </a:extLst>
+          </p:cNvPr>
+          <p:cNvPicPr>
+            <a:picLocks noChangeAspect="1"/>
+          </p:cNvPicPr>
+          <p:nvPr/>
+        </p:nvPicPr>
+        <p:blipFill>
+          <a:blip r:embed="rId2"/>
+          <a:srcRect r="827" b="51683"/>
+          <a:stretch>
+            <a:fillRect/>
+          </a:stretch>
+        </p:blipFill>
+        <p:spPr>
+          <a:xfrm>
+            <a:off x="1564234" y="1740095"/>
+            <a:ext cx="9063531" cy="4752780"/>
           </a:xfrm>
           <a:prstGeom prst="rect">
             <a:avLst/>
@@ -7019,7 +8564,7 @@
 </p:sld>
 </file>
 
-<file path=ppt/slides/slide30.xml><?xml version="1.0" encoding="utf-8"?>
+<file path=ppt/slides/slide42.xml><?xml version="1.0" encoding="utf-8"?>
 <p:sld xmlns:a="http://schemas.openxmlformats.org/drawingml/2006/main" xmlns:r="http://schemas.openxmlformats.org/officeDocument/2006/relationships" xmlns:p="http://schemas.openxmlformats.org/presentationml/2006/main">
   <p:cSld>
     <p:spTree>
@@ -7041,166 +8586,6 @@
           <p:cNvPr id="2" name="Title 1">
             <a:extLst>
               <a:ext uri="{FF2B5EF4-FFF2-40B4-BE49-F238E27FC236}">
-                <a16:creationId xmlns:a16="http://schemas.microsoft.com/office/drawing/2014/main" id="{2473313D-9410-7606-DB19-CE63EE0B4B09}"/>
-              </a:ext>
-            </a:extLst>
-          </p:cNvPr>
-          <p:cNvSpPr>
-            <a:spLocks noGrp="1"/>
-          </p:cNvSpPr>
-          <p:nvPr>
-            <p:ph type="title"/>
-          </p:nvPr>
-        </p:nvSpPr>
-        <p:spPr/>
-        <p:txBody>
-          <a:bodyPr/>
-          <a:lstStyle/>
-          <a:p>
-            <a:endParaRPr lang="en-US"/>
-          </a:p>
-        </p:txBody>
-      </p:sp>
-      <p:sp>
-        <p:nvSpPr>
-          <p:cNvPr id="3" name="Content Placeholder 2">
-            <a:extLst>
-              <a:ext uri="{FF2B5EF4-FFF2-40B4-BE49-F238E27FC236}">
-                <a16:creationId xmlns:a16="http://schemas.microsoft.com/office/drawing/2014/main" id="{2F30C77D-E59B-5D9E-C679-3B98F968634F}"/>
-              </a:ext>
-            </a:extLst>
-          </p:cNvPr>
-          <p:cNvSpPr>
-            <a:spLocks noGrp="1"/>
-          </p:cNvSpPr>
-          <p:nvPr>
-            <p:ph idx="1"/>
-          </p:nvPr>
-        </p:nvSpPr>
-        <p:spPr/>
-        <p:txBody>
-          <a:bodyPr/>
-          <a:lstStyle/>
-          <a:p>
-            <a:endParaRPr lang="en-US"/>
-          </a:p>
-        </p:txBody>
-      </p:sp>
-    </p:spTree>
-    <p:extLst>
-      <p:ext uri="{BB962C8B-B14F-4D97-AF65-F5344CB8AC3E}">
-        <p14:creationId xmlns:p14="http://schemas.microsoft.com/office/powerpoint/2010/main" val="787473245"/>
-      </p:ext>
-    </p:extLst>
-  </p:cSld>
-  <p:clrMapOvr>
-    <a:masterClrMapping/>
-  </p:clrMapOvr>
-</p:sld>
-</file>
-
-<file path=ppt/slides/slide31.xml><?xml version="1.0" encoding="utf-8"?>
-<p:sld xmlns:a="http://schemas.openxmlformats.org/drawingml/2006/main" xmlns:r="http://schemas.openxmlformats.org/officeDocument/2006/relationships" xmlns:p="http://schemas.openxmlformats.org/presentationml/2006/main">
-  <p:cSld>
-    <p:spTree>
-      <p:nvGrpSpPr>
-        <p:cNvPr id="1" name=""/>
-        <p:cNvGrpSpPr/>
-        <p:nvPr/>
-      </p:nvGrpSpPr>
-      <p:grpSpPr>
-        <a:xfrm>
-          <a:off x="0" y="0"/>
-          <a:ext cx="0" cy="0"/>
-          <a:chOff x="0" y="0"/>
-          <a:chExt cx="0" cy="0"/>
-        </a:xfrm>
-      </p:grpSpPr>
-      <p:sp>
-        <p:nvSpPr>
-          <p:cNvPr id="2" name="Title 1">
-            <a:extLst>
-              <a:ext uri="{FF2B5EF4-FFF2-40B4-BE49-F238E27FC236}">
-                <a16:creationId xmlns:a16="http://schemas.microsoft.com/office/drawing/2014/main" id="{17F016EE-8CCC-98C7-EBF4-3DD8648C6038}"/>
-              </a:ext>
-            </a:extLst>
-          </p:cNvPr>
-          <p:cNvSpPr>
-            <a:spLocks noGrp="1"/>
-          </p:cNvSpPr>
-          <p:nvPr>
-            <p:ph type="title"/>
-          </p:nvPr>
-        </p:nvSpPr>
-        <p:spPr/>
-        <p:txBody>
-          <a:bodyPr/>
-          <a:lstStyle/>
-          <a:p>
-            <a:endParaRPr lang="en-US"/>
-          </a:p>
-        </p:txBody>
-      </p:sp>
-      <p:sp>
-        <p:nvSpPr>
-          <p:cNvPr id="3" name="Content Placeholder 2">
-            <a:extLst>
-              <a:ext uri="{FF2B5EF4-FFF2-40B4-BE49-F238E27FC236}">
-                <a16:creationId xmlns:a16="http://schemas.microsoft.com/office/drawing/2014/main" id="{FCEEF53E-840B-45A6-AEE4-B33A69894A7B}"/>
-              </a:ext>
-            </a:extLst>
-          </p:cNvPr>
-          <p:cNvSpPr>
-            <a:spLocks noGrp="1"/>
-          </p:cNvSpPr>
-          <p:nvPr>
-            <p:ph idx="1"/>
-          </p:nvPr>
-        </p:nvSpPr>
-        <p:spPr/>
-        <p:txBody>
-          <a:bodyPr/>
-          <a:lstStyle/>
-          <a:p>
-            <a:endParaRPr lang="en-US"/>
-          </a:p>
-        </p:txBody>
-      </p:sp>
-    </p:spTree>
-    <p:extLst>
-      <p:ext uri="{BB962C8B-B14F-4D97-AF65-F5344CB8AC3E}">
-        <p14:creationId xmlns:p14="http://schemas.microsoft.com/office/powerpoint/2010/main" val="612133903"/>
-      </p:ext>
-    </p:extLst>
-  </p:cSld>
-  <p:clrMapOvr>
-    <a:masterClrMapping/>
-  </p:clrMapOvr>
-</p:sld>
-</file>
-
-<file path=ppt/slides/slide32.xml><?xml version="1.0" encoding="utf-8"?>
-<p:sld xmlns:a="http://schemas.openxmlformats.org/drawingml/2006/main" xmlns:r="http://schemas.openxmlformats.org/officeDocument/2006/relationships" xmlns:p="http://schemas.openxmlformats.org/presentationml/2006/main">
-  <p:cSld>
-    <p:spTree>
-      <p:nvGrpSpPr>
-        <p:cNvPr id="1" name=""/>
-        <p:cNvGrpSpPr/>
-        <p:nvPr/>
-      </p:nvGrpSpPr>
-      <p:grpSpPr>
-        <a:xfrm>
-          <a:off x="0" y="0"/>
-          <a:ext cx="0" cy="0"/>
-          <a:chOff x="0" y="0"/>
-          <a:chExt cx="0" cy="0"/>
-        </a:xfrm>
-      </p:grpSpPr>
-      <p:sp>
-        <p:nvSpPr>
-          <p:cNvPr id="2" name="Title 1">
-            <a:extLst>
-              <a:ext uri="{FF2B5EF4-FFF2-40B4-BE49-F238E27FC236}">
                 <a16:creationId xmlns:a16="http://schemas.microsoft.com/office/drawing/2014/main" id="{6555FD4B-716A-8585-F669-ED515BE77843}"/>
               </a:ext>
             </a:extLst>
@@ -7262,7 +8647,7 @@
 </p:sld>
 </file>
 
-<file path=ppt/slides/slide33.xml><?xml version="1.0" encoding="utf-8"?>
+<file path=ppt/slides/slide43.xml><?xml version="1.0" encoding="utf-8"?>
 <p:sld xmlns:a="http://schemas.openxmlformats.org/drawingml/2006/main" xmlns:r="http://schemas.openxmlformats.org/officeDocument/2006/relationships" xmlns:p="http://schemas.openxmlformats.org/presentationml/2006/main">
   <p:cSld>
     <p:spTree>
@@ -7372,7 +8757,7 @@
 </p:sld>
 </file>
 
-<file path=ppt/slides/slide34.xml><?xml version="1.0" encoding="utf-8"?>
+<file path=ppt/slides/slide44.xml><?xml version="1.0" encoding="utf-8"?>
 <p:sld xmlns:a="http://schemas.openxmlformats.org/drawingml/2006/main" xmlns:r="http://schemas.openxmlformats.org/officeDocument/2006/relationships" xmlns:p="http://schemas.openxmlformats.org/presentationml/2006/main">
   <p:cSld>
     <p:spTree>
@@ -7482,7 +8867,7 @@
 </p:sld>
 </file>
 
-<file path=ppt/slides/slide35.xml><?xml version="1.0" encoding="utf-8"?>
+<file path=ppt/slides/slide45.xml><?xml version="1.0" encoding="utf-8"?>
 <p:sld xmlns:a="http://schemas.openxmlformats.org/drawingml/2006/main" xmlns:r="http://schemas.openxmlformats.org/officeDocument/2006/relationships" xmlns:p="http://schemas.openxmlformats.org/presentationml/2006/main">
   <p:cSld>
     <p:spTree>
@@ -7592,7 +8977,7 @@
 </p:sld>
 </file>
 
-<file path=ppt/slides/slide36.xml><?xml version="1.0" encoding="utf-8"?>
+<file path=ppt/slides/slide46.xml><?xml version="1.0" encoding="utf-8"?>
 <p:sld xmlns:a="http://schemas.openxmlformats.org/drawingml/2006/main" xmlns:r="http://schemas.openxmlformats.org/officeDocument/2006/relationships" xmlns:p="http://schemas.openxmlformats.org/presentationml/2006/main">
   <p:cSld>
     <p:spTree>
@@ -7672,7 +9057,7 @@
 </p:sld>
 </file>
 
-<file path=ppt/slides/slide37.xml><?xml version="1.0" encoding="utf-8"?>
+<file path=ppt/slides/slide47.xml><?xml version="1.0" encoding="utf-8"?>
 <p:sld xmlns:a="http://schemas.openxmlformats.org/drawingml/2006/main" xmlns:r="http://schemas.openxmlformats.org/officeDocument/2006/relationships" xmlns:p="http://schemas.openxmlformats.org/presentationml/2006/main">
   <p:cSld>
     <p:spTree>
@@ -7782,7 +9167,7 @@
 </p:sld>
 </file>
 
-<file path=ppt/slides/slide38.xml><?xml version="1.0" encoding="utf-8"?>
+<file path=ppt/slides/slide48.xml><?xml version="1.0" encoding="utf-8"?>
 <p:sld xmlns:a="http://schemas.openxmlformats.org/drawingml/2006/main" xmlns:r="http://schemas.openxmlformats.org/officeDocument/2006/relationships" xmlns:p="http://schemas.openxmlformats.org/presentationml/2006/main">
   <p:cSld>
     <p:spTree>
@@ -7925,7 +9310,7 @@
 </p:sld>
 </file>
 
-<file path=ppt/slides/slide39.xml><?xml version="1.0" encoding="utf-8"?>
+<file path=ppt/slides/slide49.xml><?xml version="1.0" encoding="utf-8"?>
 <p:sld xmlns:a="http://schemas.openxmlformats.org/drawingml/2006/main" xmlns:r="http://schemas.openxmlformats.org/officeDocument/2006/relationships" xmlns:p="http://schemas.openxmlformats.org/presentationml/2006/main">
   <p:cSld>
     <p:spTree>
@@ -8035,471 +9420,7 @@
 </p:sld>
 </file>
 
-<file path=ppt/slides/slide4.xml><?xml version="1.0" encoding="utf-8"?>
-<p:sld xmlns:a="http://schemas.openxmlformats.org/drawingml/2006/main" xmlns:r="http://schemas.openxmlformats.org/officeDocument/2006/relationships" xmlns:p="http://schemas.openxmlformats.org/presentationml/2006/main">
-  <p:cSld>
-    <p:spTree>
-      <p:nvGrpSpPr>
-        <p:cNvPr id="1" name="">
-          <a:extLst>
-            <a:ext uri="{FF2B5EF4-FFF2-40B4-BE49-F238E27FC236}">
-              <a16:creationId xmlns:a16="http://schemas.microsoft.com/office/drawing/2014/main" id="{57D9EE95-29B0-444E-862E-C8EBBB46B271}"/>
-            </a:ext>
-          </a:extLst>
-        </p:cNvPr>
-        <p:cNvGrpSpPr/>
-        <p:nvPr/>
-      </p:nvGrpSpPr>
-      <p:grpSpPr>
-        <a:xfrm>
-          <a:off x="0" y="0"/>
-          <a:ext cx="0" cy="0"/>
-          <a:chOff x="0" y="0"/>
-          <a:chExt cx="0" cy="0"/>
-        </a:xfrm>
-      </p:grpSpPr>
-      <p:sp>
-        <p:nvSpPr>
-          <p:cNvPr id="2" name="Title 1">
-            <a:extLst>
-              <a:ext uri="{FF2B5EF4-FFF2-40B4-BE49-F238E27FC236}">
-                <a16:creationId xmlns:a16="http://schemas.microsoft.com/office/drawing/2014/main" id="{5A38A37B-F21C-0AC6-B0A5-6E00BCBF6BD7}"/>
-              </a:ext>
-            </a:extLst>
-          </p:cNvPr>
-          <p:cNvSpPr>
-            <a:spLocks noGrp="1"/>
-          </p:cNvSpPr>
-          <p:nvPr>
-            <p:ph type="title"/>
-          </p:nvPr>
-        </p:nvSpPr>
-        <p:spPr/>
-        <p:txBody>
-          <a:bodyPr/>
-          <a:lstStyle/>
-          <a:p>
-            <a:r>
-              <a:rPr lang="en-US" dirty="0"/>
-              <a:t>Env data plots</a:t>
-            </a:r>
-          </a:p>
-        </p:txBody>
-      </p:sp>
-      <p:sp>
-        <p:nvSpPr>
-          <p:cNvPr id="3" name="Content Placeholder 2">
-            <a:extLst>
-              <a:ext uri="{FF2B5EF4-FFF2-40B4-BE49-F238E27FC236}">
-                <a16:creationId xmlns:a16="http://schemas.microsoft.com/office/drawing/2014/main" id="{C590EC79-74F3-B72A-D66F-4C024AA7B044}"/>
-              </a:ext>
-            </a:extLst>
-          </p:cNvPr>
-          <p:cNvSpPr>
-            <a:spLocks noGrp="1"/>
-          </p:cNvSpPr>
-          <p:nvPr>
-            <p:ph idx="1"/>
-          </p:nvPr>
-        </p:nvSpPr>
-        <p:spPr/>
-        <p:txBody>
-          <a:bodyPr/>
-          <a:lstStyle/>
-          <a:p>
-            <a:r>
-              <a:rPr lang="en-US" dirty="0"/>
-              <a:t>PDO and NPGO</a:t>
-            </a:r>
-          </a:p>
-        </p:txBody>
-      </p:sp>
-      <p:pic>
-        <p:nvPicPr>
-          <p:cNvPr id="6" name="Picture 5">
-            <a:extLst>
-              <a:ext uri="{FF2B5EF4-FFF2-40B4-BE49-F238E27FC236}">
-                <a16:creationId xmlns:a16="http://schemas.microsoft.com/office/drawing/2014/main" id="{A7C554CA-1D2A-2FEB-F754-E7533274B0F3}"/>
-              </a:ext>
-            </a:extLst>
-          </p:cNvPr>
-          <p:cNvPicPr>
-            <a:picLocks noChangeAspect="1"/>
-          </p:cNvPicPr>
-          <p:nvPr/>
-        </p:nvPicPr>
-        <p:blipFill>
-          <a:blip r:embed="rId2"/>
-          <a:stretch>
-            <a:fillRect/>
-          </a:stretch>
-        </p:blipFill>
-        <p:spPr>
-          <a:xfrm>
-            <a:off x="266020" y="2844799"/>
-            <a:ext cx="5720956" cy="3648076"/>
-          </a:xfrm>
-          <a:prstGeom prst="rect">
-            <a:avLst/>
-          </a:prstGeom>
-        </p:spPr>
-      </p:pic>
-      <p:pic>
-        <p:nvPicPr>
-          <p:cNvPr id="9" name="Picture 8">
-            <a:extLst>
-              <a:ext uri="{FF2B5EF4-FFF2-40B4-BE49-F238E27FC236}">
-                <a16:creationId xmlns:a16="http://schemas.microsoft.com/office/drawing/2014/main" id="{71B2C31F-292E-17AE-72DF-3499C1211FDD}"/>
-              </a:ext>
-            </a:extLst>
-          </p:cNvPr>
-          <p:cNvPicPr>
-            <a:picLocks noChangeAspect="1"/>
-          </p:cNvPicPr>
-          <p:nvPr/>
-        </p:nvPicPr>
-        <p:blipFill>
-          <a:blip r:embed="rId3"/>
-          <a:stretch>
-            <a:fillRect/>
-          </a:stretch>
-        </p:blipFill>
-        <p:spPr>
-          <a:xfrm>
-            <a:off x="6205026" y="2844799"/>
-            <a:ext cx="5720956" cy="3648076"/>
-          </a:xfrm>
-          <a:prstGeom prst="rect">
-            <a:avLst/>
-          </a:prstGeom>
-        </p:spPr>
-      </p:pic>
-    </p:spTree>
-    <p:extLst>
-      <p:ext uri="{BB962C8B-B14F-4D97-AF65-F5344CB8AC3E}">
-        <p14:creationId xmlns:p14="http://schemas.microsoft.com/office/powerpoint/2010/main" val="1379679899"/>
-      </p:ext>
-    </p:extLst>
-  </p:cSld>
-  <p:clrMapOvr>
-    <a:masterClrMapping/>
-  </p:clrMapOvr>
-</p:sld>
-</file>
-
-<file path=ppt/slides/slide40.xml><?xml version="1.0" encoding="utf-8"?>
-<p:sld xmlns:a="http://schemas.openxmlformats.org/drawingml/2006/main" xmlns:r="http://schemas.openxmlformats.org/officeDocument/2006/relationships" xmlns:p="http://schemas.openxmlformats.org/presentationml/2006/main">
-  <p:cSld>
-    <p:spTree>
-      <p:nvGrpSpPr>
-        <p:cNvPr id="1" name=""/>
-        <p:cNvGrpSpPr/>
-        <p:nvPr/>
-      </p:nvGrpSpPr>
-      <p:grpSpPr>
-        <a:xfrm>
-          <a:off x="0" y="0"/>
-          <a:ext cx="0" cy="0"/>
-          <a:chOff x="0" y="0"/>
-          <a:chExt cx="0" cy="0"/>
-        </a:xfrm>
-      </p:grpSpPr>
-      <p:sp>
-        <p:nvSpPr>
-          <p:cNvPr id="2" name="Title 1">
-            <a:extLst>
-              <a:ext uri="{FF2B5EF4-FFF2-40B4-BE49-F238E27FC236}">
-                <a16:creationId xmlns:a16="http://schemas.microsoft.com/office/drawing/2014/main" id="{1B4F899D-7172-97F0-AEB9-22F23528885F}"/>
-              </a:ext>
-            </a:extLst>
-          </p:cNvPr>
-          <p:cNvSpPr>
-            <a:spLocks noGrp="1"/>
-          </p:cNvSpPr>
-          <p:nvPr>
-            <p:ph type="title"/>
-          </p:nvPr>
-        </p:nvSpPr>
-        <p:spPr/>
-        <p:txBody>
-          <a:bodyPr/>
-          <a:lstStyle/>
-          <a:p>
-            <a:endParaRPr lang="en-US"/>
-          </a:p>
-        </p:txBody>
-      </p:sp>
-      <p:sp>
-        <p:nvSpPr>
-          <p:cNvPr id="3" name="Content Placeholder 2">
-            <a:extLst>
-              <a:ext uri="{FF2B5EF4-FFF2-40B4-BE49-F238E27FC236}">
-                <a16:creationId xmlns:a16="http://schemas.microsoft.com/office/drawing/2014/main" id="{97E331C5-05F1-E46E-09B0-CA9D5E9401D7}"/>
-              </a:ext>
-            </a:extLst>
-          </p:cNvPr>
-          <p:cNvSpPr>
-            <a:spLocks noGrp="1"/>
-          </p:cNvSpPr>
-          <p:nvPr>
-            <p:ph idx="1"/>
-          </p:nvPr>
-        </p:nvSpPr>
-        <p:spPr/>
-        <p:txBody>
-          <a:bodyPr/>
-          <a:lstStyle/>
-          <a:p>
-            <a:endParaRPr lang="en-US"/>
-          </a:p>
-        </p:txBody>
-      </p:sp>
-    </p:spTree>
-    <p:extLst>
-      <p:ext uri="{BB962C8B-B14F-4D97-AF65-F5344CB8AC3E}">
-        <p14:creationId xmlns:p14="http://schemas.microsoft.com/office/powerpoint/2010/main" val="387653240"/>
-      </p:ext>
-    </p:extLst>
-  </p:cSld>
-  <p:clrMapOvr>
-    <a:masterClrMapping/>
-  </p:clrMapOvr>
-</p:sld>
-</file>
-
-<file path=ppt/slides/slide41.xml><?xml version="1.0" encoding="utf-8"?>
-<p:sld xmlns:a="http://schemas.openxmlformats.org/drawingml/2006/main" xmlns:r="http://schemas.openxmlformats.org/officeDocument/2006/relationships" xmlns:p="http://schemas.openxmlformats.org/presentationml/2006/main">
-  <p:cSld>
-    <p:spTree>
-      <p:nvGrpSpPr>
-        <p:cNvPr id="1" name=""/>
-        <p:cNvGrpSpPr/>
-        <p:nvPr/>
-      </p:nvGrpSpPr>
-      <p:grpSpPr>
-        <a:xfrm>
-          <a:off x="0" y="0"/>
-          <a:ext cx="0" cy="0"/>
-          <a:chOff x="0" y="0"/>
-          <a:chExt cx="0" cy="0"/>
-        </a:xfrm>
-      </p:grpSpPr>
-      <p:sp>
-        <p:nvSpPr>
-          <p:cNvPr id="2" name="Title 1">
-            <a:extLst>
-              <a:ext uri="{FF2B5EF4-FFF2-40B4-BE49-F238E27FC236}">
-                <a16:creationId xmlns:a16="http://schemas.microsoft.com/office/drawing/2014/main" id="{8283EF55-EB33-0AE4-2506-D01C6C8E560B}"/>
-              </a:ext>
-            </a:extLst>
-          </p:cNvPr>
-          <p:cNvSpPr>
-            <a:spLocks noGrp="1"/>
-          </p:cNvSpPr>
-          <p:nvPr>
-            <p:ph type="title"/>
-          </p:nvPr>
-        </p:nvSpPr>
-        <p:spPr/>
-        <p:txBody>
-          <a:bodyPr/>
-          <a:lstStyle/>
-          <a:p>
-            <a:endParaRPr lang="en-US"/>
-          </a:p>
-        </p:txBody>
-      </p:sp>
-      <p:sp>
-        <p:nvSpPr>
-          <p:cNvPr id="3" name="Content Placeholder 2">
-            <a:extLst>
-              <a:ext uri="{FF2B5EF4-FFF2-40B4-BE49-F238E27FC236}">
-                <a16:creationId xmlns:a16="http://schemas.microsoft.com/office/drawing/2014/main" id="{0439DFE2-83DC-5A0B-AD55-CF7E09B08013}"/>
-              </a:ext>
-            </a:extLst>
-          </p:cNvPr>
-          <p:cNvSpPr>
-            <a:spLocks noGrp="1"/>
-          </p:cNvSpPr>
-          <p:nvPr>
-            <p:ph idx="1"/>
-          </p:nvPr>
-        </p:nvSpPr>
-        <p:spPr/>
-        <p:txBody>
-          <a:bodyPr/>
-          <a:lstStyle/>
-          <a:p>
-            <a:endParaRPr lang="en-US"/>
-          </a:p>
-        </p:txBody>
-      </p:sp>
-    </p:spTree>
-    <p:extLst>
-      <p:ext uri="{BB962C8B-B14F-4D97-AF65-F5344CB8AC3E}">
-        <p14:creationId xmlns:p14="http://schemas.microsoft.com/office/powerpoint/2010/main" val="3603619897"/>
-      </p:ext>
-    </p:extLst>
-  </p:cSld>
-  <p:clrMapOvr>
-    <a:masterClrMapping/>
-  </p:clrMapOvr>
-</p:sld>
-</file>
-
 <file path=ppt/slides/slide5.xml><?xml version="1.0" encoding="utf-8"?>
-<p:sld xmlns:a="http://schemas.openxmlformats.org/drawingml/2006/main" xmlns:r="http://schemas.openxmlformats.org/officeDocument/2006/relationships" xmlns:p="http://schemas.openxmlformats.org/presentationml/2006/main">
-  <p:cSld>
-    <p:spTree>
-      <p:nvGrpSpPr>
-        <p:cNvPr id="1" name="">
-          <a:extLst>
-            <a:ext uri="{FF2B5EF4-FFF2-40B4-BE49-F238E27FC236}">
-              <a16:creationId xmlns:a16="http://schemas.microsoft.com/office/drawing/2014/main" id="{EEB1E60C-20CB-5321-9E5D-94DB47F4B15A}"/>
-            </a:ext>
-          </a:extLst>
-        </p:cNvPr>
-        <p:cNvGrpSpPr/>
-        <p:nvPr/>
-      </p:nvGrpSpPr>
-      <p:grpSpPr>
-        <a:xfrm>
-          <a:off x="0" y="0"/>
-          <a:ext cx="0" cy="0"/>
-          <a:chOff x="0" y="0"/>
-          <a:chExt cx="0" cy="0"/>
-        </a:xfrm>
-      </p:grpSpPr>
-      <p:sp>
-        <p:nvSpPr>
-          <p:cNvPr id="2" name="Title 1">
-            <a:extLst>
-              <a:ext uri="{FF2B5EF4-FFF2-40B4-BE49-F238E27FC236}">
-                <a16:creationId xmlns:a16="http://schemas.microsoft.com/office/drawing/2014/main" id="{5DA238A7-6716-640F-7161-17FECB540E5B}"/>
-              </a:ext>
-            </a:extLst>
-          </p:cNvPr>
-          <p:cNvSpPr>
-            <a:spLocks noGrp="1"/>
-          </p:cNvSpPr>
-          <p:nvPr>
-            <p:ph type="title"/>
-          </p:nvPr>
-        </p:nvSpPr>
-        <p:spPr/>
-        <p:txBody>
-          <a:bodyPr/>
-          <a:lstStyle/>
-          <a:p>
-            <a:r>
-              <a:rPr lang="en-US" dirty="0"/>
-              <a:t>Env data plots</a:t>
-            </a:r>
-          </a:p>
-        </p:txBody>
-      </p:sp>
-      <p:sp>
-        <p:nvSpPr>
-          <p:cNvPr id="3" name="Content Placeholder 2">
-            <a:extLst>
-              <a:ext uri="{FF2B5EF4-FFF2-40B4-BE49-F238E27FC236}">
-                <a16:creationId xmlns:a16="http://schemas.microsoft.com/office/drawing/2014/main" id="{67A12D8A-C703-C271-5D8B-3E9500284D34}"/>
-              </a:ext>
-            </a:extLst>
-          </p:cNvPr>
-          <p:cNvSpPr>
-            <a:spLocks noGrp="1"/>
-          </p:cNvSpPr>
-          <p:nvPr>
-            <p:ph idx="1"/>
-          </p:nvPr>
-        </p:nvSpPr>
-        <p:spPr/>
-        <p:txBody>
-          <a:bodyPr/>
-          <a:lstStyle/>
-          <a:p>
-            <a:r>
-              <a:rPr lang="en-US" dirty="0"/>
-              <a:t>ONI and NPI</a:t>
-            </a:r>
-          </a:p>
-        </p:txBody>
-      </p:sp>
-      <p:pic>
-        <p:nvPicPr>
-          <p:cNvPr id="5" name="Picture 4">
-            <a:extLst>
-              <a:ext uri="{FF2B5EF4-FFF2-40B4-BE49-F238E27FC236}">
-                <a16:creationId xmlns:a16="http://schemas.microsoft.com/office/drawing/2014/main" id="{FFF0C0A6-3A03-C95A-6F50-3F21A82E042A}"/>
-              </a:ext>
-            </a:extLst>
-          </p:cNvPr>
-          <p:cNvPicPr>
-            <a:picLocks noChangeAspect="1"/>
-          </p:cNvPicPr>
-          <p:nvPr/>
-        </p:nvPicPr>
-        <p:blipFill>
-          <a:blip r:embed="rId2"/>
-          <a:stretch>
-            <a:fillRect/>
-          </a:stretch>
-        </p:blipFill>
-        <p:spPr>
-          <a:xfrm>
-            <a:off x="148331" y="2993641"/>
-            <a:ext cx="5766286" cy="3676982"/>
-          </a:xfrm>
-          <a:prstGeom prst="rect">
-            <a:avLst/>
-          </a:prstGeom>
-        </p:spPr>
-      </p:pic>
-      <p:pic>
-        <p:nvPicPr>
-          <p:cNvPr id="8" name="Picture 7">
-            <a:extLst>
-              <a:ext uri="{FF2B5EF4-FFF2-40B4-BE49-F238E27FC236}">
-                <a16:creationId xmlns:a16="http://schemas.microsoft.com/office/drawing/2014/main" id="{156E5472-1329-A51D-495D-A204CDAE34F7}"/>
-              </a:ext>
-            </a:extLst>
-          </p:cNvPr>
-          <p:cNvPicPr>
-            <a:picLocks noChangeAspect="1"/>
-          </p:cNvPicPr>
-          <p:nvPr/>
-        </p:nvPicPr>
-        <p:blipFill>
-          <a:blip r:embed="rId3"/>
-          <a:stretch>
-            <a:fillRect/>
-          </a:stretch>
-        </p:blipFill>
-        <p:spPr>
-          <a:xfrm>
-            <a:off x="6096000" y="2993641"/>
-            <a:ext cx="5766287" cy="3676982"/>
-          </a:xfrm>
-          <a:prstGeom prst="rect">
-            <a:avLst/>
-          </a:prstGeom>
-        </p:spPr>
-      </p:pic>
-    </p:spTree>
-    <p:extLst>
-      <p:ext uri="{BB962C8B-B14F-4D97-AF65-F5344CB8AC3E}">
-        <p14:creationId xmlns:p14="http://schemas.microsoft.com/office/powerpoint/2010/main" val="1212096548"/>
-      </p:ext>
-    </p:extLst>
-  </p:cSld>
-  <p:clrMapOvr>
-    <a:masterClrMapping/>
-  </p:clrMapOvr>
-</p:sld>
-</file>
-
-<file path=ppt/slides/slide6.xml><?xml version="1.0" encoding="utf-8"?>
 <p:sld xmlns:a="http://schemas.openxmlformats.org/drawingml/2006/main" xmlns:r="http://schemas.openxmlformats.org/officeDocument/2006/relationships" xmlns:p="http://schemas.openxmlformats.org/presentationml/2006/main">
   <p:cSld>
     <p:spTree>
@@ -8593,7 +9514,167 @@
 </p:sld>
 </file>
 
-<file path=ppt/slides/slide7.xml><?xml version="1.0" encoding="utf-8"?>
+<file path=ppt/slides/slide50.xml><?xml version="1.0" encoding="utf-8"?>
+<p:sld xmlns:a="http://schemas.openxmlformats.org/drawingml/2006/main" xmlns:r="http://schemas.openxmlformats.org/officeDocument/2006/relationships" xmlns:p="http://schemas.openxmlformats.org/presentationml/2006/main">
+  <p:cSld>
+    <p:spTree>
+      <p:nvGrpSpPr>
+        <p:cNvPr id="1" name=""/>
+        <p:cNvGrpSpPr/>
+        <p:nvPr/>
+      </p:nvGrpSpPr>
+      <p:grpSpPr>
+        <a:xfrm>
+          <a:off x="0" y="0"/>
+          <a:ext cx="0" cy="0"/>
+          <a:chOff x="0" y="0"/>
+          <a:chExt cx="0" cy="0"/>
+        </a:xfrm>
+      </p:grpSpPr>
+      <p:sp>
+        <p:nvSpPr>
+          <p:cNvPr id="2" name="Title 1">
+            <a:extLst>
+              <a:ext uri="{FF2B5EF4-FFF2-40B4-BE49-F238E27FC236}">
+                <a16:creationId xmlns:a16="http://schemas.microsoft.com/office/drawing/2014/main" id="{1B4F899D-7172-97F0-AEB9-22F23528885F}"/>
+              </a:ext>
+            </a:extLst>
+          </p:cNvPr>
+          <p:cNvSpPr>
+            <a:spLocks noGrp="1"/>
+          </p:cNvSpPr>
+          <p:nvPr>
+            <p:ph type="title"/>
+          </p:nvPr>
+        </p:nvSpPr>
+        <p:spPr/>
+        <p:txBody>
+          <a:bodyPr/>
+          <a:lstStyle/>
+          <a:p>
+            <a:endParaRPr lang="en-US"/>
+          </a:p>
+        </p:txBody>
+      </p:sp>
+      <p:sp>
+        <p:nvSpPr>
+          <p:cNvPr id="3" name="Content Placeholder 2">
+            <a:extLst>
+              <a:ext uri="{FF2B5EF4-FFF2-40B4-BE49-F238E27FC236}">
+                <a16:creationId xmlns:a16="http://schemas.microsoft.com/office/drawing/2014/main" id="{97E331C5-05F1-E46E-09B0-CA9D5E9401D7}"/>
+              </a:ext>
+            </a:extLst>
+          </p:cNvPr>
+          <p:cNvSpPr>
+            <a:spLocks noGrp="1"/>
+          </p:cNvSpPr>
+          <p:nvPr>
+            <p:ph idx="1"/>
+          </p:nvPr>
+        </p:nvSpPr>
+        <p:spPr/>
+        <p:txBody>
+          <a:bodyPr/>
+          <a:lstStyle/>
+          <a:p>
+            <a:endParaRPr lang="en-US"/>
+          </a:p>
+        </p:txBody>
+      </p:sp>
+    </p:spTree>
+    <p:extLst>
+      <p:ext uri="{BB962C8B-B14F-4D97-AF65-F5344CB8AC3E}">
+        <p14:creationId xmlns:p14="http://schemas.microsoft.com/office/powerpoint/2010/main" val="387653240"/>
+      </p:ext>
+    </p:extLst>
+  </p:cSld>
+  <p:clrMapOvr>
+    <a:masterClrMapping/>
+  </p:clrMapOvr>
+</p:sld>
+</file>
+
+<file path=ppt/slides/slide51.xml><?xml version="1.0" encoding="utf-8"?>
+<p:sld xmlns:a="http://schemas.openxmlformats.org/drawingml/2006/main" xmlns:r="http://schemas.openxmlformats.org/officeDocument/2006/relationships" xmlns:p="http://schemas.openxmlformats.org/presentationml/2006/main">
+  <p:cSld>
+    <p:spTree>
+      <p:nvGrpSpPr>
+        <p:cNvPr id="1" name=""/>
+        <p:cNvGrpSpPr/>
+        <p:nvPr/>
+      </p:nvGrpSpPr>
+      <p:grpSpPr>
+        <a:xfrm>
+          <a:off x="0" y="0"/>
+          <a:ext cx="0" cy="0"/>
+          <a:chOff x="0" y="0"/>
+          <a:chExt cx="0" cy="0"/>
+        </a:xfrm>
+      </p:grpSpPr>
+      <p:sp>
+        <p:nvSpPr>
+          <p:cNvPr id="2" name="Title 1">
+            <a:extLst>
+              <a:ext uri="{FF2B5EF4-FFF2-40B4-BE49-F238E27FC236}">
+                <a16:creationId xmlns:a16="http://schemas.microsoft.com/office/drawing/2014/main" id="{8283EF55-EB33-0AE4-2506-D01C6C8E560B}"/>
+              </a:ext>
+            </a:extLst>
+          </p:cNvPr>
+          <p:cNvSpPr>
+            <a:spLocks noGrp="1"/>
+          </p:cNvSpPr>
+          <p:nvPr>
+            <p:ph type="title"/>
+          </p:nvPr>
+        </p:nvSpPr>
+        <p:spPr/>
+        <p:txBody>
+          <a:bodyPr/>
+          <a:lstStyle/>
+          <a:p>
+            <a:endParaRPr lang="en-US"/>
+          </a:p>
+        </p:txBody>
+      </p:sp>
+      <p:sp>
+        <p:nvSpPr>
+          <p:cNvPr id="3" name="Content Placeholder 2">
+            <a:extLst>
+              <a:ext uri="{FF2B5EF4-FFF2-40B4-BE49-F238E27FC236}">
+                <a16:creationId xmlns:a16="http://schemas.microsoft.com/office/drawing/2014/main" id="{0439DFE2-83DC-5A0B-AD55-CF7E09B08013}"/>
+              </a:ext>
+            </a:extLst>
+          </p:cNvPr>
+          <p:cNvSpPr>
+            <a:spLocks noGrp="1"/>
+          </p:cNvSpPr>
+          <p:nvPr>
+            <p:ph idx="1"/>
+          </p:nvPr>
+        </p:nvSpPr>
+        <p:spPr/>
+        <p:txBody>
+          <a:bodyPr/>
+          <a:lstStyle/>
+          <a:p>
+            <a:endParaRPr lang="en-US"/>
+          </a:p>
+        </p:txBody>
+      </p:sp>
+    </p:spTree>
+    <p:extLst>
+      <p:ext uri="{BB962C8B-B14F-4D97-AF65-F5344CB8AC3E}">
+        <p14:creationId xmlns:p14="http://schemas.microsoft.com/office/powerpoint/2010/main" val="3603619897"/>
+      </p:ext>
+    </p:extLst>
+  </p:cSld>
+  <p:clrMapOvr>
+    <a:masterClrMapping/>
+  </p:clrMapOvr>
+</p:sld>
+</file>
+
+<file path=ppt/slides/slide6.xml><?xml version="1.0" encoding="utf-8"?>
 <p:sld xmlns:a="http://schemas.openxmlformats.org/drawingml/2006/main" xmlns:r="http://schemas.openxmlformats.org/officeDocument/2006/relationships" xmlns:p="http://schemas.openxmlformats.org/presentationml/2006/main">
   <p:cSld>
     <p:spTree>
@@ -8712,7 +9793,7 @@
 </p:sld>
 </file>
 
-<file path=ppt/slides/slide8.xml><?xml version="1.0" encoding="utf-8"?>
+<file path=ppt/slides/slide7.xml><?xml version="1.0" encoding="utf-8"?>
 <p:sld xmlns:a="http://schemas.openxmlformats.org/drawingml/2006/main" xmlns:r="http://schemas.openxmlformats.org/officeDocument/2006/relationships" xmlns:p="http://schemas.openxmlformats.org/presentationml/2006/main">
   <p:cSld>
     <p:spTree>
@@ -8831,7 +9912,7 @@
 </p:sld>
 </file>
 
-<file path=ppt/slides/slide9.xml><?xml version="1.0" encoding="utf-8"?>
+<file path=ppt/slides/slide8.xml><?xml version="1.0" encoding="utf-8"?>
 <p:sld xmlns:a="http://schemas.openxmlformats.org/drawingml/2006/main" xmlns:r="http://schemas.openxmlformats.org/officeDocument/2006/relationships" xmlns:p="http://schemas.openxmlformats.org/presentationml/2006/main">
   <p:cSld>
     <p:spTree>
@@ -8935,6 +10016,100 @@
     <p:extLst>
       <p:ext uri="{BB962C8B-B14F-4D97-AF65-F5344CB8AC3E}">
         <p14:creationId xmlns:p14="http://schemas.microsoft.com/office/powerpoint/2010/main" val="1479296786"/>
+      </p:ext>
+    </p:extLst>
+  </p:cSld>
+  <p:clrMapOvr>
+    <a:masterClrMapping/>
+  </p:clrMapOvr>
+</p:sld>
+</file>
+
+<file path=ppt/slides/slide9.xml><?xml version="1.0" encoding="utf-8"?>
+<p:sld xmlns:a="http://schemas.openxmlformats.org/drawingml/2006/main" xmlns:r="http://schemas.openxmlformats.org/officeDocument/2006/relationships" xmlns:p="http://schemas.openxmlformats.org/presentationml/2006/main">
+  <p:cSld>
+    <p:spTree>
+      <p:nvGrpSpPr>
+        <p:cNvPr id="1" name="">
+          <a:extLst>
+            <a:ext uri="{FF2B5EF4-FFF2-40B4-BE49-F238E27FC236}">
+              <a16:creationId xmlns:a16="http://schemas.microsoft.com/office/drawing/2014/main" id="{99EB299D-3070-B03A-6039-34685C748421}"/>
+            </a:ext>
+          </a:extLst>
+        </p:cNvPr>
+        <p:cNvGrpSpPr/>
+        <p:nvPr/>
+      </p:nvGrpSpPr>
+      <p:grpSpPr>
+        <a:xfrm>
+          <a:off x="0" y="0"/>
+          <a:ext cx="0" cy="0"/>
+          <a:chOff x="0" y="0"/>
+          <a:chExt cx="0" cy="0"/>
+        </a:xfrm>
+      </p:grpSpPr>
+      <p:sp>
+        <p:nvSpPr>
+          <p:cNvPr id="2" name="Title 1">
+            <a:extLst>
+              <a:ext uri="{FF2B5EF4-FFF2-40B4-BE49-F238E27FC236}">
+                <a16:creationId xmlns:a16="http://schemas.microsoft.com/office/drawing/2014/main" id="{7287E5C3-6A63-10AA-1280-022AC875066C}"/>
+              </a:ext>
+            </a:extLst>
+          </p:cNvPr>
+          <p:cNvSpPr>
+            <a:spLocks noGrp="1"/>
+          </p:cNvSpPr>
+          <p:nvPr>
+            <p:ph type="title"/>
+          </p:nvPr>
+        </p:nvSpPr>
+        <p:spPr/>
+        <p:txBody>
+          <a:bodyPr/>
+          <a:lstStyle/>
+          <a:p>
+            <a:r>
+              <a:rPr lang="en-US" dirty="0"/>
+              <a:t>Env data plots – US Data</a:t>
+            </a:r>
+          </a:p>
+        </p:txBody>
+      </p:sp>
+      <p:pic>
+        <p:nvPicPr>
+          <p:cNvPr id="4" name="Picture 3">
+            <a:extLst>
+              <a:ext uri="{FF2B5EF4-FFF2-40B4-BE49-F238E27FC236}">
+                <a16:creationId xmlns:a16="http://schemas.microsoft.com/office/drawing/2014/main" id="{759E3529-BD8B-027B-CDD6-9F00584D5600}"/>
+              </a:ext>
+            </a:extLst>
+          </p:cNvPr>
+          <p:cNvPicPr>
+            <a:picLocks noChangeAspect="1"/>
+          </p:cNvPicPr>
+          <p:nvPr/>
+        </p:nvPicPr>
+        <p:blipFill>
+          <a:blip r:embed="rId3"/>
+          <a:stretch>
+            <a:fillRect/>
+          </a:stretch>
+        </p:blipFill>
+        <p:spPr>
+          <a:xfrm>
+            <a:off x="2203578" y="1475632"/>
+            <a:ext cx="7784844" cy="5017243"/>
+          </a:xfrm>
+          <a:prstGeom prst="rect">
+            <a:avLst/>
+          </a:prstGeom>
+        </p:spPr>
+      </p:pic>
+    </p:spTree>
+    <p:extLst>
+      <p:ext uri="{BB962C8B-B14F-4D97-AF65-F5344CB8AC3E}">
+        <p14:creationId xmlns:p14="http://schemas.microsoft.com/office/powerpoint/2010/main" val="3763793456"/>
       </p:ext>
     </p:extLst>
   </p:cSld>

</xml_diff>

<commit_message>
added more plots to slides
</commit_message>
<xml_diff>
--- a/stock-specific/hake/output_plots_20260730.pptx
+++ b/stock-specific/hake/output_plots_20260730.pptx
@@ -5,7 +5,7 @@
     <p:sldMasterId id="2147483648" r:id="rId1"/>
   </p:sldMasterIdLst>
   <p:notesMasterIdLst>
-    <p:notesMasterId r:id="rId53"/>
+    <p:notesMasterId r:id="rId59"/>
   </p:notesMasterIdLst>
   <p:sldIdLst>
     <p:sldId id="256" r:id="rId2"/>
@@ -46,19 +46,25 @@
     <p:sldId id="317" r:id="rId37"/>
     <p:sldId id="318" r:id="rId38"/>
     <p:sldId id="319" r:id="rId39"/>
-    <p:sldId id="270" r:id="rId40"/>
-    <p:sldId id="266" r:id="rId41"/>
-    <p:sldId id="257" r:id="rId42"/>
-    <p:sldId id="287" r:id="rId43"/>
-    <p:sldId id="280" r:id="rId44"/>
-    <p:sldId id="281" r:id="rId45"/>
-    <p:sldId id="288" r:id="rId46"/>
-    <p:sldId id="289" r:id="rId47"/>
-    <p:sldId id="292" r:id="rId48"/>
-    <p:sldId id="294" r:id="rId49"/>
-    <p:sldId id="295" r:id="rId50"/>
-    <p:sldId id="296" r:id="rId51"/>
-    <p:sldId id="297" r:id="rId52"/>
+    <p:sldId id="342" r:id="rId40"/>
+    <p:sldId id="270" r:id="rId41"/>
+    <p:sldId id="266" r:id="rId42"/>
+    <p:sldId id="257" r:id="rId43"/>
+    <p:sldId id="287" r:id="rId44"/>
+    <p:sldId id="280" r:id="rId45"/>
+    <p:sldId id="281" r:id="rId46"/>
+    <p:sldId id="288" r:id="rId47"/>
+    <p:sldId id="289" r:id="rId48"/>
+    <p:sldId id="292" r:id="rId49"/>
+    <p:sldId id="294" r:id="rId50"/>
+    <p:sldId id="295" r:id="rId51"/>
+    <p:sldId id="296" r:id="rId52"/>
+    <p:sldId id="297" r:id="rId53"/>
+    <p:sldId id="337" r:id="rId54"/>
+    <p:sldId id="338" r:id="rId55"/>
+    <p:sldId id="339" r:id="rId56"/>
+    <p:sldId id="340" r:id="rId57"/>
+    <p:sldId id="341" r:id="rId58"/>
   </p:sldIdLst>
   <p:sldSz cx="12192000" cy="6858000"/>
   <p:notesSz cx="6858000" cy="9144000"/>
@@ -1120,6 +1126,282 @@
     <p:extLst>
       <p:ext uri="{BB962C8B-B14F-4D97-AF65-F5344CB8AC3E}">
         <p14:creationId xmlns:p14="http://schemas.microsoft.com/office/powerpoint/2010/main" val="2695915399"/>
+      </p:ext>
+    </p:extLst>
+  </p:cSld>
+  <p:clrMapOvr>
+    <a:masterClrMapping/>
+  </p:clrMapOvr>
+</p:notes>
+</file>
+
+<file path=ppt/notesSlides/notesSlide7.xml><?xml version="1.0" encoding="utf-8"?>
+<p:notes xmlns:a="http://schemas.openxmlformats.org/drawingml/2006/main" xmlns:r="http://schemas.openxmlformats.org/officeDocument/2006/relationships" xmlns:p="http://schemas.openxmlformats.org/presentationml/2006/main">
+  <p:cSld>
+    <p:spTree>
+      <p:nvGrpSpPr>
+        <p:cNvPr id="1" name=""/>
+        <p:cNvGrpSpPr/>
+        <p:nvPr/>
+      </p:nvGrpSpPr>
+      <p:grpSpPr>
+        <a:xfrm>
+          <a:off x="0" y="0"/>
+          <a:ext cx="0" cy="0"/>
+          <a:chOff x="0" y="0"/>
+          <a:chExt cx="0" cy="0"/>
+        </a:xfrm>
+      </p:grpSpPr>
+      <p:sp>
+        <p:nvSpPr>
+          <p:cNvPr id="2" name="Slide Image Placeholder 1"/>
+          <p:cNvSpPr>
+            <a:spLocks noGrp="1" noRot="1" noChangeAspect="1"/>
+          </p:cNvSpPr>
+          <p:nvPr>
+            <p:ph type="sldImg"/>
+          </p:nvPr>
+        </p:nvSpPr>
+        <p:spPr/>
+      </p:sp>
+      <p:sp>
+        <p:nvSpPr>
+          <p:cNvPr id="3" name="Notes Placeholder 2"/>
+          <p:cNvSpPr>
+            <a:spLocks noGrp="1"/>
+          </p:cNvSpPr>
+          <p:nvPr>
+            <p:ph type="body" idx="1"/>
+          </p:nvPr>
+        </p:nvSpPr>
+        <p:spPr/>
+        <p:txBody>
+          <a:bodyPr/>
+          <a:lstStyle/>
+          <a:p>
+            <a:r>
+              <a:rPr lang="en-US" dirty="0"/>
+              <a:t>Spring they have lower body condition coming out of winter after spawning and migrating</a:t>
+            </a:r>
+          </a:p>
+          <a:p>
+            <a:r>
+              <a:rPr lang="en-US" dirty="0"/>
+              <a:t>In summer they are in peak feeding phase and storing fat</a:t>
+            </a:r>
+          </a:p>
+        </p:txBody>
+      </p:sp>
+      <p:sp>
+        <p:nvSpPr>
+          <p:cNvPr id="4" name="Slide Number Placeholder 3"/>
+          <p:cNvSpPr>
+            <a:spLocks noGrp="1"/>
+          </p:cNvSpPr>
+          <p:nvPr>
+            <p:ph type="sldNum" sz="quarter" idx="5"/>
+          </p:nvPr>
+        </p:nvSpPr>
+        <p:spPr/>
+        <p:txBody>
+          <a:bodyPr/>
+          <a:lstStyle/>
+          <a:p>
+            <a:fld id="{BC9AF6F9-19A8-4B2B-96C4-42992BE88AC3}" type="slidenum">
+              <a:rPr lang="en-US" smtClean="0"/>
+              <a:t>54</a:t>
+            </a:fld>
+            <a:endParaRPr lang="en-US"/>
+          </a:p>
+        </p:txBody>
+      </p:sp>
+    </p:spTree>
+    <p:extLst>
+      <p:ext uri="{BB962C8B-B14F-4D97-AF65-F5344CB8AC3E}">
+        <p14:creationId xmlns:p14="http://schemas.microsoft.com/office/powerpoint/2010/main" val="1934691591"/>
+      </p:ext>
+    </p:extLst>
+  </p:cSld>
+  <p:clrMapOvr>
+    <a:masterClrMapping/>
+  </p:clrMapOvr>
+</p:notes>
+</file>
+
+<file path=ppt/notesSlides/notesSlide8.xml><?xml version="1.0" encoding="utf-8"?>
+<p:notes xmlns:a="http://schemas.openxmlformats.org/drawingml/2006/main" xmlns:r="http://schemas.openxmlformats.org/officeDocument/2006/relationships" xmlns:p="http://schemas.openxmlformats.org/presentationml/2006/main">
+  <p:cSld>
+    <p:spTree>
+      <p:nvGrpSpPr>
+        <p:cNvPr id="1" name=""/>
+        <p:cNvGrpSpPr/>
+        <p:nvPr/>
+      </p:nvGrpSpPr>
+      <p:grpSpPr>
+        <a:xfrm>
+          <a:off x="0" y="0"/>
+          <a:ext cx="0" cy="0"/>
+          <a:chOff x="0" y="0"/>
+          <a:chExt cx="0" cy="0"/>
+        </a:xfrm>
+      </p:grpSpPr>
+      <p:sp>
+        <p:nvSpPr>
+          <p:cNvPr id="2" name="Slide Image Placeholder 1"/>
+          <p:cNvSpPr>
+            <a:spLocks noGrp="1" noRot="1" noChangeAspect="1"/>
+          </p:cNvSpPr>
+          <p:nvPr>
+            <p:ph type="sldImg"/>
+          </p:nvPr>
+        </p:nvSpPr>
+        <p:spPr/>
+      </p:sp>
+      <p:sp>
+        <p:nvSpPr>
+          <p:cNvPr id="3" name="Notes Placeholder 2"/>
+          <p:cNvSpPr>
+            <a:spLocks noGrp="1"/>
+          </p:cNvSpPr>
+          <p:nvPr>
+            <p:ph type="body" idx="1"/>
+          </p:nvPr>
+        </p:nvSpPr>
+        <p:spPr/>
+        <p:txBody>
+          <a:bodyPr/>
+          <a:lstStyle/>
+          <a:p>
+            <a:r>
+              <a:rPr lang="en-US" dirty="0"/>
+              <a:t>These are Bayesian posteriors.</a:t>
+            </a:r>
+          </a:p>
+          <a:p>
+            <a:endParaRPr lang="en-US" dirty="0"/>
+          </a:p>
+          <a:p>
+            <a:r>
+              <a:rPr lang="en-US" dirty="0"/>
+              <a:t>Ecosystem drivers that are measure with these </a:t>
+            </a:r>
+          </a:p>
+        </p:txBody>
+      </p:sp>
+      <p:sp>
+        <p:nvSpPr>
+          <p:cNvPr id="4" name="Slide Number Placeholder 3"/>
+          <p:cNvSpPr>
+            <a:spLocks noGrp="1"/>
+          </p:cNvSpPr>
+          <p:nvPr>
+            <p:ph type="sldNum" sz="quarter" idx="5"/>
+          </p:nvPr>
+        </p:nvSpPr>
+        <p:spPr/>
+        <p:txBody>
+          <a:bodyPr/>
+          <a:lstStyle/>
+          <a:p>
+            <a:fld id="{BC9AF6F9-19A8-4B2B-96C4-42992BE88AC3}" type="slidenum">
+              <a:rPr lang="en-US" smtClean="0"/>
+              <a:t>55</a:t>
+            </a:fld>
+            <a:endParaRPr lang="en-US"/>
+          </a:p>
+        </p:txBody>
+      </p:sp>
+    </p:spTree>
+    <p:extLst>
+      <p:ext uri="{BB962C8B-B14F-4D97-AF65-F5344CB8AC3E}">
+        <p14:creationId xmlns:p14="http://schemas.microsoft.com/office/powerpoint/2010/main" val="422378332"/>
+      </p:ext>
+    </p:extLst>
+  </p:cSld>
+  <p:clrMapOvr>
+    <a:masterClrMapping/>
+  </p:clrMapOvr>
+</p:notes>
+</file>
+
+<file path=ppt/notesSlides/notesSlide9.xml><?xml version="1.0" encoding="utf-8"?>
+<p:notes xmlns:a="http://schemas.openxmlformats.org/drawingml/2006/main" xmlns:r="http://schemas.openxmlformats.org/officeDocument/2006/relationships" xmlns:p="http://schemas.openxmlformats.org/presentationml/2006/main">
+  <p:cSld>
+    <p:spTree>
+      <p:nvGrpSpPr>
+        <p:cNvPr id="1" name=""/>
+        <p:cNvGrpSpPr/>
+        <p:nvPr/>
+      </p:nvGrpSpPr>
+      <p:grpSpPr>
+        <a:xfrm>
+          <a:off x="0" y="0"/>
+          <a:ext cx="0" cy="0"/>
+          <a:chOff x="0" y="0"/>
+          <a:chExt cx="0" cy="0"/>
+        </a:xfrm>
+      </p:grpSpPr>
+      <p:sp>
+        <p:nvSpPr>
+          <p:cNvPr id="2" name="Slide Image Placeholder 1"/>
+          <p:cNvSpPr>
+            <a:spLocks noGrp="1" noRot="1" noChangeAspect="1"/>
+          </p:cNvSpPr>
+          <p:nvPr>
+            <p:ph type="sldImg"/>
+          </p:nvPr>
+        </p:nvSpPr>
+        <p:spPr/>
+      </p:sp>
+      <p:sp>
+        <p:nvSpPr>
+          <p:cNvPr id="3" name="Notes Placeholder 2"/>
+          <p:cNvSpPr>
+            <a:spLocks noGrp="1"/>
+          </p:cNvSpPr>
+          <p:nvPr>
+            <p:ph type="body" idx="1"/>
+          </p:nvPr>
+        </p:nvSpPr>
+        <p:spPr/>
+        <p:txBody>
+          <a:bodyPr/>
+          <a:lstStyle/>
+          <a:p>
+            <a:r>
+              <a:rPr lang="en-US" dirty="0"/>
+              <a:t>Suggests that hake may be less sensitive to differences in the environment when food and such are generally more abundant and their overall body condition is higher than normal.</a:t>
+            </a:r>
+          </a:p>
+        </p:txBody>
+      </p:sp>
+      <p:sp>
+        <p:nvSpPr>
+          <p:cNvPr id="4" name="Slide Number Placeholder 3"/>
+          <p:cNvSpPr>
+            <a:spLocks noGrp="1"/>
+          </p:cNvSpPr>
+          <p:nvPr>
+            <p:ph type="sldNum" sz="quarter" idx="5"/>
+          </p:nvPr>
+        </p:nvSpPr>
+        <p:spPr/>
+        <p:txBody>
+          <a:bodyPr/>
+          <a:lstStyle/>
+          <a:p>
+            <a:fld id="{BC9AF6F9-19A8-4B2B-96C4-42992BE88AC3}" type="slidenum">
+              <a:rPr lang="en-US" smtClean="0"/>
+              <a:t>56</a:t>
+            </a:fld>
+            <a:endParaRPr lang="en-US"/>
+          </a:p>
+        </p:txBody>
+      </p:sp>
+    </p:spTree>
+    <p:extLst>
+      <p:ext uri="{BB962C8B-B14F-4D97-AF65-F5344CB8AC3E}">
+        <p14:creationId xmlns:p14="http://schemas.microsoft.com/office/powerpoint/2010/main" val="3977632355"/>
       </p:ext>
     </p:extLst>
   </p:cSld>
@@ -8037,6 +8319,36 @@
           </a:p>
         </p:txBody>
       </p:sp>
+      <p:pic>
+        <p:nvPicPr>
+          <p:cNvPr id="5" name="Picture 4">
+            <a:extLst>
+              <a:ext uri="{FF2B5EF4-FFF2-40B4-BE49-F238E27FC236}">
+                <a16:creationId xmlns:a16="http://schemas.microsoft.com/office/drawing/2014/main" id="{2347223C-3D32-6D3C-8E68-A519724ED4CD}"/>
+              </a:ext>
+            </a:extLst>
+          </p:cNvPr>
+          <p:cNvPicPr>
+            <a:picLocks noChangeAspect="1"/>
+          </p:cNvPicPr>
+          <p:nvPr/>
+        </p:nvPicPr>
+        <p:blipFill>
+          <a:blip r:embed="rId2"/>
+          <a:stretch>
+            <a:fillRect/>
+          </a:stretch>
+        </p:blipFill>
+        <p:spPr>
+          <a:xfrm>
+            <a:off x="2750804" y="0"/>
+            <a:ext cx="6690391" cy="6858000"/>
+          </a:xfrm>
+          <a:prstGeom prst="rect">
+            <a:avLst/>
+          </a:prstGeom>
+        </p:spPr>
+      </p:pic>
     </p:spTree>
     <p:extLst>
       <p:ext uri="{BB962C8B-B14F-4D97-AF65-F5344CB8AC3E}">
@@ -8117,6 +8429,36 @@
           </a:p>
         </p:txBody>
       </p:sp>
+      <p:pic>
+        <p:nvPicPr>
+          <p:cNvPr id="5" name="Picture 4">
+            <a:extLst>
+              <a:ext uri="{FF2B5EF4-FFF2-40B4-BE49-F238E27FC236}">
+                <a16:creationId xmlns:a16="http://schemas.microsoft.com/office/drawing/2014/main" id="{CE7D219F-5887-3561-D11F-5843A805357C}"/>
+              </a:ext>
+            </a:extLst>
+          </p:cNvPr>
+          <p:cNvPicPr>
+            <a:picLocks noChangeAspect="1"/>
+          </p:cNvPicPr>
+          <p:nvPr/>
+        </p:nvPicPr>
+        <p:blipFill>
+          <a:blip r:embed="rId2"/>
+          <a:stretch>
+            <a:fillRect/>
+          </a:stretch>
+        </p:blipFill>
+        <p:spPr>
+          <a:xfrm>
+            <a:off x="3515329" y="101600"/>
+            <a:ext cx="6690391" cy="6858000"/>
+          </a:xfrm>
+          <a:prstGeom prst="rect">
+            <a:avLst/>
+          </a:prstGeom>
+        </p:spPr>
+      </p:pic>
     </p:spTree>
     <p:extLst>
       <p:ext uri="{BB962C8B-B14F-4D97-AF65-F5344CB8AC3E}">
@@ -8135,7 +8477,13 @@
   <p:cSld>
     <p:spTree>
       <p:nvGrpSpPr>
-        <p:cNvPr id="1" name=""/>
+        <p:cNvPr id="1" name="">
+          <a:extLst>
+            <a:ext uri="{FF2B5EF4-FFF2-40B4-BE49-F238E27FC236}">
+              <a16:creationId xmlns:a16="http://schemas.microsoft.com/office/drawing/2014/main" id="{85B1DD5E-009E-F3D5-3435-1AB6A85D3794}"/>
+            </a:ext>
+          </a:extLst>
+        </p:cNvPr>
         <p:cNvGrpSpPr/>
         <p:nvPr/>
       </p:nvGrpSpPr>
@@ -8152,7 +8500,7 @@
           <p:cNvPr id="2" name="Title 1">
             <a:extLst>
               <a:ext uri="{FF2B5EF4-FFF2-40B4-BE49-F238E27FC236}">
-                <a16:creationId xmlns:a16="http://schemas.microsoft.com/office/drawing/2014/main" id="{2473313D-9410-7606-DB19-CE63EE0B4B09}"/>
+                <a16:creationId xmlns:a16="http://schemas.microsoft.com/office/drawing/2014/main" id="{B8E12BEF-6637-9E10-48CE-0001A792F74B}"/>
               </a:ext>
             </a:extLst>
           </p:cNvPr>
@@ -8168,7 +8516,10 @@
           <a:bodyPr/>
           <a:lstStyle/>
           <a:p>
-            <a:endParaRPr lang="en-US"/>
+            <a:r>
+              <a:rPr lang="en-US" dirty="0"/>
+              <a:t>Aug-Oct condition with same year seasonal indicators</a:t>
+            </a:r>
           </a:p>
         </p:txBody>
       </p:sp>
@@ -8177,7 +8528,7 @@
           <p:cNvPr id="3" name="Content Placeholder 2">
             <a:extLst>
               <a:ext uri="{FF2B5EF4-FFF2-40B4-BE49-F238E27FC236}">
-                <a16:creationId xmlns:a16="http://schemas.microsoft.com/office/drawing/2014/main" id="{2F30C77D-E59B-5D9E-C679-3B98F968634F}"/>
+                <a16:creationId xmlns:a16="http://schemas.microsoft.com/office/drawing/2014/main" id="{D4AC2A56-C87C-BF4B-106F-A3036BDB3E37}"/>
               </a:ext>
             </a:extLst>
           </p:cNvPr>
@@ -8193,14 +8544,44 @@
           <a:bodyPr/>
           <a:lstStyle/>
           <a:p>
-            <a:endParaRPr lang="en-US"/>
-          </a:p>
-        </p:txBody>
-      </p:sp>
+            <a:endParaRPr lang="en-US" dirty="0"/>
+          </a:p>
+        </p:txBody>
+      </p:sp>
+      <p:pic>
+        <p:nvPicPr>
+          <p:cNvPr id="7" name="Picture 6">
+            <a:extLst>
+              <a:ext uri="{FF2B5EF4-FFF2-40B4-BE49-F238E27FC236}">
+                <a16:creationId xmlns:a16="http://schemas.microsoft.com/office/drawing/2014/main" id="{A693A7A5-957D-711E-3208-EE6C929916DC}"/>
+              </a:ext>
+            </a:extLst>
+          </p:cNvPr>
+          <p:cNvPicPr>
+            <a:picLocks noChangeAspect="1"/>
+          </p:cNvPicPr>
+          <p:nvPr/>
+        </p:nvPicPr>
+        <p:blipFill>
+          <a:blip r:embed="rId2"/>
+          <a:stretch>
+            <a:fillRect/>
+          </a:stretch>
+        </p:blipFill>
+        <p:spPr>
+          <a:xfrm>
+            <a:off x="4559285" y="1027906"/>
+            <a:ext cx="5377196" cy="5511907"/>
+          </a:xfrm>
+          <a:prstGeom prst="rect">
+            <a:avLst/>
+          </a:prstGeom>
+        </p:spPr>
+      </p:pic>
     </p:spTree>
     <p:extLst>
       <p:ext uri="{BB962C8B-B14F-4D97-AF65-F5344CB8AC3E}">
-        <p14:creationId xmlns:p14="http://schemas.microsoft.com/office/powerpoint/2010/main" val="787473245"/>
+        <p14:creationId xmlns:p14="http://schemas.microsoft.com/office/powerpoint/2010/main" val="867286663"/>
       </p:ext>
     </p:extLst>
   </p:cSld>
@@ -8384,6 +8765,86 @@
           <p:cNvPr id="2" name="Title 1">
             <a:extLst>
               <a:ext uri="{FF2B5EF4-FFF2-40B4-BE49-F238E27FC236}">
+                <a16:creationId xmlns:a16="http://schemas.microsoft.com/office/drawing/2014/main" id="{2473313D-9410-7606-DB19-CE63EE0B4B09}"/>
+              </a:ext>
+            </a:extLst>
+          </p:cNvPr>
+          <p:cNvSpPr>
+            <a:spLocks noGrp="1"/>
+          </p:cNvSpPr>
+          <p:nvPr>
+            <p:ph type="title"/>
+          </p:nvPr>
+        </p:nvSpPr>
+        <p:spPr/>
+        <p:txBody>
+          <a:bodyPr/>
+          <a:lstStyle/>
+          <a:p>
+            <a:endParaRPr lang="en-US"/>
+          </a:p>
+        </p:txBody>
+      </p:sp>
+      <p:sp>
+        <p:nvSpPr>
+          <p:cNvPr id="3" name="Content Placeholder 2">
+            <a:extLst>
+              <a:ext uri="{FF2B5EF4-FFF2-40B4-BE49-F238E27FC236}">
+                <a16:creationId xmlns:a16="http://schemas.microsoft.com/office/drawing/2014/main" id="{2F30C77D-E59B-5D9E-C679-3B98F968634F}"/>
+              </a:ext>
+            </a:extLst>
+          </p:cNvPr>
+          <p:cNvSpPr>
+            <a:spLocks noGrp="1"/>
+          </p:cNvSpPr>
+          <p:nvPr>
+            <p:ph idx="1"/>
+          </p:nvPr>
+        </p:nvSpPr>
+        <p:spPr/>
+        <p:txBody>
+          <a:bodyPr/>
+          <a:lstStyle/>
+          <a:p>
+            <a:endParaRPr lang="en-US"/>
+          </a:p>
+        </p:txBody>
+      </p:sp>
+    </p:spTree>
+    <p:extLst>
+      <p:ext uri="{BB962C8B-B14F-4D97-AF65-F5344CB8AC3E}">
+        <p14:creationId xmlns:p14="http://schemas.microsoft.com/office/powerpoint/2010/main" val="787473245"/>
+      </p:ext>
+    </p:extLst>
+  </p:cSld>
+  <p:clrMapOvr>
+    <a:masterClrMapping/>
+  </p:clrMapOvr>
+</p:sld>
+</file>
+
+<file path=ppt/slides/slide41.xml><?xml version="1.0" encoding="utf-8"?>
+<p:sld xmlns:a="http://schemas.openxmlformats.org/drawingml/2006/main" xmlns:r="http://schemas.openxmlformats.org/officeDocument/2006/relationships" xmlns:p="http://schemas.openxmlformats.org/presentationml/2006/main">
+  <p:cSld>
+    <p:spTree>
+      <p:nvGrpSpPr>
+        <p:cNvPr id="1" name=""/>
+        <p:cNvGrpSpPr/>
+        <p:nvPr/>
+      </p:nvGrpSpPr>
+      <p:grpSpPr>
+        <a:xfrm>
+          <a:off x="0" y="0"/>
+          <a:ext cx="0" cy="0"/>
+          <a:chOff x="0" y="0"/>
+          <a:chExt cx="0" cy="0"/>
+        </a:xfrm>
+      </p:grpSpPr>
+      <p:sp>
+        <p:nvSpPr>
+          <p:cNvPr id="2" name="Title 1">
+            <a:extLst>
+              <a:ext uri="{FF2B5EF4-FFF2-40B4-BE49-F238E27FC236}">
                 <a16:creationId xmlns:a16="http://schemas.microsoft.com/office/drawing/2014/main" id="{17F016EE-8CCC-98C7-EBF4-3DD8648C6038}"/>
               </a:ext>
             </a:extLst>
@@ -8442,7 +8903,7 @@
 </p:sld>
 </file>
 
-<file path=ppt/slides/slide41.xml><?xml version="1.0" encoding="utf-8"?>
+<file path=ppt/slides/slide42.xml><?xml version="1.0" encoding="utf-8"?>
 <p:sld xmlns:a="http://schemas.openxmlformats.org/drawingml/2006/main" xmlns:r="http://schemas.openxmlformats.org/officeDocument/2006/relationships" xmlns:p="http://schemas.openxmlformats.org/presentationml/2006/main">
   <p:cSld>
     <p:spTree>
@@ -8564,7 +9025,7 @@
 </p:sld>
 </file>
 
-<file path=ppt/slides/slide42.xml><?xml version="1.0" encoding="utf-8"?>
+<file path=ppt/slides/slide43.xml><?xml version="1.0" encoding="utf-8"?>
 <p:sld xmlns:a="http://schemas.openxmlformats.org/drawingml/2006/main" xmlns:r="http://schemas.openxmlformats.org/officeDocument/2006/relationships" xmlns:p="http://schemas.openxmlformats.org/presentationml/2006/main">
   <p:cSld>
     <p:spTree>
@@ -8647,7 +9108,7 @@
 </p:sld>
 </file>
 
-<file path=ppt/slides/slide43.xml><?xml version="1.0" encoding="utf-8"?>
+<file path=ppt/slides/slide44.xml><?xml version="1.0" encoding="utf-8"?>
 <p:sld xmlns:a="http://schemas.openxmlformats.org/drawingml/2006/main" xmlns:r="http://schemas.openxmlformats.org/officeDocument/2006/relationships" xmlns:p="http://schemas.openxmlformats.org/presentationml/2006/main">
   <p:cSld>
     <p:spTree>
@@ -8757,7 +9218,7 @@
 </p:sld>
 </file>
 
-<file path=ppt/slides/slide44.xml><?xml version="1.0" encoding="utf-8"?>
+<file path=ppt/slides/slide45.xml><?xml version="1.0" encoding="utf-8"?>
 <p:sld xmlns:a="http://schemas.openxmlformats.org/drawingml/2006/main" xmlns:r="http://schemas.openxmlformats.org/officeDocument/2006/relationships" xmlns:p="http://schemas.openxmlformats.org/presentationml/2006/main">
   <p:cSld>
     <p:spTree>
@@ -8867,7 +9328,7 @@
 </p:sld>
 </file>
 
-<file path=ppt/slides/slide45.xml><?xml version="1.0" encoding="utf-8"?>
+<file path=ppt/slides/slide46.xml><?xml version="1.0" encoding="utf-8"?>
 <p:sld xmlns:a="http://schemas.openxmlformats.org/drawingml/2006/main" xmlns:r="http://schemas.openxmlformats.org/officeDocument/2006/relationships" xmlns:p="http://schemas.openxmlformats.org/presentationml/2006/main">
   <p:cSld>
     <p:spTree>
@@ -8977,7 +9438,7 @@
 </p:sld>
 </file>
 
-<file path=ppt/slides/slide46.xml><?xml version="1.0" encoding="utf-8"?>
+<file path=ppt/slides/slide47.xml><?xml version="1.0" encoding="utf-8"?>
 <p:sld xmlns:a="http://schemas.openxmlformats.org/drawingml/2006/main" xmlns:r="http://schemas.openxmlformats.org/officeDocument/2006/relationships" xmlns:p="http://schemas.openxmlformats.org/presentationml/2006/main">
   <p:cSld>
     <p:spTree>
@@ -9057,7 +9518,7 @@
 </p:sld>
 </file>
 
-<file path=ppt/slides/slide47.xml><?xml version="1.0" encoding="utf-8"?>
+<file path=ppt/slides/slide48.xml><?xml version="1.0" encoding="utf-8"?>
 <p:sld xmlns:a="http://schemas.openxmlformats.org/drawingml/2006/main" xmlns:r="http://schemas.openxmlformats.org/officeDocument/2006/relationships" xmlns:p="http://schemas.openxmlformats.org/presentationml/2006/main">
   <p:cSld>
     <p:spTree>
@@ -9167,7 +9628,7 @@
 </p:sld>
 </file>
 
-<file path=ppt/slides/slide48.xml><?xml version="1.0" encoding="utf-8"?>
+<file path=ppt/slides/slide49.xml><?xml version="1.0" encoding="utf-8"?>
 <p:sld xmlns:a="http://schemas.openxmlformats.org/drawingml/2006/main" xmlns:r="http://schemas.openxmlformats.org/officeDocument/2006/relationships" xmlns:p="http://schemas.openxmlformats.org/presentationml/2006/main">
   <p:cSld>
     <p:spTree>
@@ -9310,116 +9771,6 @@
 </p:sld>
 </file>
 
-<file path=ppt/slides/slide49.xml><?xml version="1.0" encoding="utf-8"?>
-<p:sld xmlns:a="http://schemas.openxmlformats.org/drawingml/2006/main" xmlns:r="http://schemas.openxmlformats.org/officeDocument/2006/relationships" xmlns:p="http://schemas.openxmlformats.org/presentationml/2006/main">
-  <p:cSld>
-    <p:spTree>
-      <p:nvGrpSpPr>
-        <p:cNvPr id="1" name=""/>
-        <p:cNvGrpSpPr/>
-        <p:nvPr/>
-      </p:nvGrpSpPr>
-      <p:grpSpPr>
-        <a:xfrm>
-          <a:off x="0" y="0"/>
-          <a:ext cx="0" cy="0"/>
-          <a:chOff x="0" y="0"/>
-          <a:chExt cx="0" cy="0"/>
-        </a:xfrm>
-      </p:grpSpPr>
-      <p:sp>
-        <p:nvSpPr>
-          <p:cNvPr id="2" name="Title 1">
-            <a:extLst>
-              <a:ext uri="{FF2B5EF4-FFF2-40B4-BE49-F238E27FC236}">
-                <a16:creationId xmlns:a16="http://schemas.microsoft.com/office/drawing/2014/main" id="{3158255A-61DF-05D3-DC34-C85BF9EEBCD0}"/>
-              </a:ext>
-            </a:extLst>
-          </p:cNvPr>
-          <p:cNvSpPr>
-            <a:spLocks noGrp="1"/>
-          </p:cNvSpPr>
-          <p:nvPr>
-            <p:ph type="title"/>
-          </p:nvPr>
-        </p:nvSpPr>
-        <p:spPr/>
-        <p:txBody>
-          <a:bodyPr/>
-          <a:lstStyle/>
-          <a:p>
-            <a:endParaRPr lang="en-US"/>
-          </a:p>
-        </p:txBody>
-      </p:sp>
-      <p:sp>
-        <p:nvSpPr>
-          <p:cNvPr id="3" name="Content Placeholder 2">
-            <a:extLst>
-              <a:ext uri="{FF2B5EF4-FFF2-40B4-BE49-F238E27FC236}">
-                <a16:creationId xmlns:a16="http://schemas.microsoft.com/office/drawing/2014/main" id="{E853F5FE-D531-5780-2EC3-B39CF2B67FB2}"/>
-              </a:ext>
-            </a:extLst>
-          </p:cNvPr>
-          <p:cNvSpPr>
-            <a:spLocks noGrp="1"/>
-          </p:cNvSpPr>
-          <p:nvPr>
-            <p:ph idx="1"/>
-          </p:nvPr>
-        </p:nvSpPr>
-        <p:spPr/>
-        <p:txBody>
-          <a:bodyPr/>
-          <a:lstStyle/>
-          <a:p>
-            <a:endParaRPr lang="en-US"/>
-          </a:p>
-        </p:txBody>
-      </p:sp>
-      <p:pic>
-        <p:nvPicPr>
-          <p:cNvPr id="5" name="Picture 4">
-            <a:extLst>
-              <a:ext uri="{FF2B5EF4-FFF2-40B4-BE49-F238E27FC236}">
-                <a16:creationId xmlns:a16="http://schemas.microsoft.com/office/drawing/2014/main" id="{1AC09531-393B-FA8E-BC4F-FDEB86BBEAF5}"/>
-              </a:ext>
-            </a:extLst>
-          </p:cNvPr>
-          <p:cNvPicPr>
-            <a:picLocks noChangeAspect="1"/>
-          </p:cNvPicPr>
-          <p:nvPr/>
-        </p:nvPicPr>
-        <p:blipFill>
-          <a:blip r:embed="rId2"/>
-          <a:stretch>
-            <a:fillRect/>
-          </a:stretch>
-        </p:blipFill>
-        <p:spPr>
-          <a:xfrm>
-            <a:off x="619432" y="1506028"/>
-            <a:ext cx="10087897" cy="4986847"/>
-          </a:xfrm>
-          <a:prstGeom prst="rect">
-            <a:avLst/>
-          </a:prstGeom>
-        </p:spPr>
-      </p:pic>
-    </p:spTree>
-    <p:extLst>
-      <p:ext uri="{BB962C8B-B14F-4D97-AF65-F5344CB8AC3E}">
-        <p14:creationId xmlns:p14="http://schemas.microsoft.com/office/powerpoint/2010/main" val="1601108405"/>
-      </p:ext>
-    </p:extLst>
-  </p:cSld>
-  <p:clrMapOvr>
-    <a:masterClrMapping/>
-  </p:clrMapOvr>
-</p:sld>
-</file>
-
 <file path=ppt/slides/slide5.xml><?xml version="1.0" encoding="utf-8"?>
 <p:sld xmlns:a="http://schemas.openxmlformats.org/drawingml/2006/main" xmlns:r="http://schemas.openxmlformats.org/officeDocument/2006/relationships" xmlns:p="http://schemas.openxmlformats.org/presentationml/2006/main">
   <p:cSld>
@@ -9536,7 +9887,7 @@
           <p:cNvPr id="2" name="Title 1">
             <a:extLst>
               <a:ext uri="{FF2B5EF4-FFF2-40B4-BE49-F238E27FC236}">
-                <a16:creationId xmlns:a16="http://schemas.microsoft.com/office/drawing/2014/main" id="{1B4F899D-7172-97F0-AEB9-22F23528885F}"/>
+                <a16:creationId xmlns:a16="http://schemas.microsoft.com/office/drawing/2014/main" id="{3158255A-61DF-05D3-DC34-C85BF9EEBCD0}"/>
               </a:ext>
             </a:extLst>
           </p:cNvPr>
@@ -9561,7 +9912,7 @@
           <p:cNvPr id="3" name="Content Placeholder 2">
             <a:extLst>
               <a:ext uri="{FF2B5EF4-FFF2-40B4-BE49-F238E27FC236}">
-                <a16:creationId xmlns:a16="http://schemas.microsoft.com/office/drawing/2014/main" id="{97E331C5-05F1-E46E-09B0-CA9D5E9401D7}"/>
+                <a16:creationId xmlns:a16="http://schemas.microsoft.com/office/drawing/2014/main" id="{E853F5FE-D531-5780-2EC3-B39CF2B67FB2}"/>
               </a:ext>
             </a:extLst>
           </p:cNvPr>
@@ -9581,10 +9932,40 @@
           </a:p>
         </p:txBody>
       </p:sp>
+      <p:pic>
+        <p:nvPicPr>
+          <p:cNvPr id="5" name="Picture 4">
+            <a:extLst>
+              <a:ext uri="{FF2B5EF4-FFF2-40B4-BE49-F238E27FC236}">
+                <a16:creationId xmlns:a16="http://schemas.microsoft.com/office/drawing/2014/main" id="{1AC09531-393B-FA8E-BC4F-FDEB86BBEAF5}"/>
+              </a:ext>
+            </a:extLst>
+          </p:cNvPr>
+          <p:cNvPicPr>
+            <a:picLocks noChangeAspect="1"/>
+          </p:cNvPicPr>
+          <p:nvPr/>
+        </p:nvPicPr>
+        <p:blipFill>
+          <a:blip r:embed="rId2"/>
+          <a:stretch>
+            <a:fillRect/>
+          </a:stretch>
+        </p:blipFill>
+        <p:spPr>
+          <a:xfrm>
+            <a:off x="619432" y="1506028"/>
+            <a:ext cx="10087897" cy="4986847"/>
+          </a:xfrm>
+          <a:prstGeom prst="rect">
+            <a:avLst/>
+          </a:prstGeom>
+        </p:spPr>
+      </p:pic>
     </p:spTree>
     <p:extLst>
       <p:ext uri="{BB962C8B-B14F-4D97-AF65-F5344CB8AC3E}">
-        <p14:creationId xmlns:p14="http://schemas.microsoft.com/office/powerpoint/2010/main" val="387653240"/>
+        <p14:creationId xmlns:p14="http://schemas.microsoft.com/office/powerpoint/2010/main" val="1601108405"/>
       </p:ext>
     </p:extLst>
   </p:cSld>
@@ -9616,6 +9997,86 @@
           <p:cNvPr id="2" name="Title 1">
             <a:extLst>
               <a:ext uri="{FF2B5EF4-FFF2-40B4-BE49-F238E27FC236}">
+                <a16:creationId xmlns:a16="http://schemas.microsoft.com/office/drawing/2014/main" id="{1B4F899D-7172-97F0-AEB9-22F23528885F}"/>
+              </a:ext>
+            </a:extLst>
+          </p:cNvPr>
+          <p:cNvSpPr>
+            <a:spLocks noGrp="1"/>
+          </p:cNvSpPr>
+          <p:nvPr>
+            <p:ph type="title"/>
+          </p:nvPr>
+        </p:nvSpPr>
+        <p:spPr/>
+        <p:txBody>
+          <a:bodyPr/>
+          <a:lstStyle/>
+          <a:p>
+            <a:endParaRPr lang="en-US"/>
+          </a:p>
+        </p:txBody>
+      </p:sp>
+      <p:sp>
+        <p:nvSpPr>
+          <p:cNvPr id="3" name="Content Placeholder 2">
+            <a:extLst>
+              <a:ext uri="{FF2B5EF4-FFF2-40B4-BE49-F238E27FC236}">
+                <a16:creationId xmlns:a16="http://schemas.microsoft.com/office/drawing/2014/main" id="{97E331C5-05F1-E46E-09B0-CA9D5E9401D7}"/>
+              </a:ext>
+            </a:extLst>
+          </p:cNvPr>
+          <p:cNvSpPr>
+            <a:spLocks noGrp="1"/>
+          </p:cNvSpPr>
+          <p:nvPr>
+            <p:ph idx="1"/>
+          </p:nvPr>
+        </p:nvSpPr>
+        <p:spPr/>
+        <p:txBody>
+          <a:bodyPr/>
+          <a:lstStyle/>
+          <a:p>
+            <a:endParaRPr lang="en-US"/>
+          </a:p>
+        </p:txBody>
+      </p:sp>
+    </p:spTree>
+    <p:extLst>
+      <p:ext uri="{BB962C8B-B14F-4D97-AF65-F5344CB8AC3E}">
+        <p14:creationId xmlns:p14="http://schemas.microsoft.com/office/powerpoint/2010/main" val="387653240"/>
+      </p:ext>
+    </p:extLst>
+  </p:cSld>
+  <p:clrMapOvr>
+    <a:masterClrMapping/>
+  </p:clrMapOvr>
+</p:sld>
+</file>
+
+<file path=ppt/slides/slide52.xml><?xml version="1.0" encoding="utf-8"?>
+<p:sld xmlns:a="http://schemas.openxmlformats.org/drawingml/2006/main" xmlns:r="http://schemas.openxmlformats.org/officeDocument/2006/relationships" xmlns:p="http://schemas.openxmlformats.org/presentationml/2006/main">
+  <p:cSld>
+    <p:spTree>
+      <p:nvGrpSpPr>
+        <p:cNvPr id="1" name=""/>
+        <p:cNvGrpSpPr/>
+        <p:nvPr/>
+      </p:nvGrpSpPr>
+      <p:grpSpPr>
+        <a:xfrm>
+          <a:off x="0" y="0"/>
+          <a:ext cx="0" cy="0"/>
+          <a:chOff x="0" y="0"/>
+          <a:chExt cx="0" cy="0"/>
+        </a:xfrm>
+      </p:grpSpPr>
+      <p:sp>
+        <p:nvSpPr>
+          <p:cNvPr id="2" name="Title 1">
+            <a:extLst>
+              <a:ext uri="{FF2B5EF4-FFF2-40B4-BE49-F238E27FC236}">
                 <a16:creationId xmlns:a16="http://schemas.microsoft.com/office/drawing/2014/main" id="{8283EF55-EB33-0AE4-2506-D01C6C8E560B}"/>
               </a:ext>
             </a:extLst>
@@ -9665,6 +10126,836 @@
     <p:extLst>
       <p:ext uri="{BB962C8B-B14F-4D97-AF65-F5344CB8AC3E}">
         <p14:creationId xmlns:p14="http://schemas.microsoft.com/office/powerpoint/2010/main" val="3603619897"/>
+      </p:ext>
+    </p:extLst>
+  </p:cSld>
+  <p:clrMapOvr>
+    <a:masterClrMapping/>
+  </p:clrMapOvr>
+</p:sld>
+</file>
+
+<file path=ppt/slides/slide53.xml><?xml version="1.0" encoding="utf-8"?>
+<p:sld xmlns:a="http://schemas.openxmlformats.org/drawingml/2006/main" xmlns:r="http://schemas.openxmlformats.org/officeDocument/2006/relationships" xmlns:p="http://schemas.openxmlformats.org/presentationml/2006/main">
+  <p:cSld>
+    <p:spTree>
+      <p:nvGrpSpPr>
+        <p:cNvPr id="1" name=""/>
+        <p:cNvGrpSpPr/>
+        <p:nvPr/>
+      </p:nvGrpSpPr>
+      <p:grpSpPr>
+        <a:xfrm>
+          <a:off x="0" y="0"/>
+          <a:ext cx="0" cy="0"/>
+          <a:chOff x="0" y="0"/>
+          <a:chExt cx="0" cy="0"/>
+        </a:xfrm>
+      </p:grpSpPr>
+      <p:sp>
+        <p:nvSpPr>
+          <p:cNvPr id="2" name="Title 1">
+            <a:extLst>
+              <a:ext uri="{FF2B5EF4-FFF2-40B4-BE49-F238E27FC236}">
+                <a16:creationId xmlns:a16="http://schemas.microsoft.com/office/drawing/2014/main" id="{959CF5EB-F128-4451-60D6-6B1DEF6E1205}"/>
+              </a:ext>
+            </a:extLst>
+          </p:cNvPr>
+          <p:cNvSpPr>
+            <a:spLocks noGrp="1"/>
+          </p:cNvSpPr>
+          <p:nvPr>
+            <p:ph type="title"/>
+          </p:nvPr>
+        </p:nvSpPr>
+        <p:spPr/>
+        <p:txBody>
+          <a:bodyPr/>
+          <a:lstStyle/>
+          <a:p>
+            <a:r>
+              <a:rPr lang="en-US" dirty="0"/>
+              <a:t>Slides for Andy</a:t>
+            </a:r>
+          </a:p>
+        </p:txBody>
+      </p:sp>
+      <p:sp>
+        <p:nvSpPr>
+          <p:cNvPr id="3" name="Content Placeholder 2">
+            <a:extLst>
+              <a:ext uri="{FF2B5EF4-FFF2-40B4-BE49-F238E27FC236}">
+                <a16:creationId xmlns:a16="http://schemas.microsoft.com/office/drawing/2014/main" id="{8031EB6E-6B9E-DBFA-998E-8B9668CD4B25}"/>
+              </a:ext>
+            </a:extLst>
+          </p:cNvPr>
+          <p:cNvSpPr>
+            <a:spLocks noGrp="1"/>
+          </p:cNvSpPr>
+          <p:nvPr>
+            <p:ph idx="1"/>
+          </p:nvPr>
+        </p:nvSpPr>
+        <p:spPr/>
+        <p:txBody>
+          <a:bodyPr/>
+          <a:lstStyle/>
+          <a:p>
+            <a:endParaRPr lang="en-US"/>
+          </a:p>
+        </p:txBody>
+      </p:sp>
+    </p:spTree>
+    <p:extLst>
+      <p:ext uri="{BB962C8B-B14F-4D97-AF65-F5344CB8AC3E}">
+        <p14:creationId xmlns:p14="http://schemas.microsoft.com/office/powerpoint/2010/main" val="3092105910"/>
+      </p:ext>
+    </p:extLst>
+  </p:cSld>
+  <p:clrMapOvr>
+    <a:masterClrMapping/>
+  </p:clrMapOvr>
+</p:sld>
+</file>
+
+<file path=ppt/slides/slide54.xml><?xml version="1.0" encoding="utf-8"?>
+<p:sld xmlns:a="http://schemas.openxmlformats.org/drawingml/2006/main" xmlns:r="http://schemas.openxmlformats.org/officeDocument/2006/relationships" xmlns:p="http://schemas.openxmlformats.org/presentationml/2006/main">
+  <p:cSld>
+    <p:spTree>
+      <p:nvGrpSpPr>
+        <p:cNvPr id="1" name=""/>
+        <p:cNvGrpSpPr/>
+        <p:nvPr/>
+      </p:nvGrpSpPr>
+      <p:grpSpPr>
+        <a:xfrm>
+          <a:off x="0" y="0"/>
+          <a:ext cx="0" cy="0"/>
+          <a:chOff x="0" y="0"/>
+          <a:chExt cx="0" cy="0"/>
+        </a:xfrm>
+      </p:grpSpPr>
+      <p:sp>
+        <p:nvSpPr>
+          <p:cNvPr id="2" name="Title 1">
+            <a:extLst>
+              <a:ext uri="{FF2B5EF4-FFF2-40B4-BE49-F238E27FC236}">
+                <a16:creationId xmlns:a16="http://schemas.microsoft.com/office/drawing/2014/main" id="{49488999-1CA3-00B5-34D6-1EC8BEC338BC}"/>
+              </a:ext>
+            </a:extLst>
+          </p:cNvPr>
+          <p:cNvSpPr>
+            <a:spLocks noGrp="1"/>
+          </p:cNvSpPr>
+          <p:nvPr>
+            <p:ph type="title"/>
+          </p:nvPr>
+        </p:nvSpPr>
+        <p:spPr/>
+        <p:txBody>
+          <a:bodyPr/>
+          <a:lstStyle/>
+          <a:p>
+            <a:r>
+              <a:rPr lang="en-US" dirty="0"/>
+              <a:t>Le </a:t>
+            </a:r>
+            <a:r>
+              <a:rPr lang="en-US" dirty="0" err="1"/>
+              <a:t>Cren’s</a:t>
+            </a:r>
+            <a:r>
+              <a:rPr lang="en-US" dirty="0"/>
+              <a:t> body condition</a:t>
+            </a:r>
+          </a:p>
+        </p:txBody>
+      </p:sp>
+      <p:sp>
+        <p:nvSpPr>
+          <p:cNvPr id="3" name="Content Placeholder 2">
+            <a:extLst>
+              <a:ext uri="{FF2B5EF4-FFF2-40B4-BE49-F238E27FC236}">
+                <a16:creationId xmlns:a16="http://schemas.microsoft.com/office/drawing/2014/main" id="{CAC8E92A-FFD1-AA93-B882-AEB15BE45C8B}"/>
+              </a:ext>
+            </a:extLst>
+          </p:cNvPr>
+          <p:cNvSpPr>
+            <a:spLocks noGrp="1"/>
+          </p:cNvSpPr>
+          <p:nvPr>
+            <p:ph idx="1"/>
+          </p:nvPr>
+        </p:nvSpPr>
+        <p:spPr>
+          <a:xfrm>
+            <a:off x="838200" y="1825625"/>
+            <a:ext cx="4688840" cy="4351338"/>
+          </a:xfrm>
+        </p:spPr>
+        <p:txBody>
+          <a:bodyPr>
+            <a:normAutofit lnSpcReduction="10000"/>
+          </a:bodyPr>
+          <a:lstStyle/>
+          <a:p>
+            <a:r>
+              <a:rPr lang="en-US" sz="2000" dirty="0"/>
+              <a:t>Model the length-weight relationship and the parameters </a:t>
+            </a:r>
+            <a:r>
+              <a:rPr lang="en-US" sz="2000" i="1" dirty="0"/>
+              <a:t>a</a:t>
+            </a:r>
+            <a:r>
+              <a:rPr lang="en-US" sz="2000" dirty="0"/>
+              <a:t> and </a:t>
+            </a:r>
+            <a:r>
+              <a:rPr lang="en-US" sz="2000" i="1" dirty="0"/>
+              <a:t>b</a:t>
+            </a:r>
+            <a:r>
+              <a:rPr lang="en-US" sz="2000" dirty="0"/>
+              <a:t>:</a:t>
+            </a:r>
+          </a:p>
+          <a:p>
+            <a:pPr marL="457200" lvl="1" indent="0">
+              <a:buNone/>
+            </a:pPr>
+            <a:endParaRPr lang="en-US" sz="1800" dirty="0"/>
+          </a:p>
+          <a:p>
+            <a:pPr marL="457200" lvl="1" indent="0">
+              <a:buNone/>
+            </a:pPr>
+            <a:r>
+              <a:rPr lang="en-US" sz="1800" i="1" dirty="0"/>
+              <a:t>W = </a:t>
+            </a:r>
+            <a:r>
+              <a:rPr lang="en-US" sz="1800" i="1" dirty="0" err="1"/>
+              <a:t>aL^b</a:t>
+            </a:r>
+            <a:endParaRPr lang="en-US" sz="1800" i="1" dirty="0"/>
+          </a:p>
+          <a:p>
+            <a:endParaRPr lang="en-US" sz="2000" dirty="0"/>
+          </a:p>
+          <a:p>
+            <a:r>
+              <a:rPr lang="en-US" sz="2000" dirty="0"/>
+              <a:t>Use the a and b parameters to estimate expected weight W`, and body condition, K, as:</a:t>
+            </a:r>
+          </a:p>
+          <a:p>
+            <a:endParaRPr lang="en-US" sz="2000" dirty="0"/>
+          </a:p>
+          <a:p>
+            <a:pPr marL="457200" lvl="1" indent="0">
+              <a:buNone/>
+            </a:pPr>
+            <a:r>
+              <a:rPr lang="en-US" sz="1800" dirty="0"/>
+              <a:t>K = </a:t>
+            </a:r>
+            <a:r>
+              <a:rPr lang="en-US" sz="1800" dirty="0" err="1"/>
+              <a:t>W</a:t>
+            </a:r>
+            <a:r>
+              <a:rPr lang="en-US" sz="1800" baseline="-25000" dirty="0" err="1"/>
+              <a:t>obs</a:t>
+            </a:r>
+            <a:r>
+              <a:rPr lang="en-US" sz="1800" dirty="0"/>
+              <a:t> / W`</a:t>
+            </a:r>
+          </a:p>
+          <a:p>
+            <a:endParaRPr lang="en-US" sz="2000" dirty="0"/>
+          </a:p>
+          <a:p>
+            <a:r>
+              <a:rPr lang="en-US" sz="2000" dirty="0"/>
+              <a:t>Lower body condition in spring, higher in late summer</a:t>
+            </a:r>
+          </a:p>
+        </p:txBody>
+      </p:sp>
+      <p:pic>
+        <p:nvPicPr>
+          <p:cNvPr id="16" name="Picture 15">
+            <a:extLst>
+              <a:ext uri="{FF2B5EF4-FFF2-40B4-BE49-F238E27FC236}">
+                <a16:creationId xmlns:a16="http://schemas.microsoft.com/office/drawing/2014/main" id="{F1CB0425-7666-0F35-553D-1B606B7FBF13}"/>
+              </a:ext>
+            </a:extLst>
+          </p:cNvPr>
+          <p:cNvPicPr>
+            <a:picLocks noChangeAspect="1"/>
+          </p:cNvPicPr>
+          <p:nvPr/>
+        </p:nvPicPr>
+        <p:blipFill>
+          <a:blip r:embed="rId3"/>
+          <a:stretch>
+            <a:fillRect/>
+          </a:stretch>
+        </p:blipFill>
+        <p:spPr>
+          <a:xfrm>
+            <a:off x="7714974" y="727849"/>
+            <a:ext cx="4217946" cy="2789764"/>
+          </a:xfrm>
+          <a:prstGeom prst="rect">
+            <a:avLst/>
+          </a:prstGeom>
+        </p:spPr>
+      </p:pic>
+      <p:sp>
+        <p:nvSpPr>
+          <p:cNvPr id="8" name="TextBox 7">
+            <a:extLst>
+              <a:ext uri="{FF2B5EF4-FFF2-40B4-BE49-F238E27FC236}">
+                <a16:creationId xmlns:a16="http://schemas.microsoft.com/office/drawing/2014/main" id="{8F5C1752-7920-5809-E850-CC6D6F3854CC}"/>
+              </a:ext>
+            </a:extLst>
+          </p:cNvPr>
+          <p:cNvSpPr txBox="1"/>
+          <p:nvPr/>
+        </p:nvSpPr>
+        <p:spPr>
+          <a:xfrm>
+            <a:off x="8524568" y="1286540"/>
+            <a:ext cx="1027845" cy="584775"/>
+          </a:xfrm>
+          <a:prstGeom prst="rect">
+            <a:avLst/>
+          </a:prstGeom>
+          <a:noFill/>
+        </p:spPr>
+        <p:txBody>
+          <a:bodyPr wrap="none" rtlCol="0">
+            <a:spAutoFit/>
+          </a:bodyPr>
+          <a:lstStyle/>
+          <a:p>
+            <a:r>
+              <a:rPr lang="en-US" sz="1600" dirty="0"/>
+              <a:t>Good </a:t>
+            </a:r>
+          </a:p>
+          <a:p>
+            <a:r>
+              <a:rPr lang="en-US" sz="1600" dirty="0"/>
+              <a:t>condition</a:t>
+            </a:r>
+          </a:p>
+        </p:txBody>
+      </p:sp>
+      <p:sp>
+        <p:nvSpPr>
+          <p:cNvPr id="10" name="TextBox 9">
+            <a:extLst>
+              <a:ext uri="{FF2B5EF4-FFF2-40B4-BE49-F238E27FC236}">
+                <a16:creationId xmlns:a16="http://schemas.microsoft.com/office/drawing/2014/main" id="{FC504361-0837-DFC5-FB97-FA7A44D90751}"/>
+              </a:ext>
+            </a:extLst>
+          </p:cNvPr>
+          <p:cNvSpPr txBox="1"/>
+          <p:nvPr/>
+        </p:nvSpPr>
+        <p:spPr>
+          <a:xfrm>
+            <a:off x="9823947" y="2402076"/>
+            <a:ext cx="1027845" cy="584775"/>
+          </a:xfrm>
+          <a:prstGeom prst="rect">
+            <a:avLst/>
+          </a:prstGeom>
+          <a:noFill/>
+        </p:spPr>
+        <p:txBody>
+          <a:bodyPr wrap="none" rtlCol="0">
+            <a:spAutoFit/>
+          </a:bodyPr>
+          <a:lstStyle/>
+          <a:p>
+            <a:r>
+              <a:rPr lang="en-US" sz="1600" dirty="0"/>
+              <a:t>Poor </a:t>
+            </a:r>
+          </a:p>
+          <a:p>
+            <a:r>
+              <a:rPr lang="en-US" sz="1600" dirty="0"/>
+              <a:t>condition</a:t>
+            </a:r>
+          </a:p>
+        </p:txBody>
+      </p:sp>
+      <p:pic>
+        <p:nvPicPr>
+          <p:cNvPr id="18" name="Picture 17">
+            <a:extLst>
+              <a:ext uri="{FF2B5EF4-FFF2-40B4-BE49-F238E27FC236}">
+                <a16:creationId xmlns:a16="http://schemas.microsoft.com/office/drawing/2014/main" id="{C5DBE00D-5A01-D6A0-1B68-7A22AE0386AE}"/>
+              </a:ext>
+            </a:extLst>
+          </p:cNvPr>
+          <p:cNvPicPr>
+            <a:picLocks noChangeAspect="1"/>
+          </p:cNvPicPr>
+          <p:nvPr/>
+        </p:nvPicPr>
+        <p:blipFill>
+          <a:blip r:embed="rId4"/>
+          <a:stretch>
+            <a:fillRect/>
+          </a:stretch>
+        </p:blipFill>
+        <p:spPr>
+          <a:xfrm>
+            <a:off x="5770881" y="3591692"/>
+            <a:ext cx="6228080" cy="3225668"/>
+          </a:xfrm>
+          <a:prstGeom prst="rect">
+            <a:avLst/>
+          </a:prstGeom>
+        </p:spPr>
+      </p:pic>
+    </p:spTree>
+    <p:extLst>
+      <p:ext uri="{BB962C8B-B14F-4D97-AF65-F5344CB8AC3E}">
+        <p14:creationId xmlns:p14="http://schemas.microsoft.com/office/powerpoint/2010/main" val="1262578990"/>
+      </p:ext>
+    </p:extLst>
+  </p:cSld>
+  <p:clrMapOvr>
+    <a:masterClrMapping/>
+  </p:clrMapOvr>
+</p:sld>
+</file>
+
+<file path=ppt/slides/slide55.xml><?xml version="1.0" encoding="utf-8"?>
+<p:sld xmlns:a="http://schemas.openxmlformats.org/drawingml/2006/main" xmlns:r="http://schemas.openxmlformats.org/officeDocument/2006/relationships" xmlns:p="http://schemas.openxmlformats.org/presentationml/2006/main">
+  <p:cSld>
+    <p:spTree>
+      <p:nvGrpSpPr>
+        <p:cNvPr id="1" name=""/>
+        <p:cNvGrpSpPr/>
+        <p:nvPr/>
+      </p:nvGrpSpPr>
+      <p:grpSpPr>
+        <a:xfrm>
+          <a:off x="0" y="0"/>
+          <a:ext cx="0" cy="0"/>
+          <a:chOff x="0" y="0"/>
+          <a:chExt cx="0" cy="0"/>
+        </a:xfrm>
+      </p:grpSpPr>
+      <p:sp>
+        <p:nvSpPr>
+          <p:cNvPr id="2" name="Title 1">
+            <a:extLst>
+              <a:ext uri="{FF2B5EF4-FFF2-40B4-BE49-F238E27FC236}">
+                <a16:creationId xmlns:a16="http://schemas.microsoft.com/office/drawing/2014/main" id="{324E614A-5CBB-3D74-9673-22B7C4307C31}"/>
+              </a:ext>
+            </a:extLst>
+          </p:cNvPr>
+          <p:cNvSpPr>
+            <a:spLocks noGrp="1"/>
+          </p:cNvSpPr>
+          <p:nvPr>
+            <p:ph type="title"/>
+          </p:nvPr>
+        </p:nvSpPr>
+        <p:spPr/>
+        <p:txBody>
+          <a:bodyPr/>
+          <a:lstStyle/>
+          <a:p>
+            <a:r>
+              <a:rPr lang="en-US" dirty="0"/>
+              <a:t>Spring body condition</a:t>
+            </a:r>
+          </a:p>
+        </p:txBody>
+      </p:sp>
+      <p:sp>
+        <p:nvSpPr>
+          <p:cNvPr id="3" name="Content Placeholder 2">
+            <a:extLst>
+              <a:ext uri="{FF2B5EF4-FFF2-40B4-BE49-F238E27FC236}">
+                <a16:creationId xmlns:a16="http://schemas.microsoft.com/office/drawing/2014/main" id="{54F1D035-F7F4-EA0D-E76A-E9FE2C65D7F5}"/>
+              </a:ext>
+            </a:extLst>
+          </p:cNvPr>
+          <p:cNvSpPr>
+            <a:spLocks noGrp="1"/>
+          </p:cNvSpPr>
+          <p:nvPr>
+            <p:ph idx="1"/>
+          </p:nvPr>
+        </p:nvSpPr>
+        <p:spPr>
+          <a:xfrm>
+            <a:off x="838200" y="1825625"/>
+            <a:ext cx="5521960" cy="4351338"/>
+          </a:xfrm>
+        </p:spPr>
+        <p:txBody>
+          <a:bodyPr>
+            <a:normAutofit/>
+          </a:bodyPr>
+          <a:lstStyle/>
+          <a:p>
+            <a:r>
+              <a:rPr lang="en-US" dirty="0"/>
+              <a:t>Environmental indices stored in </a:t>
+            </a:r>
+            <a:r>
+              <a:rPr lang="en-US" dirty="0" err="1"/>
+              <a:t>pacea</a:t>
+            </a:r>
+            <a:r>
+              <a:rPr lang="en-US" dirty="0"/>
+              <a:t> R package</a:t>
+            </a:r>
+          </a:p>
+          <a:p>
+            <a:r>
+              <a:rPr lang="en-US" dirty="0"/>
+              <a:t>Apr-Jun means of body condition and environment</a:t>
+            </a:r>
+          </a:p>
+          <a:p>
+            <a:pPr marL="0" indent="0">
+              <a:buNone/>
+            </a:pPr>
+            <a:endParaRPr lang="en-US" dirty="0"/>
+          </a:p>
+          <a:p>
+            <a:r>
+              <a:rPr lang="en-US" dirty="0"/>
+              <a:t>Hake body condition is sensitive to changes in environmental during the early spring when body condition is already low coming out of winter</a:t>
+            </a:r>
+          </a:p>
+        </p:txBody>
+      </p:sp>
+      <p:pic>
+        <p:nvPicPr>
+          <p:cNvPr id="9" name="Picture 8">
+            <a:extLst>
+              <a:ext uri="{FF2B5EF4-FFF2-40B4-BE49-F238E27FC236}">
+                <a16:creationId xmlns:a16="http://schemas.microsoft.com/office/drawing/2014/main" id="{B17759A0-05AD-1455-58DD-A8FAA388D662}"/>
+              </a:ext>
+            </a:extLst>
+          </p:cNvPr>
+          <p:cNvPicPr>
+            <a:picLocks noChangeAspect="1"/>
+          </p:cNvPicPr>
+          <p:nvPr/>
+        </p:nvPicPr>
+        <p:blipFill>
+          <a:blip r:embed="rId3"/>
+          <a:stretch>
+            <a:fillRect/>
+          </a:stretch>
+        </p:blipFill>
+        <p:spPr>
+          <a:xfrm>
+            <a:off x="6444784" y="846433"/>
+            <a:ext cx="5477531" cy="2976563"/>
+          </a:xfrm>
+          <a:prstGeom prst="rect">
+            <a:avLst/>
+          </a:prstGeom>
+        </p:spPr>
+      </p:pic>
+      <p:pic>
+        <p:nvPicPr>
+          <p:cNvPr id="13" name="Picture 12">
+            <a:extLst>
+              <a:ext uri="{FF2B5EF4-FFF2-40B4-BE49-F238E27FC236}">
+                <a16:creationId xmlns:a16="http://schemas.microsoft.com/office/drawing/2014/main" id="{4C6EE695-AB33-7585-8295-9F62121A7532}"/>
+              </a:ext>
+            </a:extLst>
+          </p:cNvPr>
+          <p:cNvPicPr>
+            <a:picLocks noChangeAspect="1"/>
+          </p:cNvPicPr>
+          <p:nvPr/>
+        </p:nvPicPr>
+        <p:blipFill>
+          <a:blip r:embed="rId4"/>
+          <a:stretch>
+            <a:fillRect/>
+          </a:stretch>
+        </p:blipFill>
+        <p:spPr>
+          <a:xfrm>
+            <a:off x="6360160" y="4124031"/>
+            <a:ext cx="3702495" cy="2445044"/>
+          </a:xfrm>
+          <a:prstGeom prst="rect">
+            <a:avLst/>
+          </a:prstGeom>
+        </p:spPr>
+      </p:pic>
+    </p:spTree>
+    <p:extLst>
+      <p:ext uri="{BB962C8B-B14F-4D97-AF65-F5344CB8AC3E}">
+        <p14:creationId xmlns:p14="http://schemas.microsoft.com/office/powerpoint/2010/main" val="606901517"/>
+      </p:ext>
+    </p:extLst>
+  </p:cSld>
+  <p:clrMapOvr>
+    <a:masterClrMapping/>
+  </p:clrMapOvr>
+</p:sld>
+</file>
+
+<file path=ppt/slides/slide56.xml><?xml version="1.0" encoding="utf-8"?>
+<p:sld xmlns:a="http://schemas.openxmlformats.org/drawingml/2006/main" xmlns:r="http://schemas.openxmlformats.org/officeDocument/2006/relationships" xmlns:p="http://schemas.openxmlformats.org/presentationml/2006/main">
+  <p:cSld>
+    <p:spTree>
+      <p:nvGrpSpPr>
+        <p:cNvPr id="1" name=""/>
+        <p:cNvGrpSpPr/>
+        <p:nvPr/>
+      </p:nvGrpSpPr>
+      <p:grpSpPr>
+        <a:xfrm>
+          <a:off x="0" y="0"/>
+          <a:ext cx="0" cy="0"/>
+          <a:chOff x="0" y="0"/>
+          <a:chExt cx="0" cy="0"/>
+        </a:xfrm>
+      </p:grpSpPr>
+      <p:sp>
+        <p:nvSpPr>
+          <p:cNvPr id="2" name="Title 1">
+            <a:extLst>
+              <a:ext uri="{FF2B5EF4-FFF2-40B4-BE49-F238E27FC236}">
+                <a16:creationId xmlns:a16="http://schemas.microsoft.com/office/drawing/2014/main" id="{173CD597-A9D5-497F-CCD1-DBCFA2205361}"/>
+              </a:ext>
+            </a:extLst>
+          </p:cNvPr>
+          <p:cNvSpPr>
+            <a:spLocks noGrp="1"/>
+          </p:cNvSpPr>
+          <p:nvPr>
+            <p:ph type="title"/>
+          </p:nvPr>
+        </p:nvSpPr>
+        <p:spPr/>
+        <p:txBody>
+          <a:bodyPr/>
+          <a:lstStyle/>
+          <a:p>
+            <a:r>
+              <a:rPr lang="en-US" dirty="0"/>
+              <a:t>Late summer body </a:t>
+            </a:r>
+            <a:br>
+              <a:rPr lang="en-US" dirty="0"/>
+            </a:br>
+            <a:r>
+              <a:rPr lang="en-US" dirty="0"/>
+              <a:t>condition</a:t>
+            </a:r>
+          </a:p>
+        </p:txBody>
+      </p:sp>
+      <p:sp>
+        <p:nvSpPr>
+          <p:cNvPr id="3" name="Content Placeholder 2">
+            <a:extLst>
+              <a:ext uri="{FF2B5EF4-FFF2-40B4-BE49-F238E27FC236}">
+                <a16:creationId xmlns:a16="http://schemas.microsoft.com/office/drawing/2014/main" id="{6D603B2E-39B5-A9D3-FA09-4C4F138DE2B0}"/>
+              </a:ext>
+            </a:extLst>
+          </p:cNvPr>
+          <p:cNvSpPr>
+            <a:spLocks noGrp="1"/>
+          </p:cNvSpPr>
+          <p:nvPr>
+            <p:ph idx="1"/>
+          </p:nvPr>
+        </p:nvSpPr>
+        <p:spPr>
+          <a:xfrm>
+            <a:off x="838200" y="1825625"/>
+            <a:ext cx="5046996" cy="4351338"/>
+          </a:xfrm>
+        </p:spPr>
+        <p:txBody>
+          <a:bodyPr/>
+          <a:lstStyle/>
+          <a:p>
+            <a:r>
+              <a:rPr lang="en-US" dirty="0"/>
+              <a:t>Aug-Oct means of body condition and environment</a:t>
+            </a:r>
+          </a:p>
+          <a:p>
+            <a:endParaRPr lang="en-US" dirty="0"/>
+          </a:p>
+          <a:p>
+            <a:r>
+              <a:rPr lang="en-US" dirty="0"/>
+              <a:t>Patterns are less clear during the high feeding periods of the summer when body condition is generally higher</a:t>
+            </a:r>
+          </a:p>
+        </p:txBody>
+      </p:sp>
+      <p:pic>
+        <p:nvPicPr>
+          <p:cNvPr id="9" name="Picture 8">
+            <a:extLst>
+              <a:ext uri="{FF2B5EF4-FFF2-40B4-BE49-F238E27FC236}">
+                <a16:creationId xmlns:a16="http://schemas.microsoft.com/office/drawing/2014/main" id="{857503F4-B846-6BDA-4DF8-5526B81E600C}"/>
+              </a:ext>
+            </a:extLst>
+          </p:cNvPr>
+          <p:cNvPicPr>
+            <a:picLocks noChangeAspect="1"/>
+          </p:cNvPicPr>
+          <p:nvPr/>
+        </p:nvPicPr>
+        <p:blipFill>
+          <a:blip r:embed="rId3"/>
+          <a:stretch>
+            <a:fillRect/>
+          </a:stretch>
+        </p:blipFill>
+        <p:spPr>
+          <a:xfrm>
+            <a:off x="6010275" y="3980974"/>
+            <a:ext cx="4322445" cy="2854445"/>
+          </a:xfrm>
+          <a:prstGeom prst="rect">
+            <a:avLst/>
+          </a:prstGeom>
+        </p:spPr>
+      </p:pic>
+      <p:pic>
+        <p:nvPicPr>
+          <p:cNvPr id="11" name="Picture 10">
+            <a:extLst>
+              <a:ext uri="{FF2B5EF4-FFF2-40B4-BE49-F238E27FC236}">
+                <a16:creationId xmlns:a16="http://schemas.microsoft.com/office/drawing/2014/main" id="{4AFB5751-2397-E479-600B-22B869F51CF1}"/>
+              </a:ext>
+            </a:extLst>
+          </p:cNvPr>
+          <p:cNvPicPr>
+            <a:picLocks noChangeAspect="1"/>
+          </p:cNvPicPr>
+          <p:nvPr/>
+        </p:nvPicPr>
+        <p:blipFill>
+          <a:blip r:embed="rId4"/>
+          <a:stretch>
+            <a:fillRect/>
+          </a:stretch>
+        </p:blipFill>
+        <p:spPr>
+          <a:xfrm>
+            <a:off x="6010275" y="498465"/>
+            <a:ext cx="5209009" cy="3289469"/>
+          </a:xfrm>
+          <a:prstGeom prst="rect">
+            <a:avLst/>
+          </a:prstGeom>
+        </p:spPr>
+      </p:pic>
+    </p:spTree>
+    <p:extLst>
+      <p:ext uri="{BB962C8B-B14F-4D97-AF65-F5344CB8AC3E}">
+        <p14:creationId xmlns:p14="http://schemas.microsoft.com/office/powerpoint/2010/main" val="600607100"/>
+      </p:ext>
+    </p:extLst>
+  </p:cSld>
+  <p:clrMapOvr>
+    <a:masterClrMapping/>
+  </p:clrMapOvr>
+</p:sld>
+</file>
+
+<file path=ppt/slides/slide57.xml><?xml version="1.0" encoding="utf-8"?>
+<p:sld xmlns:a="http://schemas.openxmlformats.org/drawingml/2006/main" xmlns:r="http://schemas.openxmlformats.org/officeDocument/2006/relationships" xmlns:p="http://schemas.openxmlformats.org/presentationml/2006/main">
+  <p:cSld>
+    <p:spTree>
+      <p:nvGrpSpPr>
+        <p:cNvPr id="1" name=""/>
+        <p:cNvGrpSpPr/>
+        <p:nvPr/>
+      </p:nvGrpSpPr>
+      <p:grpSpPr>
+        <a:xfrm>
+          <a:off x="0" y="0"/>
+          <a:ext cx="0" cy="0"/>
+          <a:chOff x="0" y="0"/>
+          <a:chExt cx="0" cy="0"/>
+        </a:xfrm>
+      </p:grpSpPr>
+      <p:sp>
+        <p:nvSpPr>
+          <p:cNvPr id="2" name="Title 1">
+            <a:extLst>
+              <a:ext uri="{FF2B5EF4-FFF2-40B4-BE49-F238E27FC236}">
+                <a16:creationId xmlns:a16="http://schemas.microsoft.com/office/drawing/2014/main" id="{184D7E90-0197-40D2-283C-9BA1E843C090}"/>
+              </a:ext>
+            </a:extLst>
+          </p:cNvPr>
+          <p:cNvSpPr>
+            <a:spLocks noGrp="1"/>
+          </p:cNvSpPr>
+          <p:nvPr>
+            <p:ph type="title"/>
+          </p:nvPr>
+        </p:nvSpPr>
+        <p:spPr/>
+        <p:txBody>
+          <a:bodyPr/>
+          <a:lstStyle/>
+          <a:p>
+            <a:endParaRPr lang="en-US"/>
+          </a:p>
+        </p:txBody>
+      </p:sp>
+      <p:sp>
+        <p:nvSpPr>
+          <p:cNvPr id="3" name="Content Placeholder 2">
+            <a:extLst>
+              <a:ext uri="{FF2B5EF4-FFF2-40B4-BE49-F238E27FC236}">
+                <a16:creationId xmlns:a16="http://schemas.microsoft.com/office/drawing/2014/main" id="{E5DD603D-CF43-EFE7-351F-742623507E92}"/>
+              </a:ext>
+            </a:extLst>
+          </p:cNvPr>
+          <p:cNvSpPr>
+            <a:spLocks noGrp="1"/>
+          </p:cNvSpPr>
+          <p:nvPr>
+            <p:ph idx="1"/>
+          </p:nvPr>
+        </p:nvSpPr>
+        <p:spPr/>
+        <p:txBody>
+          <a:bodyPr/>
+          <a:lstStyle/>
+          <a:p>
+            <a:endParaRPr lang="en-US"/>
+          </a:p>
+        </p:txBody>
+      </p:sp>
+    </p:spTree>
+    <p:extLst>
+      <p:ext uri="{BB962C8B-B14F-4D97-AF65-F5344CB8AC3E}">
+        <p14:creationId xmlns:p14="http://schemas.microsoft.com/office/powerpoint/2010/main" val="1339027459"/>
       </p:ext>
     </p:extLst>
   </p:cSld>

</xml_diff>